<commit_message>
Render markdown **bold** in PPTX instead of literal asterisks.
Parse **...** in rich_text.py and apply b=1 to runs. Document syntax in formulas.md and slide_generator prompt. Rebuild presentations for derevo_resheniy and lineynaya_regressiya.

Co-authored-by: Cursor <cursoragent@cursor.com>
</commit_message>
<xml_diff>
--- a/lessons/lineynaya_regressiya/presentation.pptx
+++ b/lessons/lineynaya_regressiya/presentation.pptx
@@ -5866,7 +5866,23 @@
                   <a:srgbClr val="000000"/>
                 </a:solidFill>
               </a:rPr>
-              <a:t>Data leakage: impute/scale **до** split — статистики теста попадают в train</a:t>
+              <a:t xml:space="preserve">Data leakage: impute/scale </a:t>
+            </a:r>
+            <a:r>
+              <a:rPr lang="ru-RU" dirty="0" sz="2000" b="1">
+                <a:solidFill>
+                  <a:srgbClr val="000000"/>
+                </a:solidFill>
+              </a:rPr>
+              <a:t>до</a:t>
+            </a:r>
+            <a:r>
+              <a:rPr lang="ru-RU" dirty="0" sz="2000">
+                <a:solidFill>
+                  <a:srgbClr val="000000"/>
+                </a:solidFill>
+              </a:rPr>
+              <a:t xml:space="preserve"> split — статистики теста попадают в train</a:t>
             </a:r>
           </a:p>
           <a:p>
@@ -6565,7 +6581,23 @@
                   <a:srgbClr val="000000"/>
                 </a:solidFill>
               </a:rPr>
-              <a:t>Минимизируем **вертикальные** расстояния от точек до линии (не перпендикуляры к прямой)</a:t>
+              <a:t xml:space="preserve">Минимизируем </a:t>
+            </a:r>
+            <a:r>
+              <a:rPr lang="ru-RU" dirty="0" sz="2000" b="1">
+                <a:solidFill>
+                  <a:srgbClr val="000000"/>
+                </a:solidFill>
+              </a:rPr>
+              <a:t>вертикальные</a:t>
+            </a:r>
+            <a:r>
+              <a:rPr lang="ru-RU" dirty="0" sz="2000">
+                <a:solidFill>
+                  <a:srgbClr val="000000"/>
+                </a:solidFill>
+              </a:rPr>
+              <a:t xml:space="preserve"> расстояния от точек до линии (не перпендикуляры к прямой)</a:t>
             </a:r>
           </a:p>
           <a:p>
@@ -7649,7 +7681,23 @@
                   <a:srgbClr val="000000"/>
                 </a:solidFill>
               </a:rPr>
-              <a:t>Масштабирование нужно для **интерпретации весов** (сравнивать влияние признаков)</a:t>
+              <a:t xml:space="preserve">Масштабирование нужно для </a:t>
+            </a:r>
+            <a:r>
+              <a:rPr lang="ru-RU" dirty="0" sz="2000" b="1">
+                <a:solidFill>
+                  <a:srgbClr val="000000"/>
+                </a:solidFill>
+              </a:rPr>
+              <a:t>интерпретации весов</a:t>
+            </a:r>
+            <a:r>
+              <a:rPr lang="ru-RU" dirty="0" sz="2000">
+                <a:solidFill>
+                  <a:srgbClr val="000000"/>
+                </a:solidFill>
+              </a:rPr>
+              <a:t xml:space="preserve"> (сравнивать влияние признаков)</a:t>
             </a:r>
           </a:p>
           <a:p>
@@ -7664,7 +7712,23 @@
                   <a:srgbClr val="000000"/>
                 </a:solidFill>
               </a:rPr>
-              <a:t>Для градиентного спуска и регуляризации масштабирование **обязательно** — иначе медленная или неверная сходимость</a:t>
+              <a:t xml:space="preserve">Для градиентного спуска и регуляризации масштабирование </a:t>
+            </a:r>
+            <a:r>
+              <a:rPr lang="ru-RU" dirty="0" sz="2000" b="1">
+                <a:solidFill>
+                  <a:srgbClr val="000000"/>
+                </a:solidFill>
+              </a:rPr>
+              <a:t>обязательно</a:t>
+            </a:r>
+            <a:r>
+              <a:rPr lang="ru-RU" dirty="0" sz="2000">
+                <a:solidFill>
+                  <a:srgbClr val="000000"/>
+                </a:solidFill>
+              </a:rPr>
+              <a:t xml:space="preserve"> — иначе медленная или неверная сходимость</a:t>
             </a:r>
           </a:p>
         </p:txBody>

</xml_diff>

<commit_message>
Add illustrations to linear regression lesson (15 slides, multi-image layout).
Add 11 new PNG assets and visuals metadata for slides 02-14; up to 2 images per slide via grid layout in pptx_builder. Include generate_visuals.py for reproducibility and docs/visuals.md policy. Slide 16 (checklist) intentionally without visuals.

Co-authored-by: Cursor <cursoragent@cursor.com>
</commit_message>
<xml_diff>
--- a/lessons/lineynaya_regressiya/presentation.pptx
+++ b/lessons/lineynaya_regressiya/presentation.pptx
@@ -4774,7 +4774,7 @@
         <p:spPr>
           <a:xfrm>
             <a:off x="640080" y="1371600"/>
-            <a:ext cx="11247120" cy="5029200"/>
+            <a:ext cx="6858000" cy="5029200"/>
           </a:xfrm>
           <a:prstGeom prst="rect">
             <a:avLst/>
@@ -4848,6 +4848,30 @@
           </a:p>
         </p:txBody>
       </p:sp>
+      <p:pic>
+        <p:nvPicPr>
+          <p:cNvPr id="4" name="Picture 3" descr="train_test_split.png"/>
+          <p:cNvPicPr>
+            <a:picLocks noChangeAspect="1"/>
+          </p:cNvPicPr>
+          <p:nvPr/>
+        </p:nvPicPr>
+        <p:blipFill>
+          <a:blip r:embed="rId2"/>
+          <a:stretch>
+            <a:fillRect/>
+          </a:stretch>
+        </p:blipFill>
+        <p:spPr>
+          <a:xfrm>
+            <a:off x="7635240" y="2728376"/>
+            <a:ext cx="4343400" cy="1675566"/>
+          </a:xfrm>
+          <a:prstGeom prst="rect">
+            <a:avLst/>
+          </a:prstGeom>
+        </p:spPr>
+      </p:pic>
     </p:spTree>
   </p:cSld>
   <p:clrMapOvr>
@@ -5112,8 +5136,8 @@
         </p:blipFill>
         <p:spPr>
           <a:xfrm>
-            <a:off x="7772400" y="1371600"/>
-            <a:ext cx="4114800" cy="2057400"/>
+            <a:off x="7635240" y="2569642"/>
+            <a:ext cx="4343400" cy="1993035"/>
           </a:xfrm>
           <a:prstGeom prst="rect">
             <a:avLst/>
@@ -5180,7 +5204,7 @@
         <p:spPr>
           <a:xfrm>
             <a:off x="640080" y="1371600"/>
-            <a:ext cx="11247120" cy="5029200"/>
+            <a:ext cx="6858000" cy="5029200"/>
           </a:xfrm>
           <a:prstGeom prst="rect">
             <a:avLst/>
@@ -5357,6 +5381,30 @@
           </a:p>
         </p:txBody>
       </p:sp>
+      <p:pic>
+        <p:nvPicPr>
+          <p:cNvPr id="4" name="Picture 3" descr="regression_metrics_bar.png"/>
+          <p:cNvPicPr>
+            <a:picLocks noChangeAspect="1"/>
+          </p:cNvPicPr>
+          <p:nvPr/>
+        </p:nvPicPr>
+        <p:blipFill>
+          <a:blip r:embed="rId2"/>
+          <a:stretch>
+            <a:fillRect/>
+          </a:stretch>
+        </p:blipFill>
+        <p:spPr>
+          <a:xfrm>
+            <a:off x="7635240" y="2069048"/>
+            <a:ext cx="4343400" cy="2994224"/>
+          </a:xfrm>
+          <a:prstGeom prst="rect">
+            <a:avLst/>
+          </a:prstGeom>
+        </p:spPr>
+      </p:pic>
     </p:spTree>
   </p:cSld>
   <p:clrMapOvr>
@@ -5561,8 +5609,8 @@
         </p:blipFill>
         <p:spPr>
           <a:xfrm>
-            <a:off x="7772400" y="1371600"/>
-            <a:ext cx="4114800" cy="1645920"/>
+            <a:off x="7635240" y="2697479"/>
+            <a:ext cx="4343400" cy="1737360"/>
           </a:xfrm>
           <a:prstGeom prst="rect">
             <a:avLst/>
@@ -5629,7 +5677,7 @@
         <p:spPr>
           <a:xfrm>
             <a:off x="640080" y="1371600"/>
-            <a:ext cx="11247120" cy="5029200"/>
+            <a:ext cx="6858000" cy="5029200"/>
           </a:xfrm>
           <a:prstGeom prst="rect">
             <a:avLst/>
@@ -5767,6 +5815,30 @@
           </a:p>
         </p:txBody>
       </p:sp>
+      <p:pic>
+        <p:nvPicPr>
+          <p:cNvPr id="4" name="Picture 3" descr="standardized_weights.png"/>
+          <p:cNvPicPr>
+            <a:picLocks noChangeAspect="1"/>
+          </p:cNvPicPr>
+          <p:nvPr/>
+        </p:nvPicPr>
+        <p:blipFill>
+          <a:blip r:embed="rId2"/>
+          <a:stretch>
+            <a:fillRect/>
+          </a:stretch>
+        </p:blipFill>
+        <p:spPr>
+          <a:xfrm>
+            <a:off x="7635240" y="2069048"/>
+            <a:ext cx="4343400" cy="2994224"/>
+          </a:xfrm>
+          <a:prstGeom prst="rect">
+            <a:avLst/>
+          </a:prstGeom>
+        </p:spPr>
+      </p:pic>
     </p:spTree>
   </p:cSld>
   <p:clrMapOvr>
@@ -5827,7 +5899,7 @@
         <p:spPr>
           <a:xfrm>
             <a:off x="640080" y="1371600"/>
-            <a:ext cx="11247120" cy="5029200"/>
+            <a:ext cx="6858000" cy="5029200"/>
           </a:xfrm>
           <a:prstGeom prst="rect">
             <a:avLst/>
@@ -5917,6 +5989,30 @@
           </a:p>
         </p:txBody>
       </p:sp>
+      <p:pic>
+        <p:nvPicPr>
+          <p:cNvPr id="4" name="Picture 3" descr="pipeline_leakage.png"/>
+          <p:cNvPicPr>
+            <a:picLocks noChangeAspect="1"/>
+          </p:cNvPicPr>
+          <p:nvPr/>
+        </p:nvPicPr>
+        <p:blipFill>
+          <a:blip r:embed="rId2"/>
+          <a:stretch>
+            <a:fillRect/>
+          </a:stretch>
+        </p:blipFill>
+        <p:spPr>
+          <a:xfrm>
+            <a:off x="7635240" y="2868583"/>
+            <a:ext cx="4343400" cy="1395153"/>
+          </a:xfrm>
+          <a:prstGeom prst="rect">
+            <a:avLst/>
+          </a:prstGeom>
+        </p:spPr>
+      </p:pic>
     </p:spTree>
   </p:cSld>
   <p:clrMapOvr>
@@ -6121,8 +6217,8 @@
         </p:blipFill>
         <p:spPr>
           <a:xfrm>
-            <a:off x="7772400" y="1371600"/>
-            <a:ext cx="4114800" cy="2571750"/>
+            <a:off x="7635240" y="2208847"/>
+            <a:ext cx="4343400" cy="2714625"/>
           </a:xfrm>
           <a:prstGeom prst="rect">
             <a:avLst/>
@@ -6489,8 +6585,8 @@
         </p:blipFill>
         <p:spPr>
           <a:xfrm>
-            <a:off x="7772400" y="1371600"/>
-            <a:ext cx="4114800" cy="2571750"/>
+            <a:off x="7635240" y="2208847"/>
+            <a:ext cx="4343400" cy="2714625"/>
           </a:xfrm>
           <a:prstGeom prst="rect">
             <a:avLst/>
@@ -6724,8 +6820,32 @@
         </p:blipFill>
         <p:spPr>
           <a:xfrm>
-            <a:off x="7772400" y="1371600"/>
-            <a:ext cx="4114800" cy="2571750"/>
+            <a:off x="8043976" y="1325880"/>
+            <a:ext cx="3525926" cy="2203704"/>
+          </a:xfrm>
+          <a:prstGeom prst="rect">
+            <a:avLst/>
+          </a:prstGeom>
+        </p:spPr>
+      </p:pic>
+      <p:pic>
+        <p:nvPicPr>
+          <p:cNvPr id="5" name="Picture 4" descr="residuals_histogram.png"/>
+          <p:cNvPicPr>
+            <a:picLocks noChangeAspect="1"/>
+          </p:cNvPicPr>
+          <p:nvPr/>
+        </p:nvPicPr>
+        <p:blipFill>
+          <a:blip r:embed="rId3"/>
+          <a:stretch>
+            <a:fillRect/>
+          </a:stretch>
+        </p:blipFill>
+        <p:spPr>
+          <a:xfrm>
+            <a:off x="8208601" y="3602735"/>
+            <a:ext cx="3196677" cy="2203704"/>
           </a:xfrm>
           <a:prstGeom prst="rect">
             <a:avLst/>
@@ -6792,7 +6912,7 @@
         <p:spPr>
           <a:xfrm>
             <a:off x="640080" y="1371600"/>
-            <a:ext cx="11247120" cy="5029200"/>
+            <a:ext cx="6858000" cy="5029200"/>
           </a:xfrm>
           <a:prstGeom prst="rect">
             <a:avLst/>
@@ -7056,6 +7176,30 @@
           </a:p>
         </p:txBody>
       </p:sp>
+      <p:pic>
+        <p:nvPicPr>
+          <p:cNvPr id="4" name="Picture 3" descr="mse_vs_mae_loss.png"/>
+          <p:cNvPicPr>
+            <a:picLocks noChangeAspect="1"/>
+          </p:cNvPicPr>
+          <p:nvPr/>
+        </p:nvPicPr>
+        <p:blipFill>
+          <a:blip r:embed="rId2"/>
+          <a:stretch>
+            <a:fillRect/>
+          </a:stretch>
+        </p:blipFill>
+        <p:spPr>
+          <a:xfrm>
+            <a:off x="7635240" y="2074965"/>
+            <a:ext cx="4343400" cy="2982389"/>
+          </a:xfrm>
+          <a:prstGeom prst="rect">
+            <a:avLst/>
+          </a:prstGeom>
+        </p:spPr>
+      </p:pic>
     </p:spTree>
   </p:cSld>
   <p:clrMapOvr>
@@ -7116,7 +7260,7 @@
         <p:spPr>
           <a:xfrm>
             <a:off x="640080" y="1371600"/>
-            <a:ext cx="11247120" cy="5029200"/>
+            <a:ext cx="6858000" cy="5029200"/>
           </a:xfrm>
           <a:prstGeom prst="rect">
             <a:avLst/>
@@ -7279,6 +7423,30 @@
           </a:p>
         </p:txBody>
       </p:sp>
+      <p:pic>
+        <p:nvPicPr>
+          <p:cNvPr id="4" name="Picture 3" descr="gradient_descent_contour.png"/>
+          <p:cNvPicPr>
+            <a:picLocks noChangeAspect="1"/>
+          </p:cNvPicPr>
+          <p:nvPr/>
+        </p:nvPicPr>
+        <p:blipFill>
+          <a:blip r:embed="rId2"/>
+          <a:stretch>
+            <a:fillRect/>
+          </a:stretch>
+        </p:blipFill>
+        <p:spPr>
+          <a:xfrm>
+            <a:off x="7635240" y="2069968"/>
+            <a:ext cx="4343400" cy="2992383"/>
+          </a:xfrm>
+          <a:prstGeom prst="rect">
+            <a:avLst/>
+          </a:prstGeom>
+        </p:spPr>
+      </p:pic>
     </p:spTree>
   </p:cSld>
   <p:clrMapOvr>
@@ -7339,7 +7507,7 @@
         <p:spPr>
           <a:xfrm>
             <a:off x="640080" y="1371600"/>
-            <a:ext cx="11247120" cy="5029200"/>
+            <a:ext cx="6858000" cy="5029200"/>
           </a:xfrm>
           <a:prstGeom prst="rect">
             <a:avLst/>
@@ -7552,6 +7720,30 @@
           </a:p>
         </p:txBody>
       </p:sp>
+      <p:pic>
+        <p:nvPicPr>
+          <p:cNvPr id="4" name="Picture 3" descr="hyperplane_3d.png"/>
+          <p:cNvPicPr>
+            <a:picLocks noChangeAspect="1"/>
+          </p:cNvPicPr>
+          <p:nvPr/>
+        </p:nvPicPr>
+        <p:blipFill>
+          <a:blip r:embed="rId2"/>
+          <a:stretch>
+            <a:fillRect/>
+          </a:stretch>
+        </p:blipFill>
+        <p:spPr>
+          <a:xfrm>
+            <a:off x="7661153" y="1325880"/>
+            <a:ext cx="4291573" cy="4480560"/>
+          </a:xfrm>
+          <a:prstGeom prst="rect">
+            <a:avLst/>
+          </a:prstGeom>
+        </p:spPr>
+      </p:pic>
     </p:spTree>
   </p:cSld>
   <p:clrMapOvr>
@@ -7612,7 +7804,7 @@
         <p:spPr>
           <a:xfrm>
             <a:off x="640080" y="1371600"/>
-            <a:ext cx="11247120" cy="5029200"/>
+            <a:ext cx="6858000" cy="5029200"/>
           </a:xfrm>
           <a:prstGeom prst="rect">
             <a:avLst/>
@@ -7733,6 +7925,30 @@
           </a:p>
         </p:txBody>
       </p:sp>
+      <p:pic>
+        <p:nvPicPr>
+          <p:cNvPr id="4" name="Picture 3" descr="scaling_weights_compare.png"/>
+          <p:cNvPicPr>
+            <a:picLocks noChangeAspect="1"/>
+          </p:cNvPicPr>
+          <p:nvPr/>
+        </p:nvPicPr>
+        <p:blipFill>
+          <a:blip r:embed="rId2"/>
+          <a:stretch>
+            <a:fillRect/>
+          </a:stretch>
+        </p:blipFill>
+        <p:spPr>
+          <a:xfrm>
+            <a:off x="7635240" y="2739333"/>
+            <a:ext cx="4343400" cy="1653653"/>
+          </a:xfrm>
+          <a:prstGeom prst="rect">
+            <a:avLst/>
+          </a:prstGeom>
+        </p:spPr>
+      </p:pic>
     </p:spTree>
   </p:cSld>
   <p:clrMapOvr>
@@ -7935,8 +8151,32 @@
         </p:blipFill>
         <p:spPr>
           <a:xfrm>
-            <a:off x="7772400" y="1371600"/>
-            <a:ext cx="4114800" cy="1645920"/>
+            <a:off x="7635240" y="1559051"/>
+            <a:ext cx="4343400" cy="1737360"/>
+          </a:xfrm>
+          <a:prstGeom prst="rect">
+            <a:avLst/>
+          </a:prstGeom>
+        </p:spPr>
+      </p:pic>
+      <p:pic>
+        <p:nvPicPr>
+          <p:cNvPr id="5" name="Picture 4" descr="outlier_leverage_x.png"/>
+          <p:cNvPicPr>
+            <a:picLocks noChangeAspect="1"/>
+          </p:cNvPicPr>
+          <p:nvPr/>
+        </p:nvPicPr>
+        <p:blipFill>
+          <a:blip r:embed="rId3"/>
+          <a:stretch>
+            <a:fillRect/>
+          </a:stretch>
+        </p:blipFill>
+        <p:spPr>
+          <a:xfrm>
+            <a:off x="7635240" y="3878111"/>
+            <a:ext cx="4343400" cy="1652954"/>
           </a:xfrm>
           <a:prstGeom prst="rect">
             <a:avLst/>
@@ -8003,7 +8243,7 @@
         <p:spPr>
           <a:xfrm>
             <a:off x="640080" y="1371600"/>
-            <a:ext cx="11247120" cy="5029200"/>
+            <a:ext cx="6858000" cy="5029200"/>
           </a:xfrm>
           <a:prstGeom prst="rect">
             <a:avLst/>
@@ -8101,6 +8341,30 @@
           </a:p>
         </p:txBody>
       </p:sp>
+      <p:pic>
+        <p:nvPicPr>
+          <p:cNvPr id="4" name="Picture 3" descr="multicollinearity.png"/>
+          <p:cNvPicPr>
+            <a:picLocks noChangeAspect="1"/>
+          </p:cNvPicPr>
+          <p:nvPr/>
+        </p:nvPicPr>
+        <p:blipFill>
+          <a:blip r:embed="rId2"/>
+          <a:stretch>
+            <a:fillRect/>
+          </a:stretch>
+        </p:blipFill>
+        <p:spPr>
+          <a:xfrm>
+            <a:off x="7635240" y="2652101"/>
+            <a:ext cx="4343400" cy="1828118"/>
+          </a:xfrm>
+          <a:prstGeom prst="rect">
+            <a:avLst/>
+          </a:prstGeom>
+        </p:spPr>
+      </p:pic>
     </p:spTree>
   </p:cSld>
   <p:clrMapOvr>

</xml_diff>

<commit_message>
Add references agent with Colab links and QR on literature slide.
Introduces references_agent, GitHub-to-Colab URL builder, references slide type in pptx_builder, and docs. Bootstraps lineynaya_regressiya slide 17 as example.

Co-authored-by: Cursor <cursoragent@cursor.com>
</commit_message>
<xml_diff>
--- a/lessons/lineynaya_regressiya/presentation.pptx
+++ b/lessons/lineynaya_regressiya/presentation.pptx
@@ -22,6 +22,7 @@
     <p:sldId id="270" r:id="rId22"/>
     <p:sldId id="271" r:id="rId23"/>
     <p:sldId id="272" r:id="rId24"/>
+    <p:sldId id="273" r:id="rId25"/>
   </p:sldIdLst>
   <p:sldSz cx="12191695" cy="6858000" type="screen4x3"/>
   <p:notesSz cx="6858000" cy="9144000"/>
@@ -1009,6 +1010,76 @@
           <a:p>
             <a:r>
               <a:t>Можно раздать чек-лист одним слайдом в конце.</a:t>
+            </a:r>
+          </a:p>
+        </p:txBody>
+      </p:sp>
+      <p:sp>
+        <p:nvSpPr>
+          <p:cNvPr id="4" name="Slide Number Placeholder 3"/>
+          <p:cNvSpPr>
+            <a:spLocks noGrp="1"/>
+          </p:cNvSpPr>
+          <p:nvPr>
+            <p:ph type="sldNum" idx="5" sz="quarter"/>
+          </p:nvPr>
+        </p:nvSpPr>
+        <p:spPr/>
+      </p:sp>
+    </p:spTree>
+  </p:cSld>
+  <p:clrMapOvr>
+    <a:masterClrMapping/>
+  </p:clrMapOvr>
+</p:notes>
+</file>
+
+<file path=ppt/notesSlides/notesSlide17.xml><?xml version="1.0" encoding="utf-8"?>
+<p:notes xmlns:a="http://schemas.openxmlformats.org/drawingml/2006/main" xmlns:p="http://schemas.openxmlformats.org/presentationml/2006/main" xmlns:r="http://schemas.openxmlformats.org/officeDocument/2006/relationships">
+  <p:cSld>
+    <p:spTree>
+      <p:nvGrpSpPr>
+        <p:cNvPr id="1" name=""/>
+        <p:cNvGrpSpPr/>
+        <p:nvPr/>
+      </p:nvGrpSpPr>
+      <p:grpSpPr>
+        <a:xfrm>
+          <a:off x="0" y="0"/>
+          <a:ext cx="0" cy="0"/>
+          <a:chOff x="0" y="0"/>
+          <a:chExt cx="0" cy="0"/>
+        </a:xfrm>
+      </p:grpSpPr>
+      <p:sp>
+        <p:nvSpPr>
+          <p:cNvPr id="2" name="Slide Image Placeholder 1"/>
+          <p:cNvSpPr>
+            <a:spLocks noGrp="1"/>
+          </p:cNvSpPr>
+          <p:nvPr>
+            <p:ph type="sldImg" idx="2"/>
+          </p:nvPr>
+        </p:nvSpPr>
+        <p:spPr/>
+      </p:sp>
+      <p:sp>
+        <p:nvSpPr>
+          <p:cNvPr id="3" name="Notes Placeholder 2"/>
+          <p:cNvSpPr>
+            <a:spLocks noGrp="1"/>
+          </p:cNvSpPr>
+          <p:nvPr>
+            <p:ph type="body" idx="3" sz="quarter"/>
+          </p:nvPr>
+        </p:nvSpPr>
+        <p:spPr/>
+        <p:txBody>
+          <a:bodyPr/>
+          <a:lstStyle/>
+          <a:p>
+            <a:r>
+              <a:t>Colab-ссылки обновляются агентом при --apply.</a:t>
             </a:r>
           </a:p>
         </p:txBody>
@@ -4864,8 +4935,8 @@
         </p:blipFill>
         <p:spPr>
           <a:xfrm>
-            <a:off x="7635240" y="2728376"/>
-            <a:ext cx="4343400" cy="1675566"/>
+            <a:off x="7635240" y="2743231"/>
+            <a:ext cx="4343400" cy="1645857"/>
           </a:xfrm>
           <a:prstGeom prst="rect">
             <a:avLst/>
@@ -5136,8 +5207,8 @@
         </p:blipFill>
         <p:spPr>
           <a:xfrm>
-            <a:off x="7635240" y="2569642"/>
-            <a:ext cx="4343400" cy="1993035"/>
+            <a:off x="7635240" y="2585197"/>
+            <a:ext cx="4343400" cy="1961925"/>
           </a:xfrm>
           <a:prstGeom prst="rect">
             <a:avLst/>
@@ -5397,8 +5468,8 @@
         </p:blipFill>
         <p:spPr>
           <a:xfrm>
-            <a:off x="7635240" y="2069048"/>
-            <a:ext cx="4343400" cy="2994224"/>
+            <a:off x="7635240" y="2073874"/>
+            <a:ext cx="4343400" cy="2984571"/>
           </a:xfrm>
           <a:prstGeom prst="rect">
             <a:avLst/>
@@ -5609,8 +5680,8 @@
         </p:blipFill>
         <p:spPr>
           <a:xfrm>
-            <a:off x="7635240" y="2697479"/>
-            <a:ext cx="4343400" cy="1737360"/>
+            <a:off x="7635240" y="2758695"/>
+            <a:ext cx="4343400" cy="1614929"/>
           </a:xfrm>
           <a:prstGeom prst="rect">
             <a:avLst/>
@@ -5831,8 +5902,8 @@
         </p:blipFill>
         <p:spPr>
           <a:xfrm>
-            <a:off x="7635240" y="2069048"/>
-            <a:ext cx="4343400" cy="2994224"/>
+            <a:off x="7635240" y="2073874"/>
+            <a:ext cx="4343400" cy="2984571"/>
           </a:xfrm>
           <a:prstGeom prst="rect">
             <a:avLst/>
@@ -6005,8 +6076,8 @@
         </p:blipFill>
         <p:spPr>
           <a:xfrm>
-            <a:off x="7635240" y="2868583"/>
-            <a:ext cx="4343400" cy="1395153"/>
+            <a:off x="7635240" y="2857963"/>
+            <a:ext cx="4343400" cy="1416392"/>
           </a:xfrm>
           <a:prstGeom prst="rect">
             <a:avLst/>
@@ -6217,8 +6288,8 @@
         </p:blipFill>
         <p:spPr>
           <a:xfrm>
-            <a:off x="7635240" y="2208847"/>
-            <a:ext cx="4343400" cy="2714625"/>
+            <a:off x="7635240" y="2739840"/>
+            <a:ext cx="4343400" cy="1652640"/>
           </a:xfrm>
           <a:prstGeom prst="rect">
             <a:avLst/>
@@ -6398,6 +6469,470 @@
 </p:sld>
 </file>
 
+<file path=ppt/slides/slide18.xml><?xml version="1.0" encoding="utf-8"?>
+<p:sld xmlns:a="http://schemas.openxmlformats.org/drawingml/2006/main" xmlns:p="http://schemas.openxmlformats.org/presentationml/2006/main" xmlns:r="http://schemas.openxmlformats.org/officeDocument/2006/relationships">
+  <p:cSld>
+    <p:spTree>
+      <p:nvGrpSpPr>
+        <p:cNvPr id="1" name=""/>
+        <p:cNvGrpSpPr/>
+        <p:nvPr/>
+      </p:nvGrpSpPr>
+      <p:grpSpPr/>
+      <p:sp>
+        <p:nvSpPr>
+          <p:cNvPr id="2" name="TextBox 1"/>
+          <p:cNvSpPr txBox="1"/>
+          <p:nvPr/>
+        </p:nvSpPr>
+        <p:spPr>
+          <a:xfrm>
+            <a:off x="457200" y="274320"/>
+            <a:ext cx="11247120" cy="914400"/>
+          </a:xfrm>
+          <a:prstGeom prst="rect">
+            <a:avLst/>
+          </a:prstGeom>
+          <a:noFill/>
+        </p:spPr>
+        <p:txBody>
+          <a:bodyPr wrap="square">
+            <a:spAutoFit/>
+          </a:bodyPr>
+          <a:lstStyle/>
+          <a:p>
+            <a:r>
+              <a:rPr lang="ru-RU" dirty="0" sz="3200" b="1">
+                <a:solidFill>
+                  <a:srgbClr val="1A1A2E"/>
+                </a:solidFill>
+              </a:rPr>
+              <a:t>Источники и практика</a:t>
+            </a:r>
+          </a:p>
+        </p:txBody>
+      </p:sp>
+      <p:sp>
+        <p:nvSpPr>
+          <p:cNvPr id="3" name="TextBox 2"/>
+          <p:cNvSpPr txBox="1"/>
+          <p:nvPr/>
+        </p:nvSpPr>
+        <p:spPr>
+          <a:xfrm>
+            <a:off x="640080" y="1325880"/>
+            <a:ext cx="6583680" cy="320040"/>
+          </a:xfrm>
+          <a:prstGeom prst="rect">
+            <a:avLst/>
+          </a:prstGeom>
+          <a:noFill/>
+        </p:spPr>
+        <p:txBody>
+          <a:bodyPr wrap="none">
+            <a:spAutoFit/>
+          </a:bodyPr>
+          <a:lstStyle/>
+          <a:p>
+            <a:pPr>
+              <a:defRPr sz="1800" b="1">
+                <a:solidFill>
+                  <a:srgbClr val="000000"/>
+                </a:solidFill>
+              </a:defRPr>
+            </a:pPr>
+            <a:r>
+              <a:t>Литература</a:t>
+            </a:r>
+          </a:p>
+        </p:txBody>
+      </p:sp>
+      <p:sp>
+        <p:nvSpPr>
+          <p:cNvPr id="4" name="TextBox 3"/>
+          <p:cNvSpPr txBox="1"/>
+          <p:nvPr/>
+        </p:nvSpPr>
+        <p:spPr>
+          <a:xfrm>
+            <a:off x="640080" y="1673352"/>
+            <a:ext cx="6583680" cy="566928"/>
+          </a:xfrm>
+          <a:prstGeom prst="rect">
+            <a:avLst/>
+          </a:prstGeom>
+          <a:noFill/>
+        </p:spPr>
+        <p:txBody>
+          <a:bodyPr wrap="square">
+            <a:spAutoFit/>
+          </a:bodyPr>
+          <a:lstStyle/>
+          <a:p>
+            <a:pPr>
+              <a:spcAft>
+                <a:spcPts val="400"/>
+              </a:spcAft>
+            </a:pPr>
+            <a:r>
+              <a:rPr lang="ru-RU" dirty="0" sz="1600">
+                <a:solidFill>
+                  <a:srgbClr val="000000"/>
+                </a:solidFill>
+              </a:rPr>
+              <a:t xml:space="preserve">• </a:t>
+            </a:r>
+            <a:r>
+              <a:rPr sz="1600">
+                <a:solidFill>
+                  <a:srgbClr val="3366CC"/>
+                </a:solidFill>
+                <a:hlinkClick r:id="rId2"/>
+              </a:rPr>
+              <a:t>Hoerl A.E., Kennard R.W. (1970). Ridge Regression: Biased Estimation for Nonorthogonal Problems</a:t>
+            </a:r>
+          </a:p>
+        </p:txBody>
+      </p:sp>
+      <p:sp>
+        <p:nvSpPr>
+          <p:cNvPr id="5" name="TextBox 4"/>
+          <p:cNvSpPr txBox="1"/>
+          <p:nvPr/>
+        </p:nvSpPr>
+        <p:spPr>
+          <a:xfrm>
+            <a:off x="640080" y="2240280"/>
+            <a:ext cx="6583680" cy="566928"/>
+          </a:xfrm>
+          <a:prstGeom prst="rect">
+            <a:avLst/>
+          </a:prstGeom>
+          <a:noFill/>
+        </p:spPr>
+        <p:txBody>
+          <a:bodyPr wrap="square">
+            <a:spAutoFit/>
+          </a:bodyPr>
+          <a:lstStyle/>
+          <a:p>
+            <a:pPr>
+              <a:spcAft>
+                <a:spcPts val="400"/>
+              </a:spcAft>
+            </a:pPr>
+            <a:r>
+              <a:rPr lang="ru-RU" dirty="0" sz="1600">
+                <a:solidFill>
+                  <a:srgbClr val="000000"/>
+                </a:solidFill>
+              </a:rPr>
+              <a:t xml:space="preserve">• </a:t>
+            </a:r>
+            <a:r>
+              <a:rPr sz="1600">
+                <a:solidFill>
+                  <a:srgbClr val="3366CC"/>
+                </a:solidFill>
+                <a:hlinkClick r:id="rId3"/>
+              </a:rPr>
+              <a:t>Tibshirani R. (1996). Regression Shrinkage and Selection via the Lasso</a:t>
+            </a:r>
+          </a:p>
+        </p:txBody>
+      </p:sp>
+      <p:sp>
+        <p:nvSpPr>
+          <p:cNvPr id="6" name="TextBox 5"/>
+          <p:cNvSpPr txBox="1"/>
+          <p:nvPr/>
+        </p:nvSpPr>
+        <p:spPr>
+          <a:xfrm>
+            <a:off x="640080" y="2807208"/>
+            <a:ext cx="6583680" cy="566928"/>
+          </a:xfrm>
+          <a:prstGeom prst="rect">
+            <a:avLst/>
+          </a:prstGeom>
+          <a:noFill/>
+        </p:spPr>
+        <p:txBody>
+          <a:bodyPr wrap="square">
+            <a:spAutoFit/>
+          </a:bodyPr>
+          <a:lstStyle/>
+          <a:p>
+            <a:pPr>
+              <a:spcAft>
+                <a:spcPts val="400"/>
+              </a:spcAft>
+            </a:pPr>
+            <a:r>
+              <a:rPr lang="ru-RU" dirty="0" sz="1600">
+                <a:solidFill>
+                  <a:srgbClr val="000000"/>
+                </a:solidFill>
+              </a:rPr>
+              <a:t xml:space="preserve">• </a:t>
+            </a:r>
+            <a:r>
+              <a:rPr sz="1600">
+                <a:solidFill>
+                  <a:srgbClr val="3366CC"/>
+                </a:solidFill>
+                <a:hlinkClick r:id="rId4"/>
+              </a:rPr>
+              <a:t>Markov A.A. (1900). Least Squares Estimation of Linear Models</a:t>
+            </a:r>
+          </a:p>
+        </p:txBody>
+      </p:sp>
+      <p:sp>
+        <p:nvSpPr>
+          <p:cNvPr id="7" name="TextBox 6"/>
+          <p:cNvSpPr txBox="1"/>
+          <p:nvPr/>
+        </p:nvSpPr>
+        <p:spPr>
+          <a:xfrm>
+            <a:off x="640080" y="3374136"/>
+            <a:ext cx="6583680" cy="320040"/>
+          </a:xfrm>
+          <a:prstGeom prst="rect">
+            <a:avLst/>
+          </a:prstGeom>
+          <a:noFill/>
+        </p:spPr>
+        <p:txBody>
+          <a:bodyPr wrap="none">
+            <a:spAutoFit/>
+          </a:bodyPr>
+          <a:lstStyle/>
+          <a:p>
+            <a:pPr>
+              <a:defRPr sz="1800" b="1">
+                <a:solidFill>
+                  <a:srgbClr val="000000"/>
+                </a:solidFill>
+              </a:defRPr>
+            </a:pPr>
+            <a:r>
+              <a:t>Практика в Colab</a:t>
+            </a:r>
+          </a:p>
+        </p:txBody>
+      </p:sp>
+      <p:sp>
+        <p:nvSpPr>
+          <p:cNvPr id="8" name="TextBox 7"/>
+          <p:cNvSpPr txBox="1"/>
+          <p:nvPr/>
+        </p:nvSpPr>
+        <p:spPr>
+          <a:xfrm>
+            <a:off x="640080" y="3721608"/>
+            <a:ext cx="6583680" cy="457200"/>
+          </a:xfrm>
+          <a:prstGeom prst="rect">
+            <a:avLst/>
+          </a:prstGeom>
+          <a:noFill/>
+        </p:spPr>
+        <p:txBody>
+          <a:bodyPr wrap="square">
+            <a:spAutoFit/>
+          </a:bodyPr>
+          <a:lstStyle/>
+          <a:p>
+            <a:r>
+              <a:rPr lang="ru-RU" dirty="0" sz="1500">
+                <a:solidFill>
+                  <a:srgbClr val="000000"/>
+                </a:solidFill>
+              </a:rPr>
+              <a:t xml:space="preserve">• Примеры по слайдам: </a:t>
+            </a:r>
+            <a:r>
+              <a:rPr sz="1400">
+                <a:solidFill>
+                  <a:srgbClr val="3366CC"/>
+                </a:solidFill>
+                <a:hlinkClick r:id="rId5"/>
+              </a:rPr>
+              <a:t>https://colab.research.google.com/github/gurovic/ml-lessons/blob/pandas-lesson-rebuild/lessons/lineynaya_regressiya/code.ipynb</a:t>
+            </a:r>
+          </a:p>
+        </p:txBody>
+      </p:sp>
+      <p:sp>
+        <p:nvSpPr>
+          <p:cNvPr id="9" name="TextBox 8"/>
+          <p:cNvSpPr txBox="1"/>
+          <p:nvPr/>
+        </p:nvSpPr>
+        <p:spPr>
+          <a:xfrm>
+            <a:off x="640080" y="4178808"/>
+            <a:ext cx="6583680" cy="457200"/>
+          </a:xfrm>
+          <a:prstGeom prst="rect">
+            <a:avLst/>
+          </a:prstGeom>
+          <a:noFill/>
+        </p:spPr>
+        <p:txBody>
+          <a:bodyPr wrap="square">
+            <a:spAutoFit/>
+          </a:bodyPr>
+          <a:lstStyle/>
+          <a:p>
+            <a:r>
+              <a:rPr lang="ru-RU" dirty="0" sz="1500">
+                <a:solidFill>
+                  <a:srgbClr val="000000"/>
+                </a:solidFill>
+              </a:rPr>
+              <a:t xml:space="preserve">• Мини-проект: </a:t>
+            </a:r>
+            <a:r>
+              <a:rPr sz="1400">
+                <a:solidFill>
+                  <a:srgbClr val="3366CC"/>
+                </a:solidFill>
+                <a:hlinkClick r:id="rId6"/>
+              </a:rPr>
+              <a:t>https://colab.research.google.com/github/gurovic/ml-lessons/blob/pandas-lesson-rebuild/lessons/lineynaya_regressiya/project.ipynb</a:t>
+            </a:r>
+          </a:p>
+        </p:txBody>
+      </p:sp>
+      <p:pic>
+        <p:nvPicPr>
+          <p:cNvPr id="10" name="Picture 9" descr="_qr_ref_17_0.png"/>
+          <p:cNvPicPr>
+            <a:picLocks noChangeAspect="1"/>
+          </p:cNvPicPr>
+          <p:nvPr/>
+        </p:nvPicPr>
+        <p:blipFill>
+          <a:blip r:embed="rId7"/>
+          <a:stretch>
+            <a:fillRect/>
+          </a:stretch>
+        </p:blipFill>
+        <p:spPr>
+          <a:xfrm>
+            <a:off x="8229600" y="1463040"/>
+            <a:ext cx="1051560" cy="1051560"/>
+          </a:xfrm>
+          <a:prstGeom prst="rect">
+            <a:avLst/>
+          </a:prstGeom>
+        </p:spPr>
+      </p:pic>
+      <p:sp>
+        <p:nvSpPr>
+          <p:cNvPr id="11" name="TextBox 10"/>
+          <p:cNvSpPr txBox="1"/>
+          <p:nvPr/>
+        </p:nvSpPr>
+        <p:spPr>
+          <a:xfrm>
+            <a:off x="8138160" y="2532888"/>
+            <a:ext cx="1417319" cy="274320"/>
+          </a:xfrm>
+          <a:prstGeom prst="rect">
+            <a:avLst/>
+          </a:prstGeom>
+          <a:noFill/>
+        </p:spPr>
+        <p:txBody>
+          <a:bodyPr wrap="none">
+            <a:spAutoFit/>
+          </a:bodyPr>
+          <a:lstStyle/>
+          <a:p>
+            <a:pPr algn="ctr">
+              <a:defRPr sz="1000">
+                <a:solidFill>
+                  <a:srgbClr val="555555"/>
+                </a:solidFill>
+              </a:defRPr>
+            </a:pPr>
+            <a:r>
+              <a:t>Примеры по слайдам</a:t>
+            </a:r>
+          </a:p>
+        </p:txBody>
+      </p:sp>
+      <p:pic>
+        <p:nvPicPr>
+          <p:cNvPr id="12" name="Picture 11" descr="_qr_ref_17_1.png"/>
+          <p:cNvPicPr>
+            <a:picLocks noChangeAspect="1"/>
+          </p:cNvPicPr>
+          <p:nvPr/>
+        </p:nvPicPr>
+        <p:blipFill>
+          <a:blip r:embed="rId8"/>
+          <a:stretch>
+            <a:fillRect/>
+          </a:stretch>
+        </p:blipFill>
+        <p:spPr>
+          <a:xfrm>
+            <a:off x="8229600" y="3063240"/>
+            <a:ext cx="1051560" cy="1051560"/>
+          </a:xfrm>
+          <a:prstGeom prst="rect">
+            <a:avLst/>
+          </a:prstGeom>
+        </p:spPr>
+      </p:pic>
+      <p:sp>
+        <p:nvSpPr>
+          <p:cNvPr id="13" name="TextBox 12"/>
+          <p:cNvSpPr txBox="1"/>
+          <p:nvPr/>
+        </p:nvSpPr>
+        <p:spPr>
+          <a:xfrm>
+            <a:off x="8138160" y="4133087"/>
+            <a:ext cx="1417319" cy="274320"/>
+          </a:xfrm>
+          <a:prstGeom prst="rect">
+            <a:avLst/>
+          </a:prstGeom>
+          <a:noFill/>
+        </p:spPr>
+        <p:txBody>
+          <a:bodyPr wrap="none">
+            <a:spAutoFit/>
+          </a:bodyPr>
+          <a:lstStyle/>
+          <a:p>
+            <a:pPr algn="ctr">
+              <a:defRPr sz="1000">
+                <a:solidFill>
+                  <a:srgbClr val="555555"/>
+                </a:solidFill>
+              </a:defRPr>
+            </a:pPr>
+            <a:r>
+              <a:t>Мини-проект</a:t>
+            </a:r>
+          </a:p>
+        </p:txBody>
+      </p:sp>
+    </p:spTree>
+  </p:cSld>
+  <p:clrMapOvr>
+    <a:masterClrMapping/>
+  </p:clrMapOvr>
+</p:sld>
+</file>
+
 <file path=ppt/slides/slide2.xml><?xml version="1.0" encoding="utf-8"?>
 <p:sld xmlns:a="http://schemas.openxmlformats.org/drawingml/2006/main" xmlns:p="http://schemas.openxmlformats.org/presentationml/2006/main" xmlns:r="http://schemas.openxmlformats.org/officeDocument/2006/relationships">
   <p:cSld>
@@ -6585,8 +7120,8 @@
         </p:blipFill>
         <p:spPr>
           <a:xfrm>
-            <a:off x="7635240" y="2208847"/>
-            <a:ext cx="4343400" cy="2714625"/>
+            <a:off x="7635240" y="2075955"/>
+            <a:ext cx="4343400" cy="2980408"/>
           </a:xfrm>
           <a:prstGeom prst="rect">
             <a:avLst/>
@@ -6820,8 +7355,8 @@
         </p:blipFill>
         <p:spPr>
           <a:xfrm>
-            <a:off x="8043976" y="1325880"/>
-            <a:ext cx="3525926" cy="2203704"/>
+            <a:off x="8201192" y="1325880"/>
+            <a:ext cx="3211495" cy="2203704"/>
           </a:xfrm>
           <a:prstGeom prst="rect">
             <a:avLst/>
@@ -6844,8 +7379,8 @@
         </p:blipFill>
         <p:spPr>
           <a:xfrm>
-            <a:off x="8208601" y="3602735"/>
-            <a:ext cx="3196677" cy="2203704"/>
+            <a:off x="8203431" y="3602735"/>
+            <a:ext cx="3207016" cy="2203704"/>
           </a:xfrm>
           <a:prstGeom prst="rect">
             <a:avLst/>
@@ -7192,8 +7727,8 @@
         </p:blipFill>
         <p:spPr>
           <a:xfrm>
-            <a:off x="7635240" y="2074965"/>
-            <a:ext cx="4343400" cy="2982389"/>
+            <a:off x="7635240" y="2076907"/>
+            <a:ext cx="4343400" cy="2978505"/>
           </a:xfrm>
           <a:prstGeom prst="rect">
             <a:avLst/>
@@ -7439,8 +7974,8 @@
         </p:blipFill>
         <p:spPr>
           <a:xfrm>
-            <a:off x="7635240" y="2069968"/>
-            <a:ext cx="4343400" cy="2992383"/>
+            <a:off x="7635240" y="2073874"/>
+            <a:ext cx="4343400" cy="2984571"/>
           </a:xfrm>
           <a:prstGeom prst="rect">
             <a:avLst/>
@@ -7736,8 +8271,8 @@
         </p:blipFill>
         <p:spPr>
           <a:xfrm>
-            <a:off x="7661153" y="1325880"/>
-            <a:ext cx="4291573" cy="4480560"/>
+            <a:off x="7668306" y="1325880"/>
+            <a:ext cx="4277267" cy="4480559"/>
           </a:xfrm>
           <a:prstGeom prst="rect">
             <a:avLst/>
@@ -7941,8 +8476,8 @@
         </p:blipFill>
         <p:spPr>
           <a:xfrm>
-            <a:off x="7635240" y="2739333"/>
-            <a:ext cx="4343400" cy="1653653"/>
+            <a:off x="7635240" y="2727162"/>
+            <a:ext cx="4343400" cy="1677994"/>
           </a:xfrm>
           <a:prstGeom prst="rect">
             <a:avLst/>
@@ -8151,8 +8686,8 @@
         </p:blipFill>
         <p:spPr>
           <a:xfrm>
-            <a:off x="7635240" y="1559051"/>
-            <a:ext cx="4343400" cy="1737360"/>
+            <a:off x="7635240" y="1604240"/>
+            <a:ext cx="4343400" cy="1646984"/>
           </a:xfrm>
           <a:prstGeom prst="rect">
             <a:avLst/>
@@ -8175,8 +8710,8 @@
         </p:blipFill>
         <p:spPr>
           <a:xfrm>
-            <a:off x="7635240" y="3878111"/>
-            <a:ext cx="4343400" cy="1652954"/>
+            <a:off x="7635240" y="3881659"/>
+            <a:ext cx="4343400" cy="1645857"/>
           </a:xfrm>
           <a:prstGeom prst="rect">
             <a:avLst/>
@@ -8357,8 +8892,8 @@
         </p:blipFill>
         <p:spPr>
           <a:xfrm>
-            <a:off x="7635240" y="2652101"/>
-            <a:ext cx="4343400" cy="1828118"/>
+            <a:off x="7635240" y="2629149"/>
+            <a:ext cx="4343400" cy="1874021"/>
           </a:xfrm>
           <a:prstGeom prst="rect">
             <a:avLst/>

</xml_diff>

<commit_message>
Improve diagram font size and PPTX placement.
Raise viz_style minimum fonts and DPI, add FIGSIZE constants, widen
image column and auto wide-band layout for dual-panel PNGs. Regenerate
lineynaya_regressiya assets and rebuild presentation as proof.

Closes #16

Co-authored-by: Cursor <cursoragent@cursor.com>
</commit_message>
<xml_diff>
--- a/lessons/lineynaya_regressiya/presentation.pptx
+++ b/lessons/lineynaya_regressiya/presentation.pptx
@@ -4845,7 +4845,7 @@
         <p:spPr>
           <a:xfrm>
             <a:off x="640080" y="1371600"/>
-            <a:ext cx="6858000" cy="3035807"/>
+            <a:ext cx="6583680" cy="3035807"/>
           </a:xfrm>
           <a:prstGeom prst="rect">
             <a:avLst/>
@@ -4928,7 +4928,7 @@
         <p:spPr>
           <a:xfrm>
             <a:off x="640080" y="4517136"/>
-            <a:ext cx="6766560" cy="978407"/>
+            <a:ext cx="6492240" cy="978407"/>
           </a:xfrm>
           <a:prstGeom prst="rect">
             <a:avLst/>
@@ -4973,7 +4973,7 @@
         <p:spPr>
           <a:xfrm>
             <a:off x="713231" y="4553712"/>
-            <a:ext cx="6620256" cy="905255"/>
+            <a:ext cx="6345936" cy="905255"/>
           </a:xfrm>
           <a:prstGeom prst="rect">
             <a:avLst/>
@@ -5076,7 +5076,7 @@
         <p:spPr>
           <a:xfrm>
             <a:off x="640080" y="5550407"/>
-            <a:ext cx="6766560" cy="201168"/>
+            <a:ext cx="6492240" cy="201168"/>
           </a:xfrm>
           <a:prstGeom prst="rect">
             <a:avLst/>
@@ -5118,8 +5118,8 @@
         </p:blipFill>
         <p:spPr>
           <a:xfrm>
-            <a:off x="7635240" y="2743231"/>
-            <a:ext cx="4343400" cy="1645857"/>
+            <a:off x="5037749" y="3703320"/>
+            <a:ext cx="6292261" cy="2560320"/>
           </a:xfrm>
           <a:prstGeom prst="rect">
             <a:avLst/>
@@ -5186,7 +5186,7 @@
         <p:spPr>
           <a:xfrm>
             <a:off x="640080" y="1371600"/>
-            <a:ext cx="6858000" cy="1810512"/>
+            <a:ext cx="6583680" cy="2194560"/>
           </a:xfrm>
           <a:prstGeom prst="rect">
             <a:avLst/>
@@ -5274,7 +5274,23 @@
                   <a:srgbClr val="000000"/>
                 </a:solidFill>
               </a:rPr>
-              <a:t xml:space="preserve"> — сжимает веса, помогает при мультиколлинеарности</a:t>
+              <a:t xml:space="preserve"> — сжимает веса </a:t>
+            </a:r>
+            <a:r>
+              <a:rPr lang="ru-RU" dirty="0" sz="2000" b="1">
+                <a:solidFill>
+                  <a:srgbClr val="000000"/>
+                </a:solidFill>
+              </a:rPr>
+              <a:t>вместе</a:t>
+            </a:r>
+            <a:r>
+              <a:rPr lang="ru-RU" dirty="0" sz="2000">
+                <a:solidFill>
+                  <a:srgbClr val="000000"/>
+                </a:solidFill>
+              </a:rPr>
+              <a:t>, не обнуляя; стабилизирует при мультиколлинеарности</a:t>
             </a:r>
           </a:p>
           <a:p>
@@ -5339,7 +5355,38 @@
                   <a:srgbClr val="000000"/>
                 </a:solidFill>
               </a:rPr>
-              <a:t xml:space="preserve"> — может обнулять веса → отбор признаков</a:t>
+              <a:t xml:space="preserve"> — обнуляет слабые признаки → отбор фич, но не лечит дублирующие столбцы</a:t>
+            </a:r>
+          </a:p>
+          <a:p>
+            <a:pPr>
+              <a:spcAft>
+                <a:spcPts val="800"/>
+              </a:spcAft>
+            </a:pPr>
+            <a:r>
+              <a:rPr lang="ru-RU" dirty="0" sz="2000">
+                <a:solidFill>
+                  <a:srgbClr val="000000"/>
+                </a:solidFill>
+              </a:rPr>
+              <a:t xml:space="preserve">При коррелированных признаках предпочтите </a:t>
+            </a:r>
+            <a:r>
+              <a:rPr lang="ru-RU" dirty="0" sz="2000" b="1">
+                <a:solidFill>
+                  <a:srgbClr val="000000"/>
+                </a:solidFill>
+              </a:rPr>
+              <a:t>Ridge</a:t>
+            </a:r>
+            <a:r>
+              <a:rPr lang="ru-RU" dirty="0" sz="2000">
+                <a:solidFill>
+                  <a:srgbClr val="000000"/>
+                </a:solidFill>
+              </a:rPr>
+              <a:t>; Lasso выберет один из дублей случайно</a:t>
             </a:r>
           </a:p>
           <a:p>
@@ -5369,7 +5416,7 @@
                   <a:srgbClr val="000000"/>
                 </a:solidFill>
               </a:rPr>
-              <a:t xml:space="preserve"> подбирают по validation / cross-validation</a:t>
+              <a:t xml:space="preserve"> подбирают по validation / cross-validation (см. график)</a:t>
             </a:r>
           </a:p>
         </p:txBody>
@@ -5390,8 +5437,32 @@
         </p:blipFill>
         <p:spPr>
           <a:xfrm>
-            <a:off x="7635240" y="2585197"/>
-            <a:ext cx="4343400" cy="1961925"/>
+            <a:off x="7269480" y="1359615"/>
+            <a:ext cx="5029200" cy="2145377"/>
+          </a:xfrm>
+          <a:prstGeom prst="rect">
+            <a:avLst/>
+          </a:prstGeom>
+        </p:spPr>
+      </p:pic>
+      <p:pic>
+        <p:nvPicPr>
+          <p:cNvPr id="5" name="Picture 4" descr="ridge_alpha_cv.png"/>
+          <p:cNvPicPr>
+            <a:picLocks noChangeAspect="1"/>
+          </p:cNvPicPr>
+          <p:nvPr/>
+        </p:nvPicPr>
+        <p:blipFill>
+          <a:blip r:embed="rId3"/>
+          <a:stretch>
+            <a:fillRect/>
+          </a:stretch>
+        </p:blipFill>
+        <p:spPr>
+          <a:xfrm>
+            <a:off x="8231517" y="3593592"/>
+            <a:ext cx="3105125" cy="2212848"/>
           </a:xfrm>
           <a:prstGeom prst="rect">
             <a:avLst/>
@@ -5458,7 +5529,7 @@
         <p:spPr>
           <a:xfrm>
             <a:off x="640080" y="1371600"/>
-            <a:ext cx="6858000" cy="3209544"/>
+            <a:ext cx="6583680" cy="3035807"/>
           </a:xfrm>
           <a:prstGeom prst="rect">
             <a:avLst/>
@@ -5643,8 +5714,8 @@
         </p:nvSpPr>
         <p:spPr>
           <a:xfrm>
-            <a:off x="640080" y="4690872"/>
-            <a:ext cx="6766560" cy="804672"/>
+            <a:off x="640080" y="4517136"/>
+            <a:ext cx="6492240" cy="978407"/>
           </a:xfrm>
           <a:prstGeom prst="rect">
             <a:avLst/>
@@ -5688,8 +5759,8 @@
         </p:nvSpPr>
         <p:spPr>
           <a:xfrm>
-            <a:off x="713231" y="4727448"/>
-            <a:ext cx="6620256" cy="731520"/>
+            <a:off x="713231" y="4553712"/>
+            <a:ext cx="6345936" cy="905255"/>
           </a:xfrm>
           <a:prstGeom prst="rect">
             <a:avLst/>
@@ -5714,7 +5785,7 @@
                 </a:solidFill>
                 <a:latin typeface="Consolas"/>
               </a:rPr>
-              <a:t>from sklearn.metrics import mean_absolute_error, r2_score</a:t>
+              <a:t>from sklearn.metrics import mean_absolute_error, mean_squared_error, r2_score</a:t>
             </a:r>
           </a:p>
           <a:p>
@@ -5746,7 +5817,7 @@
                 </a:solidFill>
                 <a:latin typeface="Consolas"/>
               </a:rPr>
-              <a:t>r2 = r2_score(y_te, y_pred)</a:t>
+              <a:t>rmse = mean_squared_error(y_te, y_pred, squared=False)</a:t>
             </a:r>
           </a:p>
           <a:p>
@@ -5762,7 +5833,23 @@
                 </a:solidFill>
                 <a:latin typeface="Consolas"/>
               </a:rPr>
-              <a:t>print(f'MAE={mae:.2f}, R²={r2:.3f}')</a:t>
+              <a:t>r2 = r2_score(y_te, y_pred)</a:t>
+            </a:r>
+          </a:p>
+          <a:p>
+            <a:pPr>
+              <a:spcAft>
+                <a:spcPts val="0"/>
+              </a:spcAft>
+            </a:pPr>
+            <a:r>
+              <a:rPr sz="1100">
+                <a:solidFill>
+                  <a:srgbClr val="000000"/>
+                </a:solidFill>
+                <a:latin typeface="Consolas"/>
+              </a:rPr>
+              <a:t>print(f'MAE={mae:.2f}, RMSE={rmse:.2f}, R²={r2:.3f}')</a:t>
             </a:r>
           </a:p>
         </p:txBody>
@@ -5775,8 +5862,8 @@
         </p:nvSpPr>
         <p:spPr>
           <a:xfrm>
-            <a:off x="640080" y="5550408"/>
-            <a:ext cx="6766560" cy="201168"/>
+            <a:off x="640080" y="5550407"/>
+            <a:ext cx="6492240" cy="201168"/>
           </a:xfrm>
           <a:prstGeom prst="rect">
             <a:avLst/>
@@ -5797,7 +5884,7 @@
               </a:defRPr>
             </a:pPr>
             <a:r>
-              <a:t>MAE и R²</a:t>
+              <a:t>MAE, RMSE и R²</a:t>
             </a:r>
           </a:p>
         </p:txBody>
@@ -5818,8 +5905,8 @@
         </p:blipFill>
         <p:spPr>
           <a:xfrm>
-            <a:off x="7635240" y="2073874"/>
-            <a:ext cx="4343400" cy="2984571"/>
+            <a:off x="7269480" y="1774146"/>
+            <a:ext cx="5029200" cy="3584028"/>
           </a:xfrm>
           <a:prstGeom prst="rect">
             <a:avLst/>
@@ -5886,7 +5973,7 @@
         <p:spPr>
           <a:xfrm>
             <a:off x="640080" y="1371600"/>
-            <a:ext cx="6858000" cy="1810512"/>
+            <a:ext cx="6583680" cy="1810512"/>
           </a:xfrm>
           <a:prstGeom prst="rect">
             <a:avLst/>
@@ -6030,8 +6117,8 @@
         </p:blipFill>
         <p:spPr>
           <a:xfrm>
-            <a:off x="7635240" y="2758695"/>
-            <a:ext cx="4343400" cy="1614929"/>
+            <a:off x="4572000" y="3731449"/>
+            <a:ext cx="7223760" cy="2504062"/>
           </a:xfrm>
           <a:prstGeom prst="rect">
             <a:avLst/>
@@ -6098,7 +6185,7 @@
         <p:spPr>
           <a:xfrm>
             <a:off x="640080" y="1371600"/>
-            <a:ext cx="6858000" cy="1810512"/>
+            <a:ext cx="6583680" cy="1810512"/>
           </a:xfrm>
           <a:prstGeom prst="rect">
             <a:avLst/>
@@ -6252,8 +6339,8 @@
         </p:blipFill>
         <p:spPr>
           <a:xfrm>
-            <a:off x="7635240" y="2073874"/>
-            <a:ext cx="4343400" cy="2984571"/>
+            <a:off x="7269480" y="1789462"/>
+            <a:ext cx="5029200" cy="3553395"/>
           </a:xfrm>
           <a:prstGeom prst="rect">
             <a:avLst/>
@@ -6320,7 +6407,7 @@
         <p:spPr>
           <a:xfrm>
             <a:off x="640080" y="1371600"/>
-            <a:ext cx="6858000" cy="2514599"/>
+            <a:ext cx="6583680" cy="2514599"/>
           </a:xfrm>
           <a:prstGeom prst="rect">
             <a:avLst/>
@@ -6419,7 +6506,7 @@
         <p:spPr>
           <a:xfrm>
             <a:off x="640080" y="3995927"/>
-            <a:ext cx="6766560" cy="1499616"/>
+            <a:ext cx="6492240" cy="1499616"/>
           </a:xfrm>
           <a:prstGeom prst="rect">
             <a:avLst/>
@@ -6464,7 +6551,7 @@
         <p:spPr>
           <a:xfrm>
             <a:off x="713231" y="4032503"/>
-            <a:ext cx="6620256" cy="1426464"/>
+            <a:ext cx="6345936" cy="1426464"/>
           </a:xfrm>
           <a:prstGeom prst="rect">
             <a:avLst/>
@@ -6615,7 +6702,7 @@
         <p:spPr>
           <a:xfrm>
             <a:off x="640080" y="5550407"/>
-            <a:ext cx="6766560" cy="201168"/>
+            <a:ext cx="6492240" cy="201168"/>
           </a:xfrm>
           <a:prstGeom prst="rect">
             <a:avLst/>
@@ -6657,8 +6744,8 @@
         </p:blipFill>
         <p:spPr>
           <a:xfrm>
-            <a:off x="7635240" y="2857963"/>
-            <a:ext cx="4343400" cy="1416392"/>
+            <a:off x="4627306" y="3703320"/>
+            <a:ext cx="7113147" cy="2560320"/>
           </a:xfrm>
           <a:prstGeom prst="rect">
             <a:avLst/>
@@ -6725,7 +6812,7 @@
         <p:spPr>
           <a:xfrm>
             <a:off x="640080" y="1371600"/>
-            <a:ext cx="6858000" cy="1810512"/>
+            <a:ext cx="6583680" cy="1810512"/>
           </a:xfrm>
           <a:prstGeom prst="rect">
             <a:avLst/>
@@ -6764,7 +6851,7 @@
                   <a:srgbClr val="000000"/>
                 </a:solidFill>
               </a:rPr>
-              <a:t>Сильное взаимодействие признаков без явных фичей (</a:t>
+              <a:t xml:space="preserve">Эффект одного признака зависит от другого, но в модели нет произведения </a:t>
             </a:r>
             <ns0:m xmlns:ns0="http://schemas.microsoft.com/office/drawing/2010/main">
               <m:oMath xmlns:m="http://schemas.openxmlformats.org/officeDocument/2006/math">
@@ -6803,7 +6890,7 @@
                   <a:srgbClr val="000000"/>
                 </a:solidFill>
               </a:rPr>
-              <a:t>)</a:t>
+              <a:t xml:space="preserve"> — линейная формула это не описывает</a:t>
             </a:r>
           </a:p>
           <a:p>
@@ -6869,8 +6956,8 @@
         </p:blipFill>
         <p:spPr>
           <a:xfrm>
-            <a:off x="7635240" y="2739840"/>
-            <a:ext cx="4343400" cy="1652640"/>
+            <a:off x="5103169" y="3703320"/>
+            <a:ext cx="6161420" cy="2560320"/>
           </a:xfrm>
           <a:prstGeom prst="rect">
             <a:avLst/>
@@ -7170,7 +7257,7 @@
                 </a:solidFill>
                 <a:hlinkClick r:id="rId2"/>
               </a:rPr>
-              <a:t>Hoerl A.E., Kennard R.W. (1970). Ridge Regression: Biased Estimation for Nonorthogonal Problems</a:t>
+              <a:t>Markov A.A. (1900). Least Squares Estimation of Linear Models</a:t>
             </a:r>
           </a:p>
         </p:txBody>
@@ -7217,7 +7304,7 @@
                 </a:solidFill>
                 <a:hlinkClick r:id="rId3"/>
               </a:rPr>
-              <a:t>Tibshirani R. (1996). Regression Shrinkage and Selection via the Lasso</a:t>
+              <a:t>Hoerl A.E., Kennard R.W. (1970). Ridge Regression: Biased Estimation for Nonorthogonal Problems</a:t>
             </a:r>
           </a:p>
         </p:txBody>
@@ -7264,7 +7351,7 @@
                 </a:solidFill>
                 <a:hlinkClick r:id="rId4"/>
               </a:rPr>
-              <a:t>Markov A.A. (1900). Least Squares Estimation of Linear Models</a:t>
+              <a:t>Tibshirani R. (1996). Regression Shrinkage and Selection via the Lasso</a:t>
             </a:r>
           </a:p>
         </p:txBody>
@@ -7566,7 +7653,7 @@
         <p:spPr>
           <a:xfrm>
             <a:off x="640080" y="1371600"/>
-            <a:ext cx="6858000" cy="1810512"/>
+            <a:ext cx="6583680" cy="1810512"/>
           </a:xfrm>
           <a:prstGeom prst="rect">
             <a:avLst/>
@@ -7701,8 +7788,8 @@
         </p:blipFill>
         <p:spPr>
           <a:xfrm>
-            <a:off x="7635240" y="2075955"/>
-            <a:ext cx="4343400" cy="2980408"/>
+            <a:off x="7269480" y="1774146"/>
+            <a:ext cx="5029200" cy="3584028"/>
           </a:xfrm>
           <a:prstGeom prst="rect">
             <a:avLst/>
@@ -7769,7 +7856,7 @@
         <p:spPr>
           <a:xfrm>
             <a:off x="640080" y="1371600"/>
-            <a:ext cx="6858000" cy="1810512"/>
+            <a:ext cx="6583680" cy="1810512"/>
           </a:xfrm>
           <a:prstGeom prst="rect">
             <a:avLst/>
@@ -7895,12 +7982,65 @@
               </a:spcAft>
             </a:pPr>
             <a:r>
+              <a:rPr lang="ru-RU" dirty="0" sz="2000" b="1">
+                <a:solidFill>
+                  <a:srgbClr val="000000"/>
+                </a:solidFill>
+              </a:rPr>
+              <a:t>Intercept</a:t>
+            </a:r>
+            <a:r>
               <a:rPr lang="ru-RU" dirty="0" sz="2000">
                 <a:solidFill>
                   <a:srgbClr val="000000"/>
                 </a:solidFill>
               </a:rPr>
-              <a:t>Хорошая модель: остатки симметрично разбросаны вокруг нуля, без систематического смещения</a:t>
+              <a:t xml:space="preserve"> (</a:t>
+            </a:r>
+            <ns0:m xmlns:ns0="http://schemas.microsoft.com/office/drawing/2010/main">
+              <m:oMath xmlns:m="http://schemas.openxmlformats.org/officeDocument/2006/math">
+                <m:r>
+                  <m:t>b</m:t>
+                </m:r>
+              </m:oMath>
+            </ns0:m>
+            <a:r>
+              <a:rPr lang="ru-RU" dirty="0" sz="2000">
+                <a:solidFill>
+                  <a:srgbClr val="000000"/>
+                </a:solidFill>
+              </a:rPr>
+              <a:t xml:space="preserve">): прогноз при </a:t>
+            </a:r>
+            <ns0:m xmlns:ns0="http://schemas.microsoft.com/office/drawing/2010/main">
+              <m:oMath xmlns:m="http://schemas.openxmlformats.org/officeDocument/2006/math">
+                <m:r>
+                  <m:t>x=0</m:t>
+                </m:r>
+              </m:oMath>
+            </ns0:m>
+            <a:r>
+              <a:rPr lang="ru-RU" dirty="0" sz="2000">
+                <a:solidFill>
+                  <a:srgbClr val="000000"/>
+                </a:solidFill>
+              </a:rPr>
+              <a:t xml:space="preserve">; в sklearn — параметр `fit_intercept=True` (смещение прямой по оси </a:t>
+            </a:r>
+            <ns0:m xmlns:ns0="http://schemas.microsoft.com/office/drawing/2010/main">
+              <m:oMath xmlns:m="http://schemas.openxmlformats.org/officeDocument/2006/math">
+                <m:r>
+                  <m:t>y</m:t>
+                </m:r>
+              </m:oMath>
+            </ns0:m>
+            <a:r>
+              <a:rPr lang="ru-RU" dirty="0" sz="2000">
+                <a:solidFill>
+                  <a:srgbClr val="000000"/>
+                </a:solidFill>
+              </a:rPr>
+              <a:t>)</a:t>
             </a:r>
           </a:p>
           <a:p>
@@ -7915,7 +8055,7 @@
                   <a:srgbClr val="000000"/>
                 </a:solidFill>
               </a:rPr>
-              <a:t>Сумма остатков на обучающей выборке при МНК равна нулю (для модели с intercept)</a:t>
+              <a:t>Хорошая модель: остатки симметрично разбросаны вокруг нуля, без систематического смещения</a:t>
             </a:r>
           </a:p>
         </p:txBody>
@@ -7936,8 +8076,8 @@
         </p:blipFill>
         <p:spPr>
           <a:xfrm>
-            <a:off x="8201192" y="1325880"/>
-            <a:ext cx="3211495" cy="2203704"/>
+            <a:off x="8231517" y="1325880"/>
+            <a:ext cx="3105125" cy="2212848"/>
           </a:xfrm>
           <a:prstGeom prst="rect">
             <a:avLst/>
@@ -7960,8 +8100,8 @@
         </p:blipFill>
         <p:spPr>
           <a:xfrm>
-            <a:off x="8203431" y="3602735"/>
-            <a:ext cx="3207016" cy="2203704"/>
+            <a:off x="8231517" y="3593592"/>
+            <a:ext cx="3105125" cy="2212848"/>
           </a:xfrm>
           <a:prstGeom prst="rect">
             <a:avLst/>
@@ -8028,7 +8168,7 @@
         <p:spPr>
           <a:xfrm>
             <a:off x="640080" y="1371600"/>
-            <a:ext cx="6858000" cy="2194560"/>
+            <a:ext cx="6583680" cy="2194560"/>
           </a:xfrm>
           <a:prstGeom prst="rect">
             <a:avLst/>
@@ -8160,7 +8300,85 @@
                   <a:srgbClr val="000000"/>
                 </a:solidFill>
               </a:rPr>
-              <a:t xml:space="preserve">Сумму без деления на </a:t>
+              <a:t xml:space="preserve">Минимизация </a:t>
+            </a:r>
+            <ns0:m xmlns:ns0="http://schemas.microsoft.com/office/drawing/2010/main">
+              <m:oMath xmlns:m="http://schemas.openxmlformats.org/officeDocument/2006/math">
+                <m:nary>
+                  <m:naryPr>
+                    <m:chr m:val="∑"/>
+                    <m:limLoc m:val="subSup"/>
+                    <m:grow m:val="1"/>
+                    <m:subHide m:val="off"/>
+                    <m:supHide m:val="on"/>
+                  </m:naryPr>
+                  <m:sub>
+                    <m:r>
+                      <m:t>i</m:t>
+                    </m:r>
+                  </m:sub>
+                  <m:sup/>
+                  <m:e>
+                    <m:r>
+                      <m:t>(</m:t>
+                    </m:r>
+                  </m:e>
+                </m:nary>
+                <m:sSub>
+                  <m:e>
+                    <m:r>
+                      <m:t>y</m:t>
+                    </m:r>
+                  </m:e>
+                  <m:sub>
+                    <m:r>
+                      <m:t>i</m:t>
+                    </m:r>
+                  </m:sub>
+                </m:sSub>
+                <m:r>
+                  <m:t>−</m:t>
+                </m:r>
+                <m:sSub>
+                  <m:e>
+                    <m:acc>
+                      <m:accPr>
+                        <m:chr m:val="̂"/>
+                      </m:accPr>
+                      <m:e>
+                        <m:r>
+                          <m:t>y</m:t>
+                        </m:r>
+                      </m:e>
+                    </m:acc>
+                  </m:e>
+                  <m:sub>
+                    <m:r>
+                      <m:t>i</m:t>
+                    </m:r>
+                  </m:sub>
+                </m:sSub>
+                <m:sSup>
+                  <m:e>
+                    <m:r>
+                      <m:t>)</m:t>
+                    </m:r>
+                  </m:e>
+                  <m:sup>
+                    <m:r>
+                      <m:t>2</m:t>
+                    </m:r>
+                  </m:sup>
+                </m:sSup>
+              </m:oMath>
+            </ns0:m>
+            <a:r>
+              <a:rPr lang="ru-RU" dirty="0" sz="2000">
+                <a:solidFill>
+                  <a:srgbClr val="000000"/>
+                </a:solidFill>
+              </a:rPr>
+              <a:t xml:space="preserve"> без деления на </a:t>
             </a:r>
             <ns0:m xmlns:ns0="http://schemas.microsoft.com/office/drawing/2010/main">
               <m:oMath xmlns:m="http://schemas.openxmlformats.org/officeDocument/2006/math">
@@ -8175,7 +8393,22 @@
                   <a:srgbClr val="000000"/>
                 </a:solidFill>
               </a:rPr>
-              <a:t xml:space="preserve"> минимизировать то же самое; деление нужно для сравнимости между выборками</a:t>
+              <a:t xml:space="preserve"> даёт те же оптимальные веса; деление на </a:t>
+            </a:r>
+            <ns0:m xmlns:ns0="http://schemas.microsoft.com/office/drawing/2010/main">
+              <m:oMath xmlns:m="http://schemas.openxmlformats.org/officeDocument/2006/math">
+                <m:r>
+                  <m:t>N</m:t>
+                </m:r>
+              </m:oMath>
+            </ns0:m>
+            <a:r>
+              <a:rPr lang="ru-RU" dirty="0" sz="2000">
+                <a:solidFill>
+                  <a:srgbClr val="000000"/>
+                </a:solidFill>
+              </a:rPr>
+              <a:t xml:space="preserve"> нужно для сравнимости между выборками</a:t>
             </a:r>
           </a:p>
           <a:p>
@@ -8287,7 +8520,7 @@
                   <a:srgbClr val="000000"/>
                 </a:solidFill>
               </a:rPr>
-              <a:t>MSE = MLE при гауссовских остатках; MAE = MLE при распределении Лапласа (например, медианный шум в задачах с редкими сбоями)</a:t>
+              <a:t>MSE = MLE при нормальных остатках; MAE = MLE, если ошибки распределены по Лапласу (редкие, но крупные сбои — например, катастрофические задержки доставки)</a:t>
             </a:r>
           </a:p>
         </p:txBody>
@@ -8308,8 +8541,8 @@
         </p:blipFill>
         <p:spPr>
           <a:xfrm>
-            <a:off x="7635240" y="2076907"/>
-            <a:ext cx="4343400" cy="2978505"/>
+            <a:off x="7269480" y="1791148"/>
+            <a:ext cx="5029200" cy="3550024"/>
           </a:xfrm>
           <a:prstGeom prst="rect">
             <a:avLst/>
@@ -8376,7 +8609,7 @@
         <p:spPr>
           <a:xfrm>
             <a:off x="640080" y="1371600"/>
-            <a:ext cx="6858000" cy="3209544"/>
+            <a:ext cx="6583680" cy="3383279"/>
           </a:xfrm>
           <a:prstGeom prst="rect">
             <a:avLst/>
@@ -8400,7 +8633,7 @@
                   <a:srgbClr val="000000"/>
                 </a:solidFill>
               </a:rPr>
-              <a:t xml:space="preserve">Аналитическое решение (МНК): производная по весам → система линейных уравнений → </a:t>
+              <a:t xml:space="preserve">Аналитическое решение (МНК): </a:t>
             </a:r>
             <ns0:m xmlns:ns0="http://schemas.microsoft.com/office/drawing/2010/main">
               <m:oMath xmlns:m="http://schemas.openxmlformats.org/officeDocument/2006/math">
@@ -8461,6 +8694,14 @@
                 </m:r>
               </m:oMath>
             </ns0:m>
+            <a:r>
+              <a:rPr lang="ru-RU" dirty="0" sz="2000">
+                <a:solidFill>
+                  <a:srgbClr val="000000"/>
+                </a:solidFill>
+              </a:rPr>
+              <a:t xml:space="preserve"> — быстро для умеренных матриц</a:t>
+            </a:r>
           </a:p>
           <a:p>
             <a:pPr>
@@ -8474,7 +8715,7 @@
                   <a:srgbClr val="000000"/>
                 </a:solidFill>
               </a:rPr>
-              <a:t>`LinearRegression` в sklearn по умолчанию решает так (solver `linalg`) — быстро и точно для умеренных матриц</a:t>
+              <a:t>`LinearRegression` в sklearn использует solver `linalg` без итераций</a:t>
             </a:r>
           </a:p>
           <a:p>
@@ -8489,22 +8730,7 @@
                   <a:srgbClr val="000000"/>
                 </a:solidFill>
               </a:rPr>
-              <a:t xml:space="preserve">При очень больших </a:t>
-            </a:r>
-            <ns0:m xmlns:ns0="http://schemas.microsoft.com/office/drawing/2010/main">
-              <m:oMath xmlns:m="http://schemas.openxmlformats.org/officeDocument/2006/math">
-                <m:r>
-                  <m:t>X</m:t>
-                </m:r>
-              </m:oMath>
-            </ns0:m>
-            <a:r>
-              <a:rPr lang="ru-RU" dirty="0" sz="2000">
-                <a:solidFill>
-                  <a:srgbClr val="000000"/>
-                </a:solidFill>
-              </a:rPr>
-              <a:t xml:space="preserve"> или нехватке памяти — итеративные методы: SGD, `sag`, `lsqr`</a:t>
+              <a:t>При огромных данных — итеративные методы: SGD, `SGDRegressor`</a:t>
             </a:r>
           </a:p>
           <a:p>
@@ -8519,22 +8745,7 @@
                   <a:srgbClr val="000000"/>
                 </a:solidFill>
               </a:rPr>
-              <a:t>Градиентный спуск: шаг против градиента функции потерь; `SGDRegressor` в sklearn</a:t>
-            </a:r>
-          </a:p>
-          <a:p>
-            <a:pPr>
-              <a:spcAft>
-                <a:spcPts val="800"/>
-              </a:spcAft>
-            </a:pPr>
-            <a:r>
-              <a:rPr lang="ru-RU" dirty="0" sz="2000">
-                <a:solidFill>
-                  <a:srgbClr val="000000"/>
-                </a:solidFill>
-              </a:rPr>
-              <a:t>На практике для линейной регрессии чаще используют не «чистый» SGD, а стабильные solver'ы (`lbfgs`, `sag` в Ridge/Lasso)</a:t>
+              <a:t>Градиентный спуск: шаг против градиента функции потерь</a:t>
             </a:r>
           </a:p>
         </p:txBody>
@@ -8547,8 +8758,8 @@
         </p:nvSpPr>
         <p:spPr>
           <a:xfrm>
-            <a:off x="640080" y="4690872"/>
-            <a:ext cx="6766560" cy="804672"/>
+            <a:off x="640080" y="4864607"/>
+            <a:ext cx="6492240" cy="630936"/>
           </a:xfrm>
           <a:prstGeom prst="rect">
             <a:avLst/>
@@ -8592,8 +8803,8 @@
         </p:nvSpPr>
         <p:spPr>
           <a:xfrm>
-            <a:off x="713231" y="4727448"/>
-            <a:ext cx="6620256" cy="731520"/>
+            <a:off x="713231" y="4901183"/>
+            <a:ext cx="6345936" cy="557784"/>
           </a:xfrm>
           <a:prstGeom prst="rect">
             <a:avLst/>
@@ -8634,7 +8845,7 @@
                 </a:solidFill>
                 <a:latin typeface="Consolas"/>
               </a:rPr>
-              <a:t>model = LinearRegression()  # solver='linalg' по умолчанию</a:t>
+              <a:t>model = LinearRegression().fit(X_train, y_train)</a:t>
             </a:r>
           </a:p>
           <a:p>
@@ -8650,22 +8861,6 @@
                 </a:solidFill>
                 <a:latin typeface="Consolas"/>
               </a:rPr>
-              <a:t>model.fit(X_train, y_train)</a:t>
-            </a:r>
-          </a:p>
-          <a:p>
-            <a:pPr>
-              <a:spcAft>
-                <a:spcPts val="0"/>
-              </a:spcAft>
-            </a:pPr>
-            <a:r>
-              <a:rPr sz="1100">
-                <a:solidFill>
-                  <a:srgbClr val="000000"/>
-                </a:solidFill>
-                <a:latin typeface="Consolas"/>
-              </a:rPr>
               <a:t>y_pred = model.predict(X_test)</a:t>
             </a:r>
           </a:p>
@@ -8679,8 +8874,8 @@
         </p:nvSpPr>
         <p:spPr>
           <a:xfrm>
-            <a:off x="640080" y="5550408"/>
-            <a:ext cx="6766560" cy="201168"/>
+            <a:off x="640080" y="5550407"/>
+            <a:ext cx="6492240" cy="201168"/>
           </a:xfrm>
           <a:prstGeom prst="rect">
             <a:avLst/>
@@ -8722,8 +8917,8 @@
         </p:blipFill>
         <p:spPr>
           <a:xfrm>
-            <a:off x="7635240" y="2073874"/>
-            <a:ext cx="4343400" cy="2984571"/>
+            <a:off x="7269480" y="1774146"/>
+            <a:ext cx="5029200" cy="3584028"/>
           </a:xfrm>
           <a:prstGeom prst="rect">
             <a:avLst/>
@@ -8790,7 +8985,7 @@
         <p:spPr>
           <a:xfrm>
             <a:off x="640080" y="1371600"/>
-            <a:ext cx="6858000" cy="1810512"/>
+            <a:ext cx="6583680" cy="1810512"/>
           </a:xfrm>
           <a:prstGeom prst="rect">
             <a:avLst/>
@@ -9019,8 +9214,8 @@
         </p:blipFill>
         <p:spPr>
           <a:xfrm>
-            <a:off x="7668306" y="1325880"/>
-            <a:ext cx="4277267" cy="4480559"/>
+            <a:off x="7632338" y="1325880"/>
+            <a:ext cx="4303483" cy="4480559"/>
           </a:xfrm>
           <a:prstGeom prst="rect">
             <a:avLst/>
@@ -9087,7 +9282,7 @@
         <p:spPr>
           <a:xfrm>
             <a:off x="640080" y="1371600"/>
-            <a:ext cx="6858000" cy="2688335"/>
+            <a:ext cx="6583680" cy="2688335"/>
           </a:xfrm>
           <a:prstGeom prst="rect">
             <a:avLst/>
@@ -9217,7 +9412,7 @@
         <p:spPr>
           <a:xfrm>
             <a:off x="640080" y="4169663"/>
-            <a:ext cx="6766560" cy="1325880"/>
+            <a:ext cx="6492240" cy="1325880"/>
           </a:xfrm>
           <a:prstGeom prst="rect">
             <a:avLst/>
@@ -9262,7 +9457,7 @@
         <p:spPr>
           <a:xfrm>
             <a:off x="713231" y="4206240"/>
-            <a:ext cx="6620256" cy="1252728"/>
+            <a:ext cx="6345936" cy="1252728"/>
           </a:xfrm>
           <a:prstGeom prst="rect">
             <a:avLst/>
@@ -9397,7 +9592,7 @@
         <p:spPr>
           <a:xfrm>
             <a:off x="640080" y="5550408"/>
-            <a:ext cx="6766560" cy="201168"/>
+            <a:ext cx="6492240" cy="201168"/>
           </a:xfrm>
           <a:prstGeom prst="rect">
             <a:avLst/>
@@ -9439,8 +9634,8 @@
         </p:blipFill>
         <p:spPr>
           <a:xfrm>
-            <a:off x="7635240" y="2727162"/>
-            <a:ext cx="4343400" cy="1677994"/>
+            <a:off x="5031801" y="3703320"/>
+            <a:ext cx="6304156" cy="2560320"/>
           </a:xfrm>
           <a:prstGeom prst="rect">
             <a:avLst/>
@@ -9507,7 +9702,7 @@
         <p:spPr>
           <a:xfrm>
             <a:off x="640080" y="1371600"/>
-            <a:ext cx="6858000" cy="1810512"/>
+            <a:ext cx="6583680" cy="1810512"/>
           </a:xfrm>
           <a:prstGeom prst="rect">
             <a:avLst/>
@@ -9546,7 +9741,30 @@
                   <a:srgbClr val="000000"/>
                 </a:solidFill>
               </a:rPr>
-              <a:t>: при MSE сильно тянет линию — решение: MAE (`HuberRegressor`), робастные методы или чистка</a:t>
+              <a:t>: при MSE сильно тянет линию — одна точка может заметно сдвинуть прямую</a:t>
+            </a:r>
+          </a:p>
+          <a:p>
+            <a:pPr>
+              <a:spcAft>
+                <a:spcPts val="800"/>
+              </a:spcAft>
+            </a:pPr>
+            <a:r>
+              <a:rPr lang="ru-RU" dirty="0" sz="2000" b="1">
+                <a:solidFill>
+                  <a:srgbClr val="000000"/>
+                </a:solidFill>
+              </a:rPr>
+              <a:t>Робастные</a:t>
+            </a:r>
+            <a:r>
+              <a:rPr lang="ru-RU" dirty="0" sz="2000">
+                <a:solidFill>
+                  <a:srgbClr val="000000"/>
+                </a:solidFill>
+              </a:rPr>
+              <a:t xml:space="preserve"> методы (MAE, `HuberRegressor`, RANSAC) меньше реагируют на выбросы, чем MSE</a:t>
             </a:r>
           </a:p>
           <a:p>
@@ -9598,7 +9816,7 @@
                   <a:srgbClr val="000000"/>
                 </a:solidFill>
               </a:rPr>
-              <a:t xml:space="preserve">Всегда стройте scatter «признак vs </a:t>
+              <a:t xml:space="preserve">Перед обучением: scatter «признак vs </a:t>
             </a:r>
             <ns0:m xmlns:ns0="http://schemas.microsoft.com/office/drawing/2010/main">
               <m:oMath xmlns:m="http://schemas.openxmlformats.org/officeDocument/2006/math">
@@ -9613,22 +9831,7 @@
                   <a:srgbClr val="000000"/>
                 </a:solidFill>
               </a:rPr>
-              <a:t>» и boxplot остатков перед обучением</a:t>
-            </a:r>
-          </a:p>
-          <a:p>
-            <a:pPr>
-              <a:spcAft>
-                <a:spcPts val="800"/>
-              </a:spcAft>
-            </a:pPr>
-            <a:r>
-              <a:rPr lang="ru-RU" dirty="0" sz="2000">
-                <a:solidFill>
-                  <a:srgbClr val="000000"/>
-                </a:solidFill>
-              </a:rPr>
-              <a:t>Влиятельные точки диагностируют через остатки и расстояние от центра признаков</a:t>
+              <a:t>» и boxplot остатков</a:t>
             </a:r>
           </a:p>
         </p:txBody>
@@ -9649,8 +9852,8 @@
         </p:blipFill>
         <p:spPr>
           <a:xfrm>
-            <a:off x="7635240" y="1604240"/>
-            <a:ext cx="4343400" cy="1646984"/>
+            <a:off x="7269480" y="1589656"/>
+            <a:ext cx="2487168" cy="1685294"/>
           </a:xfrm>
           <a:prstGeom prst="rect">
             <a:avLst/>
@@ -9673,8 +9876,32 @@
         </p:blipFill>
         <p:spPr>
           <a:xfrm>
-            <a:off x="7635240" y="3881659"/>
-            <a:ext cx="4343400" cy="1645857"/>
+            <a:off x="9811512" y="1927244"/>
+            <a:ext cx="2487168" cy="1010119"/>
+          </a:xfrm>
+          <a:prstGeom prst="rect">
+            <a:avLst/>
+          </a:prstGeom>
+        </p:spPr>
+      </p:pic>
+      <p:pic>
+        <p:nvPicPr>
+          <p:cNvPr id="6" name="Picture 5" descr="outlier_scatter_boxplot.png"/>
+          <p:cNvPicPr>
+            <a:picLocks noChangeAspect="1"/>
+          </p:cNvPicPr>
+          <p:nvPr/>
+        </p:nvPicPr>
+        <p:blipFill>
+          <a:blip r:embed="rId4"/>
+          <a:stretch>
+            <a:fillRect/>
+          </a:stretch>
+        </p:blipFill>
+        <p:spPr>
+          <a:xfrm>
+            <a:off x="7269480" y="3678756"/>
+            <a:ext cx="5029200" cy="2042519"/>
           </a:xfrm>
           <a:prstGeom prst="rect">
             <a:avLst/>
@@ -9741,7 +9968,7 @@
         <p:spPr>
           <a:xfrm>
             <a:off x="640080" y="1371600"/>
-            <a:ext cx="6858000" cy="1810512"/>
+            <a:ext cx="6583680" cy="1810512"/>
           </a:xfrm>
           <a:prstGeom prst="rect">
             <a:avLst/>
@@ -9855,8 +10082,8 @@
         </p:blipFill>
         <p:spPr>
           <a:xfrm>
-            <a:off x="7635240" y="2629149"/>
-            <a:ext cx="4343400" cy="1874021"/>
+            <a:off x="5031801" y="3703320"/>
+            <a:ext cx="6304156" cy="2560320"/>
           </a:xfrm>
           <a:prstGeom prst="rect">
             <a:avLst/>

</xml_diff>

<commit_message>
Improve diagram font size and PPTX placement. (#17)
Raise viz_style minimum fonts and DPI, add FIGSIZE constants, widen
image column and auto wide-band layout for dual-panel PNGs. Regenerate
lineynaya_regressiya assets and rebuild presentation as proof.

Closes #16

Co-authored-by: Cursor <cursoragent@cursor.com>
</commit_message>
<xml_diff>
--- a/lessons/lineynaya_regressiya/presentation.pptx
+++ b/lessons/lineynaya_regressiya/presentation.pptx
@@ -4845,7 +4845,7 @@
         <p:spPr>
           <a:xfrm>
             <a:off x="640080" y="1371600"/>
-            <a:ext cx="6858000" cy="3035807"/>
+            <a:ext cx="6583680" cy="3035807"/>
           </a:xfrm>
           <a:prstGeom prst="rect">
             <a:avLst/>
@@ -4928,7 +4928,7 @@
         <p:spPr>
           <a:xfrm>
             <a:off x="640080" y="4517136"/>
-            <a:ext cx="6766560" cy="978407"/>
+            <a:ext cx="6492240" cy="978407"/>
           </a:xfrm>
           <a:prstGeom prst="rect">
             <a:avLst/>
@@ -4973,7 +4973,7 @@
         <p:spPr>
           <a:xfrm>
             <a:off x="713231" y="4553712"/>
-            <a:ext cx="6620256" cy="905255"/>
+            <a:ext cx="6345936" cy="905255"/>
           </a:xfrm>
           <a:prstGeom prst="rect">
             <a:avLst/>
@@ -5076,7 +5076,7 @@
         <p:spPr>
           <a:xfrm>
             <a:off x="640080" y="5550407"/>
-            <a:ext cx="6766560" cy="201168"/>
+            <a:ext cx="6492240" cy="201168"/>
           </a:xfrm>
           <a:prstGeom prst="rect">
             <a:avLst/>
@@ -5118,8 +5118,8 @@
         </p:blipFill>
         <p:spPr>
           <a:xfrm>
-            <a:off x="7635240" y="2743231"/>
-            <a:ext cx="4343400" cy="1645857"/>
+            <a:off x="5037749" y="3703320"/>
+            <a:ext cx="6292261" cy="2560320"/>
           </a:xfrm>
           <a:prstGeom prst="rect">
             <a:avLst/>
@@ -5186,7 +5186,7 @@
         <p:spPr>
           <a:xfrm>
             <a:off x="640080" y="1371600"/>
-            <a:ext cx="6858000" cy="1810512"/>
+            <a:ext cx="6583680" cy="2194560"/>
           </a:xfrm>
           <a:prstGeom prst="rect">
             <a:avLst/>
@@ -5274,7 +5274,23 @@
                   <a:srgbClr val="000000"/>
                 </a:solidFill>
               </a:rPr>
-              <a:t xml:space="preserve"> — сжимает веса, помогает при мультиколлинеарности</a:t>
+              <a:t xml:space="preserve"> — сжимает веса </a:t>
+            </a:r>
+            <a:r>
+              <a:rPr lang="ru-RU" dirty="0" sz="2000" b="1">
+                <a:solidFill>
+                  <a:srgbClr val="000000"/>
+                </a:solidFill>
+              </a:rPr>
+              <a:t>вместе</a:t>
+            </a:r>
+            <a:r>
+              <a:rPr lang="ru-RU" dirty="0" sz="2000">
+                <a:solidFill>
+                  <a:srgbClr val="000000"/>
+                </a:solidFill>
+              </a:rPr>
+              <a:t>, не обнуляя; стабилизирует при мультиколлинеарности</a:t>
             </a:r>
           </a:p>
           <a:p>
@@ -5339,7 +5355,38 @@
                   <a:srgbClr val="000000"/>
                 </a:solidFill>
               </a:rPr>
-              <a:t xml:space="preserve"> — может обнулять веса → отбор признаков</a:t>
+              <a:t xml:space="preserve"> — обнуляет слабые признаки → отбор фич, но не лечит дублирующие столбцы</a:t>
+            </a:r>
+          </a:p>
+          <a:p>
+            <a:pPr>
+              <a:spcAft>
+                <a:spcPts val="800"/>
+              </a:spcAft>
+            </a:pPr>
+            <a:r>
+              <a:rPr lang="ru-RU" dirty="0" sz="2000">
+                <a:solidFill>
+                  <a:srgbClr val="000000"/>
+                </a:solidFill>
+              </a:rPr>
+              <a:t xml:space="preserve">При коррелированных признаках предпочтите </a:t>
+            </a:r>
+            <a:r>
+              <a:rPr lang="ru-RU" dirty="0" sz="2000" b="1">
+                <a:solidFill>
+                  <a:srgbClr val="000000"/>
+                </a:solidFill>
+              </a:rPr>
+              <a:t>Ridge</a:t>
+            </a:r>
+            <a:r>
+              <a:rPr lang="ru-RU" dirty="0" sz="2000">
+                <a:solidFill>
+                  <a:srgbClr val="000000"/>
+                </a:solidFill>
+              </a:rPr>
+              <a:t>; Lasso выберет один из дублей случайно</a:t>
             </a:r>
           </a:p>
           <a:p>
@@ -5369,7 +5416,7 @@
                   <a:srgbClr val="000000"/>
                 </a:solidFill>
               </a:rPr>
-              <a:t xml:space="preserve"> подбирают по validation / cross-validation</a:t>
+              <a:t xml:space="preserve"> подбирают по validation / cross-validation (см. график)</a:t>
             </a:r>
           </a:p>
         </p:txBody>
@@ -5390,8 +5437,32 @@
         </p:blipFill>
         <p:spPr>
           <a:xfrm>
-            <a:off x="7635240" y="2585197"/>
-            <a:ext cx="4343400" cy="1961925"/>
+            <a:off x="7269480" y="1359615"/>
+            <a:ext cx="5029200" cy="2145377"/>
+          </a:xfrm>
+          <a:prstGeom prst="rect">
+            <a:avLst/>
+          </a:prstGeom>
+        </p:spPr>
+      </p:pic>
+      <p:pic>
+        <p:nvPicPr>
+          <p:cNvPr id="5" name="Picture 4" descr="ridge_alpha_cv.png"/>
+          <p:cNvPicPr>
+            <a:picLocks noChangeAspect="1"/>
+          </p:cNvPicPr>
+          <p:nvPr/>
+        </p:nvPicPr>
+        <p:blipFill>
+          <a:blip r:embed="rId3"/>
+          <a:stretch>
+            <a:fillRect/>
+          </a:stretch>
+        </p:blipFill>
+        <p:spPr>
+          <a:xfrm>
+            <a:off x="8231517" y="3593592"/>
+            <a:ext cx="3105125" cy="2212848"/>
           </a:xfrm>
           <a:prstGeom prst="rect">
             <a:avLst/>
@@ -5458,7 +5529,7 @@
         <p:spPr>
           <a:xfrm>
             <a:off x="640080" y="1371600"/>
-            <a:ext cx="6858000" cy="3209544"/>
+            <a:ext cx="6583680" cy="3035807"/>
           </a:xfrm>
           <a:prstGeom prst="rect">
             <a:avLst/>
@@ -5643,8 +5714,8 @@
         </p:nvSpPr>
         <p:spPr>
           <a:xfrm>
-            <a:off x="640080" y="4690872"/>
-            <a:ext cx="6766560" cy="804672"/>
+            <a:off x="640080" y="4517136"/>
+            <a:ext cx="6492240" cy="978407"/>
           </a:xfrm>
           <a:prstGeom prst="rect">
             <a:avLst/>
@@ -5688,8 +5759,8 @@
         </p:nvSpPr>
         <p:spPr>
           <a:xfrm>
-            <a:off x="713231" y="4727448"/>
-            <a:ext cx="6620256" cy="731520"/>
+            <a:off x="713231" y="4553712"/>
+            <a:ext cx="6345936" cy="905255"/>
           </a:xfrm>
           <a:prstGeom prst="rect">
             <a:avLst/>
@@ -5714,7 +5785,7 @@
                 </a:solidFill>
                 <a:latin typeface="Consolas"/>
               </a:rPr>
-              <a:t>from sklearn.metrics import mean_absolute_error, r2_score</a:t>
+              <a:t>from sklearn.metrics import mean_absolute_error, mean_squared_error, r2_score</a:t>
             </a:r>
           </a:p>
           <a:p>
@@ -5746,7 +5817,7 @@
                 </a:solidFill>
                 <a:latin typeface="Consolas"/>
               </a:rPr>
-              <a:t>r2 = r2_score(y_te, y_pred)</a:t>
+              <a:t>rmse = mean_squared_error(y_te, y_pred, squared=False)</a:t>
             </a:r>
           </a:p>
           <a:p>
@@ -5762,7 +5833,23 @@
                 </a:solidFill>
                 <a:latin typeface="Consolas"/>
               </a:rPr>
-              <a:t>print(f'MAE={mae:.2f}, R²={r2:.3f}')</a:t>
+              <a:t>r2 = r2_score(y_te, y_pred)</a:t>
+            </a:r>
+          </a:p>
+          <a:p>
+            <a:pPr>
+              <a:spcAft>
+                <a:spcPts val="0"/>
+              </a:spcAft>
+            </a:pPr>
+            <a:r>
+              <a:rPr sz="1100">
+                <a:solidFill>
+                  <a:srgbClr val="000000"/>
+                </a:solidFill>
+                <a:latin typeface="Consolas"/>
+              </a:rPr>
+              <a:t>print(f'MAE={mae:.2f}, RMSE={rmse:.2f}, R²={r2:.3f}')</a:t>
             </a:r>
           </a:p>
         </p:txBody>
@@ -5775,8 +5862,8 @@
         </p:nvSpPr>
         <p:spPr>
           <a:xfrm>
-            <a:off x="640080" y="5550408"/>
-            <a:ext cx="6766560" cy="201168"/>
+            <a:off x="640080" y="5550407"/>
+            <a:ext cx="6492240" cy="201168"/>
           </a:xfrm>
           <a:prstGeom prst="rect">
             <a:avLst/>
@@ -5797,7 +5884,7 @@
               </a:defRPr>
             </a:pPr>
             <a:r>
-              <a:t>MAE и R²</a:t>
+              <a:t>MAE, RMSE и R²</a:t>
             </a:r>
           </a:p>
         </p:txBody>
@@ -5818,8 +5905,8 @@
         </p:blipFill>
         <p:spPr>
           <a:xfrm>
-            <a:off x="7635240" y="2073874"/>
-            <a:ext cx="4343400" cy="2984571"/>
+            <a:off x="7269480" y="1774146"/>
+            <a:ext cx="5029200" cy="3584028"/>
           </a:xfrm>
           <a:prstGeom prst="rect">
             <a:avLst/>
@@ -5886,7 +5973,7 @@
         <p:spPr>
           <a:xfrm>
             <a:off x="640080" y="1371600"/>
-            <a:ext cx="6858000" cy="1810512"/>
+            <a:ext cx="6583680" cy="1810512"/>
           </a:xfrm>
           <a:prstGeom prst="rect">
             <a:avLst/>
@@ -6030,8 +6117,8 @@
         </p:blipFill>
         <p:spPr>
           <a:xfrm>
-            <a:off x="7635240" y="2758695"/>
-            <a:ext cx="4343400" cy="1614929"/>
+            <a:off x="4572000" y="3731449"/>
+            <a:ext cx="7223760" cy="2504062"/>
           </a:xfrm>
           <a:prstGeom prst="rect">
             <a:avLst/>
@@ -6098,7 +6185,7 @@
         <p:spPr>
           <a:xfrm>
             <a:off x="640080" y="1371600"/>
-            <a:ext cx="6858000" cy="1810512"/>
+            <a:ext cx="6583680" cy="1810512"/>
           </a:xfrm>
           <a:prstGeom prst="rect">
             <a:avLst/>
@@ -6252,8 +6339,8 @@
         </p:blipFill>
         <p:spPr>
           <a:xfrm>
-            <a:off x="7635240" y="2073874"/>
-            <a:ext cx="4343400" cy="2984571"/>
+            <a:off x="7269480" y="1789462"/>
+            <a:ext cx="5029200" cy="3553395"/>
           </a:xfrm>
           <a:prstGeom prst="rect">
             <a:avLst/>
@@ -6320,7 +6407,7 @@
         <p:spPr>
           <a:xfrm>
             <a:off x="640080" y="1371600"/>
-            <a:ext cx="6858000" cy="2514599"/>
+            <a:ext cx="6583680" cy="2514599"/>
           </a:xfrm>
           <a:prstGeom prst="rect">
             <a:avLst/>
@@ -6419,7 +6506,7 @@
         <p:spPr>
           <a:xfrm>
             <a:off x="640080" y="3995927"/>
-            <a:ext cx="6766560" cy="1499616"/>
+            <a:ext cx="6492240" cy="1499616"/>
           </a:xfrm>
           <a:prstGeom prst="rect">
             <a:avLst/>
@@ -6464,7 +6551,7 @@
         <p:spPr>
           <a:xfrm>
             <a:off x="713231" y="4032503"/>
-            <a:ext cx="6620256" cy="1426464"/>
+            <a:ext cx="6345936" cy="1426464"/>
           </a:xfrm>
           <a:prstGeom prst="rect">
             <a:avLst/>
@@ -6615,7 +6702,7 @@
         <p:spPr>
           <a:xfrm>
             <a:off x="640080" y="5550407"/>
-            <a:ext cx="6766560" cy="201168"/>
+            <a:ext cx="6492240" cy="201168"/>
           </a:xfrm>
           <a:prstGeom prst="rect">
             <a:avLst/>
@@ -6657,8 +6744,8 @@
         </p:blipFill>
         <p:spPr>
           <a:xfrm>
-            <a:off x="7635240" y="2857963"/>
-            <a:ext cx="4343400" cy="1416392"/>
+            <a:off x="4627306" y="3703320"/>
+            <a:ext cx="7113147" cy="2560320"/>
           </a:xfrm>
           <a:prstGeom prst="rect">
             <a:avLst/>
@@ -6725,7 +6812,7 @@
         <p:spPr>
           <a:xfrm>
             <a:off x="640080" y="1371600"/>
-            <a:ext cx="6858000" cy="1810512"/>
+            <a:ext cx="6583680" cy="1810512"/>
           </a:xfrm>
           <a:prstGeom prst="rect">
             <a:avLst/>
@@ -6764,7 +6851,7 @@
                   <a:srgbClr val="000000"/>
                 </a:solidFill>
               </a:rPr>
-              <a:t>Сильное взаимодействие признаков без явных фичей (</a:t>
+              <a:t xml:space="preserve">Эффект одного признака зависит от другого, но в модели нет произведения </a:t>
             </a:r>
             <ns0:m xmlns:ns0="http://schemas.microsoft.com/office/drawing/2010/main">
               <m:oMath xmlns:m="http://schemas.openxmlformats.org/officeDocument/2006/math">
@@ -6803,7 +6890,7 @@
                   <a:srgbClr val="000000"/>
                 </a:solidFill>
               </a:rPr>
-              <a:t>)</a:t>
+              <a:t xml:space="preserve"> — линейная формула это не описывает</a:t>
             </a:r>
           </a:p>
           <a:p>
@@ -6869,8 +6956,8 @@
         </p:blipFill>
         <p:spPr>
           <a:xfrm>
-            <a:off x="7635240" y="2739840"/>
-            <a:ext cx="4343400" cy="1652640"/>
+            <a:off x="5103169" y="3703320"/>
+            <a:ext cx="6161420" cy="2560320"/>
           </a:xfrm>
           <a:prstGeom prst="rect">
             <a:avLst/>
@@ -7170,7 +7257,7 @@
                 </a:solidFill>
                 <a:hlinkClick r:id="rId2"/>
               </a:rPr>
-              <a:t>Hoerl A.E., Kennard R.W. (1970). Ridge Regression: Biased Estimation for Nonorthogonal Problems</a:t>
+              <a:t>Markov A.A. (1900). Least Squares Estimation of Linear Models</a:t>
             </a:r>
           </a:p>
         </p:txBody>
@@ -7217,7 +7304,7 @@
                 </a:solidFill>
                 <a:hlinkClick r:id="rId3"/>
               </a:rPr>
-              <a:t>Tibshirani R. (1996). Regression Shrinkage and Selection via the Lasso</a:t>
+              <a:t>Hoerl A.E., Kennard R.W. (1970). Ridge Regression: Biased Estimation for Nonorthogonal Problems</a:t>
             </a:r>
           </a:p>
         </p:txBody>
@@ -7264,7 +7351,7 @@
                 </a:solidFill>
                 <a:hlinkClick r:id="rId4"/>
               </a:rPr>
-              <a:t>Markov A.A. (1900). Least Squares Estimation of Linear Models</a:t>
+              <a:t>Tibshirani R. (1996). Regression Shrinkage and Selection via the Lasso</a:t>
             </a:r>
           </a:p>
         </p:txBody>
@@ -7566,7 +7653,7 @@
         <p:spPr>
           <a:xfrm>
             <a:off x="640080" y="1371600"/>
-            <a:ext cx="6858000" cy="1810512"/>
+            <a:ext cx="6583680" cy="1810512"/>
           </a:xfrm>
           <a:prstGeom prst="rect">
             <a:avLst/>
@@ -7701,8 +7788,8 @@
         </p:blipFill>
         <p:spPr>
           <a:xfrm>
-            <a:off x="7635240" y="2075955"/>
-            <a:ext cx="4343400" cy="2980408"/>
+            <a:off x="7269480" y="1774146"/>
+            <a:ext cx="5029200" cy="3584028"/>
           </a:xfrm>
           <a:prstGeom prst="rect">
             <a:avLst/>
@@ -7769,7 +7856,7 @@
         <p:spPr>
           <a:xfrm>
             <a:off x="640080" y="1371600"/>
-            <a:ext cx="6858000" cy="1810512"/>
+            <a:ext cx="6583680" cy="1810512"/>
           </a:xfrm>
           <a:prstGeom prst="rect">
             <a:avLst/>
@@ -7895,12 +7982,65 @@
               </a:spcAft>
             </a:pPr>
             <a:r>
+              <a:rPr lang="ru-RU" dirty="0" sz="2000" b="1">
+                <a:solidFill>
+                  <a:srgbClr val="000000"/>
+                </a:solidFill>
+              </a:rPr>
+              <a:t>Intercept</a:t>
+            </a:r>
+            <a:r>
               <a:rPr lang="ru-RU" dirty="0" sz="2000">
                 <a:solidFill>
                   <a:srgbClr val="000000"/>
                 </a:solidFill>
               </a:rPr>
-              <a:t>Хорошая модель: остатки симметрично разбросаны вокруг нуля, без систематического смещения</a:t>
+              <a:t xml:space="preserve"> (</a:t>
+            </a:r>
+            <ns0:m xmlns:ns0="http://schemas.microsoft.com/office/drawing/2010/main">
+              <m:oMath xmlns:m="http://schemas.openxmlformats.org/officeDocument/2006/math">
+                <m:r>
+                  <m:t>b</m:t>
+                </m:r>
+              </m:oMath>
+            </ns0:m>
+            <a:r>
+              <a:rPr lang="ru-RU" dirty="0" sz="2000">
+                <a:solidFill>
+                  <a:srgbClr val="000000"/>
+                </a:solidFill>
+              </a:rPr>
+              <a:t xml:space="preserve">): прогноз при </a:t>
+            </a:r>
+            <ns0:m xmlns:ns0="http://schemas.microsoft.com/office/drawing/2010/main">
+              <m:oMath xmlns:m="http://schemas.openxmlformats.org/officeDocument/2006/math">
+                <m:r>
+                  <m:t>x=0</m:t>
+                </m:r>
+              </m:oMath>
+            </ns0:m>
+            <a:r>
+              <a:rPr lang="ru-RU" dirty="0" sz="2000">
+                <a:solidFill>
+                  <a:srgbClr val="000000"/>
+                </a:solidFill>
+              </a:rPr>
+              <a:t xml:space="preserve">; в sklearn — параметр `fit_intercept=True` (смещение прямой по оси </a:t>
+            </a:r>
+            <ns0:m xmlns:ns0="http://schemas.microsoft.com/office/drawing/2010/main">
+              <m:oMath xmlns:m="http://schemas.openxmlformats.org/officeDocument/2006/math">
+                <m:r>
+                  <m:t>y</m:t>
+                </m:r>
+              </m:oMath>
+            </ns0:m>
+            <a:r>
+              <a:rPr lang="ru-RU" dirty="0" sz="2000">
+                <a:solidFill>
+                  <a:srgbClr val="000000"/>
+                </a:solidFill>
+              </a:rPr>
+              <a:t>)</a:t>
             </a:r>
           </a:p>
           <a:p>
@@ -7915,7 +8055,7 @@
                   <a:srgbClr val="000000"/>
                 </a:solidFill>
               </a:rPr>
-              <a:t>Сумма остатков на обучающей выборке при МНК равна нулю (для модели с intercept)</a:t>
+              <a:t>Хорошая модель: остатки симметрично разбросаны вокруг нуля, без систематического смещения</a:t>
             </a:r>
           </a:p>
         </p:txBody>
@@ -7936,8 +8076,8 @@
         </p:blipFill>
         <p:spPr>
           <a:xfrm>
-            <a:off x="8201192" y="1325880"/>
-            <a:ext cx="3211495" cy="2203704"/>
+            <a:off x="8231517" y="1325880"/>
+            <a:ext cx="3105125" cy="2212848"/>
           </a:xfrm>
           <a:prstGeom prst="rect">
             <a:avLst/>
@@ -7960,8 +8100,8 @@
         </p:blipFill>
         <p:spPr>
           <a:xfrm>
-            <a:off x="8203431" y="3602735"/>
-            <a:ext cx="3207016" cy="2203704"/>
+            <a:off x="8231517" y="3593592"/>
+            <a:ext cx="3105125" cy="2212848"/>
           </a:xfrm>
           <a:prstGeom prst="rect">
             <a:avLst/>
@@ -8028,7 +8168,7 @@
         <p:spPr>
           <a:xfrm>
             <a:off x="640080" y="1371600"/>
-            <a:ext cx="6858000" cy="2194560"/>
+            <a:ext cx="6583680" cy="2194560"/>
           </a:xfrm>
           <a:prstGeom prst="rect">
             <a:avLst/>
@@ -8160,7 +8300,85 @@
                   <a:srgbClr val="000000"/>
                 </a:solidFill>
               </a:rPr>
-              <a:t xml:space="preserve">Сумму без деления на </a:t>
+              <a:t xml:space="preserve">Минимизация </a:t>
+            </a:r>
+            <ns0:m xmlns:ns0="http://schemas.microsoft.com/office/drawing/2010/main">
+              <m:oMath xmlns:m="http://schemas.openxmlformats.org/officeDocument/2006/math">
+                <m:nary>
+                  <m:naryPr>
+                    <m:chr m:val="∑"/>
+                    <m:limLoc m:val="subSup"/>
+                    <m:grow m:val="1"/>
+                    <m:subHide m:val="off"/>
+                    <m:supHide m:val="on"/>
+                  </m:naryPr>
+                  <m:sub>
+                    <m:r>
+                      <m:t>i</m:t>
+                    </m:r>
+                  </m:sub>
+                  <m:sup/>
+                  <m:e>
+                    <m:r>
+                      <m:t>(</m:t>
+                    </m:r>
+                  </m:e>
+                </m:nary>
+                <m:sSub>
+                  <m:e>
+                    <m:r>
+                      <m:t>y</m:t>
+                    </m:r>
+                  </m:e>
+                  <m:sub>
+                    <m:r>
+                      <m:t>i</m:t>
+                    </m:r>
+                  </m:sub>
+                </m:sSub>
+                <m:r>
+                  <m:t>−</m:t>
+                </m:r>
+                <m:sSub>
+                  <m:e>
+                    <m:acc>
+                      <m:accPr>
+                        <m:chr m:val="̂"/>
+                      </m:accPr>
+                      <m:e>
+                        <m:r>
+                          <m:t>y</m:t>
+                        </m:r>
+                      </m:e>
+                    </m:acc>
+                  </m:e>
+                  <m:sub>
+                    <m:r>
+                      <m:t>i</m:t>
+                    </m:r>
+                  </m:sub>
+                </m:sSub>
+                <m:sSup>
+                  <m:e>
+                    <m:r>
+                      <m:t>)</m:t>
+                    </m:r>
+                  </m:e>
+                  <m:sup>
+                    <m:r>
+                      <m:t>2</m:t>
+                    </m:r>
+                  </m:sup>
+                </m:sSup>
+              </m:oMath>
+            </ns0:m>
+            <a:r>
+              <a:rPr lang="ru-RU" dirty="0" sz="2000">
+                <a:solidFill>
+                  <a:srgbClr val="000000"/>
+                </a:solidFill>
+              </a:rPr>
+              <a:t xml:space="preserve"> без деления на </a:t>
             </a:r>
             <ns0:m xmlns:ns0="http://schemas.microsoft.com/office/drawing/2010/main">
               <m:oMath xmlns:m="http://schemas.openxmlformats.org/officeDocument/2006/math">
@@ -8175,7 +8393,22 @@
                   <a:srgbClr val="000000"/>
                 </a:solidFill>
               </a:rPr>
-              <a:t xml:space="preserve"> минимизировать то же самое; деление нужно для сравнимости между выборками</a:t>
+              <a:t xml:space="preserve"> даёт те же оптимальные веса; деление на </a:t>
+            </a:r>
+            <ns0:m xmlns:ns0="http://schemas.microsoft.com/office/drawing/2010/main">
+              <m:oMath xmlns:m="http://schemas.openxmlformats.org/officeDocument/2006/math">
+                <m:r>
+                  <m:t>N</m:t>
+                </m:r>
+              </m:oMath>
+            </ns0:m>
+            <a:r>
+              <a:rPr lang="ru-RU" dirty="0" sz="2000">
+                <a:solidFill>
+                  <a:srgbClr val="000000"/>
+                </a:solidFill>
+              </a:rPr>
+              <a:t xml:space="preserve"> нужно для сравнимости между выборками</a:t>
             </a:r>
           </a:p>
           <a:p>
@@ -8287,7 +8520,7 @@
                   <a:srgbClr val="000000"/>
                 </a:solidFill>
               </a:rPr>
-              <a:t>MSE = MLE при гауссовских остатках; MAE = MLE при распределении Лапласа (например, медианный шум в задачах с редкими сбоями)</a:t>
+              <a:t>MSE = MLE при нормальных остатках; MAE = MLE, если ошибки распределены по Лапласу (редкие, но крупные сбои — например, катастрофические задержки доставки)</a:t>
             </a:r>
           </a:p>
         </p:txBody>
@@ -8308,8 +8541,8 @@
         </p:blipFill>
         <p:spPr>
           <a:xfrm>
-            <a:off x="7635240" y="2076907"/>
-            <a:ext cx="4343400" cy="2978505"/>
+            <a:off x="7269480" y="1791148"/>
+            <a:ext cx="5029200" cy="3550024"/>
           </a:xfrm>
           <a:prstGeom prst="rect">
             <a:avLst/>
@@ -8376,7 +8609,7 @@
         <p:spPr>
           <a:xfrm>
             <a:off x="640080" y="1371600"/>
-            <a:ext cx="6858000" cy="3209544"/>
+            <a:ext cx="6583680" cy="3383279"/>
           </a:xfrm>
           <a:prstGeom prst="rect">
             <a:avLst/>
@@ -8400,7 +8633,7 @@
                   <a:srgbClr val="000000"/>
                 </a:solidFill>
               </a:rPr>
-              <a:t xml:space="preserve">Аналитическое решение (МНК): производная по весам → система линейных уравнений → </a:t>
+              <a:t xml:space="preserve">Аналитическое решение (МНК): </a:t>
             </a:r>
             <ns0:m xmlns:ns0="http://schemas.microsoft.com/office/drawing/2010/main">
               <m:oMath xmlns:m="http://schemas.openxmlformats.org/officeDocument/2006/math">
@@ -8461,6 +8694,14 @@
                 </m:r>
               </m:oMath>
             </ns0:m>
+            <a:r>
+              <a:rPr lang="ru-RU" dirty="0" sz="2000">
+                <a:solidFill>
+                  <a:srgbClr val="000000"/>
+                </a:solidFill>
+              </a:rPr>
+              <a:t xml:space="preserve"> — быстро для умеренных матриц</a:t>
+            </a:r>
           </a:p>
           <a:p>
             <a:pPr>
@@ -8474,7 +8715,7 @@
                   <a:srgbClr val="000000"/>
                 </a:solidFill>
               </a:rPr>
-              <a:t>`LinearRegression` в sklearn по умолчанию решает так (solver `linalg`) — быстро и точно для умеренных матриц</a:t>
+              <a:t>`LinearRegression` в sklearn использует solver `linalg` без итераций</a:t>
             </a:r>
           </a:p>
           <a:p>
@@ -8489,22 +8730,7 @@
                   <a:srgbClr val="000000"/>
                 </a:solidFill>
               </a:rPr>
-              <a:t xml:space="preserve">При очень больших </a:t>
-            </a:r>
-            <ns0:m xmlns:ns0="http://schemas.microsoft.com/office/drawing/2010/main">
-              <m:oMath xmlns:m="http://schemas.openxmlformats.org/officeDocument/2006/math">
-                <m:r>
-                  <m:t>X</m:t>
-                </m:r>
-              </m:oMath>
-            </ns0:m>
-            <a:r>
-              <a:rPr lang="ru-RU" dirty="0" sz="2000">
-                <a:solidFill>
-                  <a:srgbClr val="000000"/>
-                </a:solidFill>
-              </a:rPr>
-              <a:t xml:space="preserve"> или нехватке памяти — итеративные методы: SGD, `sag`, `lsqr`</a:t>
+              <a:t>При огромных данных — итеративные методы: SGD, `SGDRegressor`</a:t>
             </a:r>
           </a:p>
           <a:p>
@@ -8519,22 +8745,7 @@
                   <a:srgbClr val="000000"/>
                 </a:solidFill>
               </a:rPr>
-              <a:t>Градиентный спуск: шаг против градиента функции потерь; `SGDRegressor` в sklearn</a:t>
-            </a:r>
-          </a:p>
-          <a:p>
-            <a:pPr>
-              <a:spcAft>
-                <a:spcPts val="800"/>
-              </a:spcAft>
-            </a:pPr>
-            <a:r>
-              <a:rPr lang="ru-RU" dirty="0" sz="2000">
-                <a:solidFill>
-                  <a:srgbClr val="000000"/>
-                </a:solidFill>
-              </a:rPr>
-              <a:t>На практике для линейной регрессии чаще используют не «чистый» SGD, а стабильные solver'ы (`lbfgs`, `sag` в Ridge/Lasso)</a:t>
+              <a:t>Градиентный спуск: шаг против градиента функции потерь</a:t>
             </a:r>
           </a:p>
         </p:txBody>
@@ -8547,8 +8758,8 @@
         </p:nvSpPr>
         <p:spPr>
           <a:xfrm>
-            <a:off x="640080" y="4690872"/>
-            <a:ext cx="6766560" cy="804672"/>
+            <a:off x="640080" y="4864607"/>
+            <a:ext cx="6492240" cy="630936"/>
           </a:xfrm>
           <a:prstGeom prst="rect">
             <a:avLst/>
@@ -8592,8 +8803,8 @@
         </p:nvSpPr>
         <p:spPr>
           <a:xfrm>
-            <a:off x="713231" y="4727448"/>
-            <a:ext cx="6620256" cy="731520"/>
+            <a:off x="713231" y="4901183"/>
+            <a:ext cx="6345936" cy="557784"/>
           </a:xfrm>
           <a:prstGeom prst="rect">
             <a:avLst/>
@@ -8634,7 +8845,7 @@
                 </a:solidFill>
                 <a:latin typeface="Consolas"/>
               </a:rPr>
-              <a:t>model = LinearRegression()  # solver='linalg' по умолчанию</a:t>
+              <a:t>model = LinearRegression().fit(X_train, y_train)</a:t>
             </a:r>
           </a:p>
           <a:p>
@@ -8650,22 +8861,6 @@
                 </a:solidFill>
                 <a:latin typeface="Consolas"/>
               </a:rPr>
-              <a:t>model.fit(X_train, y_train)</a:t>
-            </a:r>
-          </a:p>
-          <a:p>
-            <a:pPr>
-              <a:spcAft>
-                <a:spcPts val="0"/>
-              </a:spcAft>
-            </a:pPr>
-            <a:r>
-              <a:rPr sz="1100">
-                <a:solidFill>
-                  <a:srgbClr val="000000"/>
-                </a:solidFill>
-                <a:latin typeface="Consolas"/>
-              </a:rPr>
               <a:t>y_pred = model.predict(X_test)</a:t>
             </a:r>
           </a:p>
@@ -8679,8 +8874,8 @@
         </p:nvSpPr>
         <p:spPr>
           <a:xfrm>
-            <a:off x="640080" y="5550408"/>
-            <a:ext cx="6766560" cy="201168"/>
+            <a:off x="640080" y="5550407"/>
+            <a:ext cx="6492240" cy="201168"/>
           </a:xfrm>
           <a:prstGeom prst="rect">
             <a:avLst/>
@@ -8722,8 +8917,8 @@
         </p:blipFill>
         <p:spPr>
           <a:xfrm>
-            <a:off x="7635240" y="2073874"/>
-            <a:ext cx="4343400" cy="2984571"/>
+            <a:off x="7269480" y="1774146"/>
+            <a:ext cx="5029200" cy="3584028"/>
           </a:xfrm>
           <a:prstGeom prst="rect">
             <a:avLst/>
@@ -8790,7 +8985,7 @@
         <p:spPr>
           <a:xfrm>
             <a:off x="640080" y="1371600"/>
-            <a:ext cx="6858000" cy="1810512"/>
+            <a:ext cx="6583680" cy="1810512"/>
           </a:xfrm>
           <a:prstGeom prst="rect">
             <a:avLst/>
@@ -9019,8 +9214,8 @@
         </p:blipFill>
         <p:spPr>
           <a:xfrm>
-            <a:off x="7668306" y="1325880"/>
-            <a:ext cx="4277267" cy="4480559"/>
+            <a:off x="7632338" y="1325880"/>
+            <a:ext cx="4303483" cy="4480559"/>
           </a:xfrm>
           <a:prstGeom prst="rect">
             <a:avLst/>
@@ -9087,7 +9282,7 @@
         <p:spPr>
           <a:xfrm>
             <a:off x="640080" y="1371600"/>
-            <a:ext cx="6858000" cy="2688335"/>
+            <a:ext cx="6583680" cy="2688335"/>
           </a:xfrm>
           <a:prstGeom prst="rect">
             <a:avLst/>
@@ -9217,7 +9412,7 @@
         <p:spPr>
           <a:xfrm>
             <a:off x="640080" y="4169663"/>
-            <a:ext cx="6766560" cy="1325880"/>
+            <a:ext cx="6492240" cy="1325880"/>
           </a:xfrm>
           <a:prstGeom prst="rect">
             <a:avLst/>
@@ -9262,7 +9457,7 @@
         <p:spPr>
           <a:xfrm>
             <a:off x="713231" y="4206240"/>
-            <a:ext cx="6620256" cy="1252728"/>
+            <a:ext cx="6345936" cy="1252728"/>
           </a:xfrm>
           <a:prstGeom prst="rect">
             <a:avLst/>
@@ -9397,7 +9592,7 @@
         <p:spPr>
           <a:xfrm>
             <a:off x="640080" y="5550408"/>
-            <a:ext cx="6766560" cy="201168"/>
+            <a:ext cx="6492240" cy="201168"/>
           </a:xfrm>
           <a:prstGeom prst="rect">
             <a:avLst/>
@@ -9439,8 +9634,8 @@
         </p:blipFill>
         <p:spPr>
           <a:xfrm>
-            <a:off x="7635240" y="2727162"/>
-            <a:ext cx="4343400" cy="1677994"/>
+            <a:off x="5031801" y="3703320"/>
+            <a:ext cx="6304156" cy="2560320"/>
           </a:xfrm>
           <a:prstGeom prst="rect">
             <a:avLst/>
@@ -9507,7 +9702,7 @@
         <p:spPr>
           <a:xfrm>
             <a:off x="640080" y="1371600"/>
-            <a:ext cx="6858000" cy="1810512"/>
+            <a:ext cx="6583680" cy="1810512"/>
           </a:xfrm>
           <a:prstGeom prst="rect">
             <a:avLst/>
@@ -9546,7 +9741,30 @@
                   <a:srgbClr val="000000"/>
                 </a:solidFill>
               </a:rPr>
-              <a:t>: при MSE сильно тянет линию — решение: MAE (`HuberRegressor`), робастные методы или чистка</a:t>
+              <a:t>: при MSE сильно тянет линию — одна точка может заметно сдвинуть прямую</a:t>
+            </a:r>
+          </a:p>
+          <a:p>
+            <a:pPr>
+              <a:spcAft>
+                <a:spcPts val="800"/>
+              </a:spcAft>
+            </a:pPr>
+            <a:r>
+              <a:rPr lang="ru-RU" dirty="0" sz="2000" b="1">
+                <a:solidFill>
+                  <a:srgbClr val="000000"/>
+                </a:solidFill>
+              </a:rPr>
+              <a:t>Робастные</a:t>
+            </a:r>
+            <a:r>
+              <a:rPr lang="ru-RU" dirty="0" sz="2000">
+                <a:solidFill>
+                  <a:srgbClr val="000000"/>
+                </a:solidFill>
+              </a:rPr>
+              <a:t xml:space="preserve"> методы (MAE, `HuberRegressor`, RANSAC) меньше реагируют на выбросы, чем MSE</a:t>
             </a:r>
           </a:p>
           <a:p>
@@ -9598,7 +9816,7 @@
                   <a:srgbClr val="000000"/>
                 </a:solidFill>
               </a:rPr>
-              <a:t xml:space="preserve">Всегда стройте scatter «признак vs </a:t>
+              <a:t xml:space="preserve">Перед обучением: scatter «признак vs </a:t>
             </a:r>
             <ns0:m xmlns:ns0="http://schemas.microsoft.com/office/drawing/2010/main">
               <m:oMath xmlns:m="http://schemas.openxmlformats.org/officeDocument/2006/math">
@@ -9613,22 +9831,7 @@
                   <a:srgbClr val="000000"/>
                 </a:solidFill>
               </a:rPr>
-              <a:t>» и boxplot остатков перед обучением</a:t>
-            </a:r>
-          </a:p>
-          <a:p>
-            <a:pPr>
-              <a:spcAft>
-                <a:spcPts val="800"/>
-              </a:spcAft>
-            </a:pPr>
-            <a:r>
-              <a:rPr lang="ru-RU" dirty="0" sz="2000">
-                <a:solidFill>
-                  <a:srgbClr val="000000"/>
-                </a:solidFill>
-              </a:rPr>
-              <a:t>Влиятельные точки диагностируют через остатки и расстояние от центра признаков</a:t>
+              <a:t>» и boxplot остатков</a:t>
             </a:r>
           </a:p>
         </p:txBody>
@@ -9649,8 +9852,8 @@
         </p:blipFill>
         <p:spPr>
           <a:xfrm>
-            <a:off x="7635240" y="1604240"/>
-            <a:ext cx="4343400" cy="1646984"/>
+            <a:off x="7269480" y="1589656"/>
+            <a:ext cx="2487168" cy="1685294"/>
           </a:xfrm>
           <a:prstGeom prst="rect">
             <a:avLst/>
@@ -9673,8 +9876,32 @@
         </p:blipFill>
         <p:spPr>
           <a:xfrm>
-            <a:off x="7635240" y="3881659"/>
-            <a:ext cx="4343400" cy="1645857"/>
+            <a:off x="9811512" y="1927244"/>
+            <a:ext cx="2487168" cy="1010119"/>
+          </a:xfrm>
+          <a:prstGeom prst="rect">
+            <a:avLst/>
+          </a:prstGeom>
+        </p:spPr>
+      </p:pic>
+      <p:pic>
+        <p:nvPicPr>
+          <p:cNvPr id="6" name="Picture 5" descr="outlier_scatter_boxplot.png"/>
+          <p:cNvPicPr>
+            <a:picLocks noChangeAspect="1"/>
+          </p:cNvPicPr>
+          <p:nvPr/>
+        </p:nvPicPr>
+        <p:blipFill>
+          <a:blip r:embed="rId4"/>
+          <a:stretch>
+            <a:fillRect/>
+          </a:stretch>
+        </p:blipFill>
+        <p:spPr>
+          <a:xfrm>
+            <a:off x="7269480" y="3678756"/>
+            <a:ext cx="5029200" cy="2042519"/>
           </a:xfrm>
           <a:prstGeom prst="rect">
             <a:avLst/>
@@ -9741,7 +9968,7 @@
         <p:spPr>
           <a:xfrm>
             <a:off x="640080" y="1371600"/>
-            <a:ext cx="6858000" cy="1810512"/>
+            <a:ext cx="6583680" cy="1810512"/>
           </a:xfrm>
           <a:prstGeom prst="rect">
             <a:avLst/>
@@ -9855,8 +10082,8 @@
         </p:blipFill>
         <p:spPr>
           <a:xfrm>
-            <a:off x="7635240" y="2629149"/>
-            <a:ext cx="4343400" cy="1874021"/>
+            <a:off x="5031801" y="3703320"/>
+            <a:ext cx="6304156" cy="2560320"/>
           </a:xfrm>
           <a:prstGeom prst="rect">
             <a:avLst/>

</xml_diff>

<commit_message>
Fix visual/text overlap with two-column bullets and dynamic wide-band placement.
Co-authored-by: Cursor <cursoragent@cursor.com>
</commit_message>
<xml_diff>
--- a/lessons/lineynaya_regressiya/presentation.pptx
+++ b/lessons/lineynaya_regressiya/presentation.pptx
@@ -4845,7 +4845,7 @@
         <p:spPr>
           <a:xfrm>
             <a:off x="640080" y="1371600"/>
-            <a:ext cx="6583680" cy="3035807"/>
+            <a:ext cx="3108960" cy="969264"/>
           </a:xfrm>
           <a:prstGeom prst="rect">
             <a:avLst/>
@@ -4887,6 +4887,29 @@
               <a:t>Линейная модель с малым числом признаков переобучается реже деревьев, но шум в данных всё равно завышает метрики на train</a:t>
             </a:r>
           </a:p>
+        </p:txBody>
+      </p:sp>
+      <p:sp>
+        <p:nvSpPr>
+          <p:cNvPr id="4" name="TextBox 3"/>
+          <p:cNvSpPr txBox="1"/>
+          <p:nvPr/>
+        </p:nvSpPr>
+        <p:spPr>
+          <a:xfrm>
+            <a:off x="3886200" y="1371600"/>
+            <a:ext cx="3108960" cy="969264"/>
+          </a:xfrm>
+          <a:prstGeom prst="rect">
+            <a:avLst/>
+          </a:prstGeom>
+          <a:noFill/>
+        </p:spPr>
+        <p:txBody>
+          <a:bodyPr wrap="square">
+            <a:normAutofit/>
+          </a:bodyPr>
+          <a:lstStyle/>
           <a:p>
             <a:pPr>
               <a:spcAft>
@@ -4921,7 +4944,7 @@
       </p:sp>
       <p:sp>
         <p:nvSpPr>
-          <p:cNvPr id="4" name="Rectangle 3"/>
+          <p:cNvPr id="5" name="Rectangle 4"/>
           <p:cNvSpPr/>
           <p:nvPr/>
         </p:nvSpPr>
@@ -4966,7 +4989,7 @@
       </p:sp>
       <p:sp>
         <p:nvSpPr>
-          <p:cNvPr id="5" name="TextBox 4"/>
+          <p:cNvPr id="6" name="TextBox 5"/>
           <p:cNvSpPr txBox="1"/>
           <p:nvPr/>
         </p:nvSpPr>
@@ -5069,7 +5092,7 @@
       </p:sp>
       <p:sp>
         <p:nvSpPr>
-          <p:cNvPr id="6" name="TextBox 5"/>
+          <p:cNvPr id="7" name="TextBox 6"/>
           <p:cNvSpPr txBox="1"/>
           <p:nvPr/>
         </p:nvSpPr>
@@ -5104,7 +5127,7 @@
       </p:sp>
       <p:pic>
         <p:nvPicPr>
-          <p:cNvPr id="7" name="Picture 6" descr="train_test_split.png"/>
+          <p:cNvPr id="8" name="Picture 7" descr="train_test_split.png"/>
           <p:cNvPicPr>
             <a:picLocks noChangeAspect="1"/>
           </p:cNvPicPr>
@@ -5118,8 +5141,8 @@
         </p:blipFill>
         <p:spPr>
           <a:xfrm>
-            <a:off x="5037749" y="3703320"/>
-            <a:ext cx="6292261" cy="2560320"/>
+            <a:off x="3721937" y="2450592"/>
+            <a:ext cx="4809085" cy="1956816"/>
           </a:xfrm>
           <a:prstGeom prst="rect">
             <a:avLst/>
@@ -5186,7 +5209,7 @@
         <p:spPr>
           <a:xfrm>
             <a:off x="640080" y="1371600"/>
-            <a:ext cx="6583680" cy="2194560"/>
+            <a:ext cx="3108960" cy="969264"/>
           </a:xfrm>
           <a:prstGeom prst="rect">
             <a:avLst/>
@@ -5274,25 +5297,32 @@
                   <a:srgbClr val="000000"/>
                 </a:solidFill>
               </a:rPr>
-              <a:t xml:space="preserve"> — сжимает веса </a:t>
-            </a:r>
-            <a:r>
-              <a:rPr lang="ru-RU" dirty="0" sz="2000" b="1">
-                <a:solidFill>
-                  <a:srgbClr val="000000"/>
-                </a:solidFill>
-              </a:rPr>
-              <a:t>вместе</a:t>
-            </a:r>
-            <a:r>
-              <a:rPr lang="ru-RU" dirty="0" sz="2000">
-                <a:solidFill>
-                  <a:srgbClr val="000000"/>
-                </a:solidFill>
-              </a:rPr>
-              <a:t>, не обнуляя; стабилизирует при мультиколлинеарности</a:t>
-            </a:r>
-          </a:p>
+              <a:t xml:space="preserve"> — сжимает веса, помогает при мультиколлинеарности</a:t>
+            </a:r>
+          </a:p>
+        </p:txBody>
+      </p:sp>
+      <p:sp>
+        <p:nvSpPr>
+          <p:cNvPr id="4" name="TextBox 3"/>
+          <p:cNvSpPr txBox="1"/>
+          <p:nvPr/>
+        </p:nvSpPr>
+        <p:spPr>
+          <a:xfrm>
+            <a:off x="3886200" y="1371600"/>
+            <a:ext cx="3108960" cy="969264"/>
+          </a:xfrm>
+          <a:prstGeom prst="rect">
+            <a:avLst/>
+          </a:prstGeom>
+          <a:noFill/>
+        </p:spPr>
+        <p:txBody>
+          <a:bodyPr wrap="square">
+            <a:spAutoFit/>
+          </a:bodyPr>
+          <a:lstStyle/>
           <a:p>
             <a:pPr>
               <a:spcAft>
@@ -5355,38 +5385,7 @@
                   <a:srgbClr val="000000"/>
                 </a:solidFill>
               </a:rPr>
-              <a:t xml:space="preserve"> — обнуляет слабые признаки → отбор фич, но не лечит дублирующие столбцы</a:t>
-            </a:r>
-          </a:p>
-          <a:p>
-            <a:pPr>
-              <a:spcAft>
-                <a:spcPts val="800"/>
-              </a:spcAft>
-            </a:pPr>
-            <a:r>
-              <a:rPr lang="ru-RU" dirty="0" sz="2000">
-                <a:solidFill>
-                  <a:srgbClr val="000000"/>
-                </a:solidFill>
-              </a:rPr>
-              <a:t xml:space="preserve">При коррелированных признаках предпочтите </a:t>
-            </a:r>
-            <a:r>
-              <a:rPr lang="ru-RU" dirty="0" sz="2000" b="1">
-                <a:solidFill>
-                  <a:srgbClr val="000000"/>
-                </a:solidFill>
-              </a:rPr>
-              <a:t>Ridge</a:t>
-            </a:r>
-            <a:r>
-              <a:rPr lang="ru-RU" dirty="0" sz="2000">
-                <a:solidFill>
-                  <a:srgbClr val="000000"/>
-                </a:solidFill>
-              </a:rPr>
-              <a:t>; Lasso выберет один из дублей случайно</a:t>
+              <a:t xml:space="preserve"> — может обнулять веса → отбор признаков</a:t>
             </a:r>
           </a:p>
           <a:p>
@@ -5416,14 +5415,14 @@
                   <a:srgbClr val="000000"/>
                 </a:solidFill>
               </a:rPr>
-              <a:t xml:space="preserve"> подбирают по validation / cross-validation (см. график)</a:t>
+              <a:t xml:space="preserve"> подбирают по validation / cross-validation</a:t>
             </a:r>
           </a:p>
         </p:txBody>
       </p:sp>
       <p:pic>
         <p:nvPicPr>
-          <p:cNvPr id="4" name="Picture 3" descr="regularization_weights.png"/>
+          <p:cNvPr id="5" name="Picture 4" descr="regularization_weights.png"/>
           <p:cNvPicPr>
             <a:picLocks noChangeAspect="1"/>
           </p:cNvPicPr>
@@ -5437,32 +5436,8 @@
         </p:blipFill>
         <p:spPr>
           <a:xfrm>
-            <a:off x="7269480" y="1359615"/>
-            <a:ext cx="5029200" cy="2145377"/>
-          </a:xfrm>
-          <a:prstGeom prst="rect">
-            <a:avLst/>
-          </a:prstGeom>
-        </p:spPr>
-      </p:pic>
-      <p:pic>
-        <p:nvPicPr>
-          <p:cNvPr id="5" name="Picture 4" descr="ridge_alpha_cv.png"/>
-          <p:cNvPicPr>
-            <a:picLocks noChangeAspect="1"/>
-          </p:cNvPicPr>
-          <p:nvPr/>
-        </p:nvPicPr>
-        <p:blipFill>
-          <a:blip r:embed="rId3"/>
-          <a:stretch>
-            <a:fillRect/>
-          </a:stretch>
-        </p:blipFill>
-        <p:spPr>
-          <a:xfrm>
-            <a:off x="8231517" y="3593592"/>
-            <a:ext cx="3105125" cy="2212848"/>
+            <a:off x="3500644" y="2450592"/>
+            <a:ext cx="5251670" cy="2240280"/>
           </a:xfrm>
           <a:prstGeom prst="rect">
             <a:avLst/>
@@ -5529,7 +5504,7 @@
         <p:spPr>
           <a:xfrm>
             <a:off x="640080" y="1371600"/>
-            <a:ext cx="6583680" cy="3035807"/>
+            <a:ext cx="3108960" cy="969264"/>
           </a:xfrm>
           <a:prstGeom prst="rect">
             <a:avLst/>
@@ -5612,6 +5587,29 @@
               <a:t xml:space="preserve"> — сильнее штрафует крупные промахи</a:t>
             </a:r>
           </a:p>
+        </p:txBody>
+      </p:sp>
+      <p:sp>
+        <p:nvSpPr>
+          <p:cNvPr id="4" name="TextBox 3"/>
+          <p:cNvSpPr txBox="1"/>
+          <p:nvPr/>
+        </p:nvSpPr>
+        <p:spPr>
+          <a:xfrm>
+            <a:off x="3886200" y="1371600"/>
+            <a:ext cx="3108960" cy="969264"/>
+          </a:xfrm>
+          <a:prstGeom prst="rect">
+            <a:avLst/>
+          </a:prstGeom>
+          <a:noFill/>
+        </p:spPr>
+        <p:txBody>
+          <a:bodyPr wrap="square">
+            <a:normAutofit/>
+          </a:bodyPr>
+          <a:lstStyle/>
           <a:p>
             <a:pPr>
               <a:spcAft>
@@ -5708,14 +5706,14 @@
       </p:sp>
       <p:sp>
         <p:nvSpPr>
-          <p:cNvPr id="4" name="Rectangle 3"/>
+          <p:cNvPr id="5" name="Rectangle 4"/>
           <p:cNvSpPr/>
           <p:nvPr/>
         </p:nvSpPr>
         <p:spPr>
           <a:xfrm>
-            <a:off x="640080" y="4517136"/>
-            <a:ext cx="6492240" cy="978407"/>
+            <a:off x="640080" y="4690872"/>
+            <a:ext cx="6492240" cy="804672"/>
           </a:xfrm>
           <a:prstGeom prst="rect">
             <a:avLst/>
@@ -5753,14 +5751,14 @@
       </p:sp>
       <p:sp>
         <p:nvSpPr>
-          <p:cNvPr id="5" name="TextBox 4"/>
+          <p:cNvPr id="6" name="TextBox 5"/>
           <p:cNvSpPr txBox="1"/>
           <p:nvPr/>
         </p:nvSpPr>
         <p:spPr>
           <a:xfrm>
-            <a:off x="713231" y="4553712"/>
-            <a:ext cx="6345936" cy="905255"/>
+            <a:off x="713231" y="4727448"/>
+            <a:ext cx="6345936" cy="731520"/>
           </a:xfrm>
           <a:prstGeom prst="rect">
             <a:avLst/>
@@ -5785,7 +5783,7 @@
                 </a:solidFill>
                 <a:latin typeface="Consolas"/>
               </a:rPr>
-              <a:t>from sklearn.metrics import mean_absolute_error, mean_squared_error, r2_score</a:t>
+              <a:t>from sklearn.metrics import mean_absolute_error, r2_score</a:t>
             </a:r>
           </a:p>
           <a:p>
@@ -5817,7 +5815,7 @@
                 </a:solidFill>
                 <a:latin typeface="Consolas"/>
               </a:rPr>
-              <a:t>rmse = mean_squared_error(y_te, y_pred, squared=False)</a:t>
+              <a:t>r2 = r2_score(y_te, y_pred)</a:t>
             </a:r>
           </a:p>
           <a:p>
@@ -5833,36 +5831,20 @@
                 </a:solidFill>
                 <a:latin typeface="Consolas"/>
               </a:rPr>
-              <a:t>r2 = r2_score(y_te, y_pred)</a:t>
-            </a:r>
-          </a:p>
-          <a:p>
-            <a:pPr>
-              <a:spcAft>
-                <a:spcPts val="0"/>
-              </a:spcAft>
-            </a:pPr>
-            <a:r>
-              <a:rPr sz="1100">
-                <a:solidFill>
-                  <a:srgbClr val="000000"/>
-                </a:solidFill>
-                <a:latin typeface="Consolas"/>
-              </a:rPr>
-              <a:t>print(f'MAE={mae:.2f}, RMSE={rmse:.2f}, R²={r2:.3f}')</a:t>
-            </a:r>
-          </a:p>
-        </p:txBody>
-      </p:sp>
-      <p:sp>
-        <p:nvSpPr>
-          <p:cNvPr id="6" name="TextBox 5"/>
+              <a:t>print(f'MAE={mae:.2f}, R²={r2:.3f}')</a:t>
+            </a:r>
+          </a:p>
+        </p:txBody>
+      </p:sp>
+      <p:sp>
+        <p:nvSpPr>
+          <p:cNvPr id="7" name="TextBox 6"/>
           <p:cNvSpPr txBox="1"/>
           <p:nvPr/>
         </p:nvSpPr>
         <p:spPr>
           <a:xfrm>
-            <a:off x="640080" y="5550407"/>
+            <a:off x="640080" y="5550408"/>
             <a:ext cx="6492240" cy="201168"/>
           </a:xfrm>
           <a:prstGeom prst="rect">
@@ -5884,14 +5866,14 @@
               </a:defRPr>
             </a:pPr>
             <a:r>
-              <a:t>MAE, RMSE и R²</a:t>
+              <a:t>MAE и R²</a:t>
             </a:r>
           </a:p>
         </p:txBody>
       </p:sp>
       <p:pic>
         <p:nvPicPr>
-          <p:cNvPr id="7" name="Picture 6" descr="regression_metrics_bar.png"/>
+          <p:cNvPr id="8" name="Picture 7" descr="regression_metrics_bar.png"/>
           <p:cNvPicPr>
             <a:picLocks noChangeAspect="1"/>
           </p:cNvPicPr>
@@ -5905,8 +5887,8 @@
         </p:blipFill>
         <p:spPr>
           <a:xfrm>
-            <a:off x="7269480" y="1774146"/>
-            <a:ext cx="5029200" cy="3584028"/>
+            <a:off x="7500144" y="1325880"/>
+            <a:ext cx="4567870" cy="3255264"/>
           </a:xfrm>
           <a:prstGeom prst="rect">
             <a:avLst/>
@@ -5973,7 +5955,7 @@
         <p:spPr>
           <a:xfrm>
             <a:off x="640080" y="1371600"/>
-            <a:ext cx="6583680" cy="1810512"/>
+            <a:ext cx="3108960" cy="969264"/>
           </a:xfrm>
           <a:prstGeom prst="rect">
             <a:avLst/>
@@ -6054,6 +6036,29 @@
               <a:t>Хорошо: случайное облако вокруг нуля, без тренда (гомоскедастичность)</a:t>
             </a:r>
           </a:p>
+        </p:txBody>
+      </p:sp>
+      <p:sp>
+        <p:nvSpPr>
+          <p:cNvPr id="4" name="TextBox 3"/>
+          <p:cNvSpPr txBox="1"/>
+          <p:nvPr/>
+        </p:nvSpPr>
+        <p:spPr>
+          <a:xfrm>
+            <a:off x="3886200" y="1371600"/>
+            <a:ext cx="3108960" cy="969264"/>
+          </a:xfrm>
+          <a:prstGeom prst="rect">
+            <a:avLst/>
+          </a:prstGeom>
+          <a:noFill/>
+        </p:spPr>
+        <p:txBody>
+          <a:bodyPr wrap="square">
+            <a:spAutoFit/>
+          </a:bodyPr>
+          <a:lstStyle/>
           <a:p>
             <a:pPr>
               <a:spcAft>
@@ -6103,7 +6108,7 @@
       </p:sp>
       <p:pic>
         <p:nvPicPr>
-          <p:cNvPr id="4" name="Picture 3" descr="residual_diagnostics.png"/>
+          <p:cNvPr id="5" name="Picture 4" descr="residual_diagnostics.png"/>
           <p:cNvPicPr>
             <a:picLocks noChangeAspect="1"/>
           </p:cNvPicPr>
@@ -6117,8 +6122,8 @@
         </p:blipFill>
         <p:spPr>
           <a:xfrm>
-            <a:off x="4572000" y="3731449"/>
-            <a:ext cx="7223760" cy="2504062"/>
+            <a:off x="2895081" y="2450592"/>
+            <a:ext cx="6462797" cy="2240280"/>
           </a:xfrm>
           <a:prstGeom prst="rect">
             <a:avLst/>
@@ -6185,7 +6190,7 @@
         <p:spPr>
           <a:xfrm>
             <a:off x="640080" y="1371600"/>
-            <a:ext cx="6583680" cy="1810512"/>
+            <a:ext cx="3108960" cy="1645920"/>
           </a:xfrm>
           <a:prstGeom prst="rect">
             <a:avLst/>
@@ -6291,6 +6296,29 @@
               <a:t>Ceteris paribus — «при прочих равных»; в реальных данных признаки коррелированы</a:t>
             </a:r>
           </a:p>
+        </p:txBody>
+      </p:sp>
+      <p:sp>
+        <p:nvSpPr>
+          <p:cNvPr id="4" name="TextBox 3"/>
+          <p:cNvSpPr txBox="1"/>
+          <p:nvPr/>
+        </p:nvSpPr>
+        <p:spPr>
+          <a:xfrm>
+            <a:off x="3886200" y="1371600"/>
+            <a:ext cx="3108960" cy="1645920"/>
+          </a:xfrm>
+          <a:prstGeom prst="rect">
+            <a:avLst/>
+          </a:prstGeom>
+          <a:noFill/>
+        </p:spPr>
+        <p:txBody>
+          <a:bodyPr wrap="square">
+            <a:spAutoFit/>
+          </a:bodyPr>
+          <a:lstStyle/>
           <a:p>
             <a:pPr>
               <a:spcAft>
@@ -6325,7 +6353,7 @@
       </p:sp>
       <p:pic>
         <p:nvPicPr>
-          <p:cNvPr id="4" name="Picture 3" descr="standardized_weights.png"/>
+          <p:cNvPr id="5" name="Picture 4" descr="standardized_weights.png"/>
           <p:cNvPicPr>
             <a:picLocks noChangeAspect="1"/>
           </p:cNvPicPr>
@@ -6339,7 +6367,7 @@
         </p:blipFill>
         <p:spPr>
           <a:xfrm>
-            <a:off x="7269480" y="1789462"/>
+            <a:off x="7269480" y="1752886"/>
             <a:ext cx="5029200" cy="3553395"/>
           </a:xfrm>
           <a:prstGeom prst="rect">
@@ -6407,7 +6435,7 @@
         <p:spPr>
           <a:xfrm>
             <a:off x="640080" y="1371600"/>
-            <a:ext cx="6583680" cy="2514599"/>
+            <a:ext cx="3108960" cy="969264"/>
           </a:xfrm>
           <a:prstGeom prst="rect">
             <a:avLst/>
@@ -6465,6 +6493,29 @@
               <a:t xml:space="preserve"> split — статистики теста попадают в train</a:t>
             </a:r>
           </a:p>
+        </p:txBody>
+      </p:sp>
+      <p:sp>
+        <p:nvSpPr>
+          <p:cNvPr id="4" name="TextBox 3"/>
+          <p:cNvSpPr txBox="1"/>
+          <p:nvPr/>
+        </p:nvSpPr>
+        <p:spPr>
+          <a:xfrm>
+            <a:off x="3886200" y="1371600"/>
+            <a:ext cx="3108960" cy="969264"/>
+          </a:xfrm>
+          <a:prstGeom prst="rect">
+            <a:avLst/>
+          </a:prstGeom>
+          <a:noFill/>
+        </p:spPr>
+        <p:txBody>
+          <a:bodyPr wrap="square">
+            <a:normAutofit/>
+          </a:bodyPr>
+          <a:lstStyle/>
           <a:p>
             <a:pPr>
               <a:spcAft>
@@ -6499,7 +6550,7 @@
       </p:sp>
       <p:sp>
         <p:nvSpPr>
-          <p:cNvPr id="4" name="Rectangle 3"/>
+          <p:cNvPr id="5" name="Rectangle 4"/>
           <p:cNvSpPr/>
           <p:nvPr/>
         </p:nvSpPr>
@@ -6544,7 +6595,7 @@
       </p:sp>
       <p:sp>
         <p:nvSpPr>
-          <p:cNvPr id="5" name="TextBox 4"/>
+          <p:cNvPr id="6" name="TextBox 5"/>
           <p:cNvSpPr txBox="1"/>
           <p:nvPr/>
         </p:nvSpPr>
@@ -6695,7 +6746,7 @@
       </p:sp>
       <p:sp>
         <p:nvSpPr>
-          <p:cNvPr id="6" name="TextBox 5"/>
+          <p:cNvPr id="7" name="TextBox 6"/>
           <p:cNvSpPr txBox="1"/>
           <p:nvPr/>
         </p:nvSpPr>
@@ -6730,7 +6781,7 @@
       </p:sp>
       <p:pic>
         <p:nvPicPr>
-          <p:cNvPr id="7" name="Picture 6" descr="pipeline_leakage.png"/>
+          <p:cNvPr id="8" name="Picture 7" descr="pipeline_leakage.png"/>
           <p:cNvPicPr>
             <a:picLocks noChangeAspect="1"/>
           </p:cNvPicPr>
@@ -6744,8 +6795,8 @@
         </p:blipFill>
         <p:spPr>
           <a:xfrm>
-            <a:off x="4627306" y="3703320"/>
-            <a:ext cx="7113147" cy="2560320"/>
+            <a:off x="4132258" y="2450592"/>
+            <a:ext cx="3988443" cy="1435608"/>
           </a:xfrm>
           <a:prstGeom prst="rect">
             <a:avLst/>
@@ -6812,7 +6863,7 @@
         <p:spPr>
           <a:xfrm>
             <a:off x="640080" y="1371600"/>
-            <a:ext cx="6583680" cy="1810512"/>
+            <a:ext cx="3108960" cy="969264"/>
           </a:xfrm>
           <a:prstGeom prst="rect">
             <a:avLst/>
@@ -6851,7 +6902,7 @@
                   <a:srgbClr val="000000"/>
                 </a:solidFill>
               </a:rPr>
-              <a:t xml:space="preserve">Эффект одного признака зависит от другого, но в модели нет произведения </a:t>
+              <a:t>Сильное взаимодействие признаков без явных фичей (</a:t>
             </a:r>
             <ns0:m xmlns:ns0="http://schemas.microsoft.com/office/drawing/2010/main">
               <m:oMath xmlns:m="http://schemas.openxmlformats.org/officeDocument/2006/math">
@@ -6890,9 +6941,32 @@
                   <a:srgbClr val="000000"/>
                 </a:solidFill>
               </a:rPr>
-              <a:t xml:space="preserve"> — линейная формула это не описывает</a:t>
-            </a:r>
-          </a:p>
+              <a:t>)</a:t>
+            </a:r>
+          </a:p>
+        </p:txBody>
+      </p:sp>
+      <p:sp>
+        <p:nvSpPr>
+          <p:cNvPr id="4" name="TextBox 3"/>
+          <p:cNvSpPr txBox="1"/>
+          <p:nvPr/>
+        </p:nvSpPr>
+        <p:spPr>
+          <a:xfrm>
+            <a:off x="3886200" y="1371600"/>
+            <a:ext cx="3108960" cy="969264"/>
+          </a:xfrm>
+          <a:prstGeom prst="rect">
+            <a:avLst/>
+          </a:prstGeom>
+          <a:noFill/>
+        </p:spPr>
+        <p:txBody>
+          <a:bodyPr wrap="square">
+            <a:spAutoFit/>
+          </a:bodyPr>
+          <a:lstStyle/>
           <a:p>
             <a:pPr>
               <a:spcAft>
@@ -6942,7 +7016,7 @@
       </p:sp>
       <p:pic>
         <p:nvPicPr>
-          <p:cNvPr id="4" name="Picture 3" descr="nonlinear_vs_linear.png"/>
+          <p:cNvPr id="5" name="Picture 4" descr="nonlinear_vs_linear.png"/>
           <p:cNvPicPr>
             <a:picLocks noChangeAspect="1"/>
           </p:cNvPicPr>
@@ -6956,8 +7030,8 @@
         </p:blipFill>
         <p:spPr>
           <a:xfrm>
-            <a:off x="5103169" y="3703320"/>
-            <a:ext cx="6161420" cy="2560320"/>
+            <a:off x="3430858" y="2450592"/>
+            <a:ext cx="5391242" cy="2240280"/>
           </a:xfrm>
           <a:prstGeom prst="rect">
             <a:avLst/>
@@ -7257,7 +7331,7 @@
                 </a:solidFill>
                 <a:hlinkClick r:id="rId2"/>
               </a:rPr>
-              <a:t>Markov A.A. (1900). Least Squares Estimation of Linear Models</a:t>
+              <a:t>Hoerl A.E., Kennard R.W. (1970). Ridge Regression: Biased Estimation for Nonorthogonal Problems</a:t>
             </a:r>
           </a:p>
         </p:txBody>
@@ -7304,7 +7378,7 @@
                 </a:solidFill>
                 <a:hlinkClick r:id="rId3"/>
               </a:rPr>
-              <a:t>Hoerl A.E., Kennard R.W. (1970). Ridge Regression: Biased Estimation for Nonorthogonal Problems</a:t>
+              <a:t>Tibshirani R. (1996). Regression Shrinkage and Selection via the Lasso</a:t>
             </a:r>
           </a:p>
         </p:txBody>
@@ -7351,7 +7425,7 @@
                 </a:solidFill>
                 <a:hlinkClick r:id="rId4"/>
               </a:rPr>
-              <a:t>Tibshirani R. (1996). Regression Shrinkage and Selection via the Lasso</a:t>
+              <a:t>Markov A.A. (1900). Least Squares Estimation of Linear Models</a:t>
             </a:r>
           </a:p>
         </p:txBody>
@@ -7653,7 +7727,7 @@
         <p:spPr>
           <a:xfrm>
             <a:off x="640080" y="1371600"/>
-            <a:ext cx="6583680" cy="1810512"/>
+            <a:ext cx="3108960" cy="1645920"/>
           </a:xfrm>
           <a:prstGeom prst="rect">
             <a:avLst/>
@@ -7710,6 +7784,29 @@
               <a:t xml:space="preserve"> — прямая на плоскости «признак → ответ»</a:t>
             </a:r>
           </a:p>
+        </p:txBody>
+      </p:sp>
+      <p:sp>
+        <p:nvSpPr>
+          <p:cNvPr id="4" name="TextBox 3"/>
+          <p:cNvSpPr txBox="1"/>
+          <p:nvPr/>
+        </p:nvSpPr>
+        <p:spPr>
+          <a:xfrm>
+            <a:off x="3886200" y="1371600"/>
+            <a:ext cx="3108960" cy="1645920"/>
+          </a:xfrm>
+          <a:prstGeom prst="rect">
+            <a:avLst/>
+          </a:prstGeom>
+          <a:noFill/>
+        </p:spPr>
+        <p:txBody>
+          <a:bodyPr wrap="square">
+            <a:spAutoFit/>
+          </a:bodyPr>
+          <a:lstStyle/>
           <a:p>
             <a:pPr>
               <a:spcAft>
@@ -7774,7 +7871,7 @@
       </p:sp>
       <p:pic>
         <p:nvPicPr>
-          <p:cNvPr id="4" name="Picture 3" descr="intro_scatter_line.png"/>
+          <p:cNvPr id="5" name="Picture 4" descr="intro_scatter_line.png"/>
           <p:cNvPicPr>
             <a:picLocks noChangeAspect="1"/>
           </p:cNvPicPr>
@@ -7788,7 +7885,7 @@
         </p:blipFill>
         <p:spPr>
           <a:xfrm>
-            <a:off x="7269480" y="1774146"/>
+            <a:off x="7269480" y="1737570"/>
             <a:ext cx="5029200" cy="3584028"/>
           </a:xfrm>
           <a:prstGeom prst="rect">
@@ -7856,7 +7953,7 @@
         <p:spPr>
           <a:xfrm>
             <a:off x="640080" y="1371600"/>
-            <a:ext cx="6583680" cy="1810512"/>
+            <a:ext cx="3108960" cy="1645920"/>
           </a:xfrm>
           <a:prstGeom prst="rect">
             <a:avLst/>
@@ -7975,6 +8072,29 @@
               <a:t xml:space="preserve"> — разница между фактом и прогнозом</a:t>
             </a:r>
           </a:p>
+        </p:txBody>
+      </p:sp>
+      <p:sp>
+        <p:nvSpPr>
+          <p:cNvPr id="4" name="TextBox 3"/>
+          <p:cNvSpPr txBox="1"/>
+          <p:nvPr/>
+        </p:nvSpPr>
+        <p:spPr>
+          <a:xfrm>
+            <a:off x="3886200" y="1371600"/>
+            <a:ext cx="3108960" cy="1645920"/>
+          </a:xfrm>
+          <a:prstGeom prst="rect">
+            <a:avLst/>
+          </a:prstGeom>
+          <a:noFill/>
+        </p:spPr>
+        <p:txBody>
+          <a:bodyPr wrap="square">
+            <a:spAutoFit/>
+          </a:bodyPr>
+          <a:lstStyle/>
           <a:p>
             <a:pPr>
               <a:spcAft>
@@ -7982,65 +8102,12 @@
               </a:spcAft>
             </a:pPr>
             <a:r>
-              <a:rPr lang="ru-RU" dirty="0" sz="2000" b="1">
-                <a:solidFill>
-                  <a:srgbClr val="000000"/>
-                </a:solidFill>
-              </a:rPr>
-              <a:t>Intercept</a:t>
-            </a:r>
-            <a:r>
               <a:rPr lang="ru-RU" dirty="0" sz="2000">
                 <a:solidFill>
                   <a:srgbClr val="000000"/>
                 </a:solidFill>
               </a:rPr>
-              <a:t xml:space="preserve"> (</a:t>
-            </a:r>
-            <ns0:m xmlns:ns0="http://schemas.microsoft.com/office/drawing/2010/main">
-              <m:oMath xmlns:m="http://schemas.openxmlformats.org/officeDocument/2006/math">
-                <m:r>
-                  <m:t>b</m:t>
-                </m:r>
-              </m:oMath>
-            </ns0:m>
-            <a:r>
-              <a:rPr lang="ru-RU" dirty="0" sz="2000">
-                <a:solidFill>
-                  <a:srgbClr val="000000"/>
-                </a:solidFill>
-              </a:rPr>
-              <a:t xml:space="preserve">): прогноз при </a:t>
-            </a:r>
-            <ns0:m xmlns:ns0="http://schemas.microsoft.com/office/drawing/2010/main">
-              <m:oMath xmlns:m="http://schemas.openxmlformats.org/officeDocument/2006/math">
-                <m:r>
-                  <m:t>x=0</m:t>
-                </m:r>
-              </m:oMath>
-            </ns0:m>
-            <a:r>
-              <a:rPr lang="ru-RU" dirty="0" sz="2000">
-                <a:solidFill>
-                  <a:srgbClr val="000000"/>
-                </a:solidFill>
-              </a:rPr>
-              <a:t xml:space="preserve">; в sklearn — параметр `fit_intercept=True` (смещение прямой по оси </a:t>
-            </a:r>
-            <ns0:m xmlns:ns0="http://schemas.microsoft.com/office/drawing/2010/main">
-              <m:oMath xmlns:m="http://schemas.openxmlformats.org/officeDocument/2006/math">
-                <m:r>
-                  <m:t>y</m:t>
-                </m:r>
-              </m:oMath>
-            </ns0:m>
-            <a:r>
-              <a:rPr lang="ru-RU" dirty="0" sz="2000">
-                <a:solidFill>
-                  <a:srgbClr val="000000"/>
-                </a:solidFill>
-              </a:rPr>
-              <a:t>)</a:t>
+              <a:t>Хорошая модель: остатки симметрично разбросаны вокруг нуля, без систематического смещения</a:t>
             </a:r>
           </a:p>
           <a:p>
@@ -8055,14 +8122,14 @@
                   <a:srgbClr val="000000"/>
                 </a:solidFill>
               </a:rPr>
-              <a:t>Хорошая модель: остатки симметрично разбросаны вокруг нуля, без систематического смещения</a:t>
+              <a:t>Сумма остатков на обучающей выборке при МНК равна нулю (для модели с intercept)</a:t>
             </a:r>
           </a:p>
         </p:txBody>
       </p:sp>
       <p:pic>
         <p:nvPicPr>
-          <p:cNvPr id="4" name="Picture 3" descr="residuals_vertical.png"/>
+          <p:cNvPr id="5" name="Picture 4" descr="residuals_vertical.png"/>
           <p:cNvPicPr>
             <a:picLocks noChangeAspect="1"/>
           </p:cNvPicPr>
@@ -8086,7 +8153,7 @@
       </p:pic>
       <p:pic>
         <p:nvPicPr>
-          <p:cNvPr id="5" name="Picture 4" descr="residuals_histogram.png"/>
+          <p:cNvPr id="6" name="Picture 5" descr="residuals_histogram.png"/>
           <p:cNvPicPr>
             <a:picLocks noChangeAspect="1"/>
           </p:cNvPicPr>
@@ -8168,7 +8235,7 @@
         <p:spPr>
           <a:xfrm>
             <a:off x="640080" y="1371600"/>
-            <a:ext cx="6583680" cy="2194560"/>
+            <a:ext cx="3108960" cy="1645920"/>
           </a:xfrm>
           <a:prstGeom prst="rect">
             <a:avLst/>
@@ -8300,85 +8367,7 @@
                   <a:srgbClr val="000000"/>
                 </a:solidFill>
               </a:rPr>
-              <a:t xml:space="preserve">Минимизация </a:t>
-            </a:r>
-            <ns0:m xmlns:ns0="http://schemas.microsoft.com/office/drawing/2010/main">
-              <m:oMath xmlns:m="http://schemas.openxmlformats.org/officeDocument/2006/math">
-                <m:nary>
-                  <m:naryPr>
-                    <m:chr m:val="∑"/>
-                    <m:limLoc m:val="subSup"/>
-                    <m:grow m:val="1"/>
-                    <m:subHide m:val="off"/>
-                    <m:supHide m:val="on"/>
-                  </m:naryPr>
-                  <m:sub>
-                    <m:r>
-                      <m:t>i</m:t>
-                    </m:r>
-                  </m:sub>
-                  <m:sup/>
-                  <m:e>
-                    <m:r>
-                      <m:t>(</m:t>
-                    </m:r>
-                  </m:e>
-                </m:nary>
-                <m:sSub>
-                  <m:e>
-                    <m:r>
-                      <m:t>y</m:t>
-                    </m:r>
-                  </m:e>
-                  <m:sub>
-                    <m:r>
-                      <m:t>i</m:t>
-                    </m:r>
-                  </m:sub>
-                </m:sSub>
-                <m:r>
-                  <m:t>−</m:t>
-                </m:r>
-                <m:sSub>
-                  <m:e>
-                    <m:acc>
-                      <m:accPr>
-                        <m:chr m:val="̂"/>
-                      </m:accPr>
-                      <m:e>
-                        <m:r>
-                          <m:t>y</m:t>
-                        </m:r>
-                      </m:e>
-                    </m:acc>
-                  </m:e>
-                  <m:sub>
-                    <m:r>
-                      <m:t>i</m:t>
-                    </m:r>
-                  </m:sub>
-                </m:sSub>
-                <m:sSup>
-                  <m:e>
-                    <m:r>
-                      <m:t>)</m:t>
-                    </m:r>
-                  </m:e>
-                  <m:sup>
-                    <m:r>
-                      <m:t>2</m:t>
-                    </m:r>
-                  </m:sup>
-                </m:sSup>
-              </m:oMath>
-            </ns0:m>
-            <a:r>
-              <a:rPr lang="ru-RU" dirty="0" sz="2000">
-                <a:solidFill>
-                  <a:srgbClr val="000000"/>
-                </a:solidFill>
-              </a:rPr>
-              <a:t xml:space="preserve"> без деления на </a:t>
+              <a:t xml:space="preserve">Сумму без деления на </a:t>
             </a:r>
             <ns0:m xmlns:ns0="http://schemas.microsoft.com/office/drawing/2010/main">
               <m:oMath xmlns:m="http://schemas.openxmlformats.org/officeDocument/2006/math">
@@ -8393,22 +8382,7 @@
                   <a:srgbClr val="000000"/>
                 </a:solidFill>
               </a:rPr>
-              <a:t xml:space="preserve"> даёт те же оптимальные веса; деление на </a:t>
-            </a:r>
-            <ns0:m xmlns:ns0="http://schemas.microsoft.com/office/drawing/2010/main">
-              <m:oMath xmlns:m="http://schemas.openxmlformats.org/officeDocument/2006/math">
-                <m:r>
-                  <m:t>N</m:t>
-                </m:r>
-              </m:oMath>
-            </ns0:m>
-            <a:r>
-              <a:rPr lang="ru-RU" dirty="0" sz="2000">
-                <a:solidFill>
-                  <a:srgbClr val="000000"/>
-                </a:solidFill>
-              </a:rPr>
-              <a:t xml:space="preserve"> нужно для сравнимости между выборками</a:t>
+              <a:t xml:space="preserve"> минимизировать то же самое; деление нужно для сравнимости между выборками</a:t>
             </a:r>
           </a:p>
           <a:p>
@@ -8493,6 +8467,29 @@
               <a:t>) устойчивее к выбросам, но не гладкая в нуле</a:t>
             </a:r>
           </a:p>
+        </p:txBody>
+      </p:sp>
+      <p:sp>
+        <p:nvSpPr>
+          <p:cNvPr id="4" name="TextBox 3"/>
+          <p:cNvSpPr txBox="1"/>
+          <p:nvPr/>
+        </p:nvSpPr>
+        <p:spPr>
+          <a:xfrm>
+            <a:off x="3886200" y="1371600"/>
+            <a:ext cx="3108960" cy="1645920"/>
+          </a:xfrm>
+          <a:prstGeom prst="rect">
+            <a:avLst/>
+          </a:prstGeom>
+          <a:noFill/>
+        </p:spPr>
+        <p:txBody>
+          <a:bodyPr wrap="square">
+            <a:spAutoFit/>
+          </a:bodyPr>
+          <a:lstStyle/>
           <a:p>
             <a:pPr>
               <a:spcAft>
@@ -8520,14 +8517,14 @@
                   <a:srgbClr val="000000"/>
                 </a:solidFill>
               </a:rPr>
-              <a:t>MSE = MLE при нормальных остатках; MAE = MLE, если ошибки распределены по Лапласу (редкие, но крупные сбои — например, катастрофические задержки доставки)</a:t>
+              <a:t>MSE = MLE при гауссовских остатках; MAE = MLE при распределении Лапласа (например, медианный шум в задачах с редкими сбоями)</a:t>
             </a:r>
           </a:p>
         </p:txBody>
       </p:sp>
       <p:pic>
         <p:nvPicPr>
-          <p:cNvPr id="4" name="Picture 3" descr="mse_vs_mae_loss.png"/>
+          <p:cNvPr id="5" name="Picture 4" descr="mse_vs_mae_loss.png"/>
           <p:cNvPicPr>
             <a:picLocks noChangeAspect="1"/>
           </p:cNvPicPr>
@@ -8541,7 +8538,7 @@
         </p:blipFill>
         <p:spPr>
           <a:xfrm>
-            <a:off x="7269480" y="1791148"/>
+            <a:off x="7269480" y="1754572"/>
             <a:ext cx="5029200" cy="3550024"/>
           </a:xfrm>
           <a:prstGeom prst="rect">
@@ -8609,7 +8606,7 @@
         <p:spPr>
           <a:xfrm>
             <a:off x="640080" y="1371600"/>
-            <a:ext cx="6583680" cy="3383279"/>
+            <a:ext cx="3108960" cy="1316736"/>
           </a:xfrm>
           <a:prstGeom prst="rect">
             <a:avLst/>
@@ -8633,7 +8630,7 @@
                   <a:srgbClr val="000000"/>
                 </a:solidFill>
               </a:rPr>
-              <a:t xml:space="preserve">Аналитическое решение (МНК): </a:t>
+              <a:t xml:space="preserve">Аналитическое решение (МНК): производная по весам → система линейных уравнений → </a:t>
             </a:r>
             <ns0:m xmlns:ns0="http://schemas.microsoft.com/office/drawing/2010/main">
               <m:oMath xmlns:m="http://schemas.openxmlformats.org/officeDocument/2006/math">
@@ -8694,14 +8691,6 @@
                 </m:r>
               </m:oMath>
             </ns0:m>
-            <a:r>
-              <a:rPr lang="ru-RU" dirty="0" sz="2000">
-                <a:solidFill>
-                  <a:srgbClr val="000000"/>
-                </a:solidFill>
-              </a:rPr>
-              <a:t xml:space="preserve"> — быстро для умеренных матриц</a:t>
-            </a:r>
           </a:p>
           <a:p>
             <a:pPr>
@@ -8715,7 +8704,7 @@
                   <a:srgbClr val="000000"/>
                 </a:solidFill>
               </a:rPr>
-              <a:t>`LinearRegression` в sklearn использует solver `linalg` без итераций</a:t>
+              <a:t>`LinearRegression` в sklearn по умолчанию решает так (solver `linalg`) — быстро и точно для умеренных матриц</a:t>
             </a:r>
           </a:p>
           <a:p>
@@ -8730,9 +8719,47 @@
                   <a:srgbClr val="000000"/>
                 </a:solidFill>
               </a:rPr>
-              <a:t>При огромных данных — итеративные методы: SGD, `SGDRegressor`</a:t>
-            </a:r>
-          </a:p>
+              <a:t xml:space="preserve">При очень больших </a:t>
+            </a:r>
+            <ns0:m xmlns:ns0="http://schemas.microsoft.com/office/drawing/2010/main">
+              <m:oMath xmlns:m="http://schemas.openxmlformats.org/officeDocument/2006/math">
+                <m:r>
+                  <m:t>X</m:t>
+                </m:r>
+              </m:oMath>
+            </ns0:m>
+            <a:r>
+              <a:rPr lang="ru-RU" dirty="0" sz="2000">
+                <a:solidFill>
+                  <a:srgbClr val="000000"/>
+                </a:solidFill>
+              </a:rPr>
+              <a:t xml:space="preserve"> или нехватке памяти — итеративные методы: SGD, `sag`, `lsqr`</a:t>
+            </a:r>
+          </a:p>
+        </p:txBody>
+      </p:sp>
+      <p:sp>
+        <p:nvSpPr>
+          <p:cNvPr id="4" name="TextBox 3"/>
+          <p:cNvSpPr txBox="1"/>
+          <p:nvPr/>
+        </p:nvSpPr>
+        <p:spPr>
+          <a:xfrm>
+            <a:off x="3886200" y="1371600"/>
+            <a:ext cx="3108960" cy="1316736"/>
+          </a:xfrm>
+          <a:prstGeom prst="rect">
+            <a:avLst/>
+          </a:prstGeom>
+          <a:noFill/>
+        </p:spPr>
+        <p:txBody>
+          <a:bodyPr wrap="square">
+            <a:normAutofit/>
+          </a:bodyPr>
+          <a:lstStyle/>
           <a:p>
             <a:pPr>
               <a:spcAft>
@@ -8745,21 +8772,36 @@
                   <a:srgbClr val="000000"/>
                 </a:solidFill>
               </a:rPr>
-              <a:t>Градиентный спуск: шаг против градиента функции потерь</a:t>
-            </a:r>
-          </a:p>
-        </p:txBody>
-      </p:sp>
-      <p:sp>
-        <p:nvSpPr>
-          <p:cNvPr id="4" name="Rectangle 3"/>
+              <a:t>Градиентный спуск: шаг против градиента функции потерь; `SGDRegressor` в sklearn</a:t>
+            </a:r>
+          </a:p>
+          <a:p>
+            <a:pPr>
+              <a:spcAft>
+                <a:spcPts val="800"/>
+              </a:spcAft>
+            </a:pPr>
+            <a:r>
+              <a:rPr lang="ru-RU" dirty="0" sz="2000">
+                <a:solidFill>
+                  <a:srgbClr val="000000"/>
+                </a:solidFill>
+              </a:rPr>
+              <a:t>На практике для линейной регрессии чаще используют не «чистый» SGD, а стабильные solver'ы (`lbfgs`, `sag` в Ridge/Lasso)</a:t>
+            </a:r>
+          </a:p>
+        </p:txBody>
+      </p:sp>
+      <p:sp>
+        <p:nvSpPr>
+          <p:cNvPr id="5" name="Rectangle 4"/>
           <p:cNvSpPr/>
           <p:nvPr/>
         </p:nvSpPr>
         <p:spPr>
           <a:xfrm>
-            <a:off x="640080" y="4864607"/>
-            <a:ext cx="6492240" cy="630936"/>
+            <a:off x="640080" y="4690872"/>
+            <a:ext cx="6492240" cy="804672"/>
           </a:xfrm>
           <a:prstGeom prst="rect">
             <a:avLst/>
@@ -8797,14 +8839,14 @@
       </p:sp>
       <p:sp>
         <p:nvSpPr>
-          <p:cNvPr id="5" name="TextBox 4"/>
+          <p:cNvPr id="6" name="TextBox 5"/>
           <p:cNvSpPr txBox="1"/>
           <p:nvPr/>
         </p:nvSpPr>
         <p:spPr>
           <a:xfrm>
-            <a:off x="713231" y="4901183"/>
-            <a:ext cx="6345936" cy="557784"/>
+            <a:off x="713231" y="4727448"/>
+            <a:ext cx="6345936" cy="731520"/>
           </a:xfrm>
           <a:prstGeom prst="rect">
             <a:avLst/>
@@ -8845,7 +8887,7 @@
                 </a:solidFill>
                 <a:latin typeface="Consolas"/>
               </a:rPr>
-              <a:t>model = LinearRegression().fit(X_train, y_train)</a:t>
+              <a:t>model = LinearRegression()  # solver='linalg' по умолчанию</a:t>
             </a:r>
           </a:p>
           <a:p>
@@ -8861,6 +8903,22 @@
                 </a:solidFill>
                 <a:latin typeface="Consolas"/>
               </a:rPr>
+              <a:t>model.fit(X_train, y_train)</a:t>
+            </a:r>
+          </a:p>
+          <a:p>
+            <a:pPr>
+              <a:spcAft>
+                <a:spcPts val="0"/>
+              </a:spcAft>
+            </a:pPr>
+            <a:r>
+              <a:rPr sz="1100">
+                <a:solidFill>
+                  <a:srgbClr val="000000"/>
+                </a:solidFill>
+                <a:latin typeface="Consolas"/>
+              </a:rPr>
               <a:t>y_pred = model.predict(X_test)</a:t>
             </a:r>
           </a:p>
@@ -8868,13 +8926,13 @@
       </p:sp>
       <p:sp>
         <p:nvSpPr>
-          <p:cNvPr id="6" name="TextBox 5"/>
+          <p:cNvPr id="7" name="TextBox 6"/>
           <p:cNvSpPr txBox="1"/>
           <p:nvPr/>
         </p:nvSpPr>
         <p:spPr>
           <a:xfrm>
-            <a:off x="640080" y="5550407"/>
+            <a:off x="640080" y="5550408"/>
             <a:ext cx="6492240" cy="201168"/>
           </a:xfrm>
           <a:prstGeom prst="rect">
@@ -8903,7 +8961,7 @@
       </p:sp>
       <p:pic>
         <p:nvPicPr>
-          <p:cNvPr id="7" name="Picture 6" descr="gradient_descent_contour.png"/>
+          <p:cNvPr id="8" name="Picture 7" descr="gradient_descent_contour.png"/>
           <p:cNvPicPr>
             <a:picLocks noChangeAspect="1"/>
           </p:cNvPicPr>
@@ -8917,8 +8975,8 @@
         </p:blipFill>
         <p:spPr>
           <a:xfrm>
-            <a:off x="7269480" y="1774146"/>
-            <a:ext cx="5029200" cy="3584028"/>
+            <a:off x="7500144" y="1325880"/>
+            <a:ext cx="4567870" cy="3255264"/>
           </a:xfrm>
           <a:prstGeom prst="rect">
             <a:avLst/>
@@ -8985,7 +9043,7 @@
         <p:spPr>
           <a:xfrm>
             <a:off x="640080" y="1371600"/>
-            <a:ext cx="6583680" cy="1810512"/>
+            <a:ext cx="3108960" cy="1645920"/>
           </a:xfrm>
           <a:prstGeom prst="rect">
             <a:avLst/>
@@ -9151,6 +9209,29 @@
               </m:oMath>
             </ns0:m>
           </a:p>
+        </p:txBody>
+      </p:sp>
+      <p:sp>
+        <p:nvSpPr>
+          <p:cNvPr id="4" name="TextBox 3"/>
+          <p:cNvSpPr txBox="1"/>
+          <p:nvPr/>
+        </p:nvSpPr>
+        <p:spPr>
+          <a:xfrm>
+            <a:off x="3886200" y="1371600"/>
+            <a:ext cx="3108960" cy="1645920"/>
+          </a:xfrm>
+          <a:prstGeom prst="rect">
+            <a:avLst/>
+          </a:prstGeom>
+          <a:noFill/>
+        </p:spPr>
+        <p:txBody>
+          <a:bodyPr wrap="square">
+            <a:spAutoFit/>
+          </a:bodyPr>
+          <a:lstStyle/>
           <a:p>
             <a:pPr>
               <a:spcAft>
@@ -9200,7 +9281,7 @@
       </p:sp>
       <p:pic>
         <p:nvPicPr>
-          <p:cNvPr id="4" name="Picture 3" descr="hyperplane_3d.png"/>
+          <p:cNvPr id="5" name="Picture 4" descr="hyperplane_3d.png"/>
           <p:cNvPicPr>
             <a:picLocks noChangeAspect="1"/>
           </p:cNvPicPr>
@@ -9214,8 +9295,8 @@
         </p:blipFill>
         <p:spPr>
           <a:xfrm>
-            <a:off x="7632338" y="1325880"/>
-            <a:ext cx="4303483" cy="4480559"/>
+            <a:off x="7667468" y="1325880"/>
+            <a:ext cx="4233223" cy="4407408"/>
           </a:xfrm>
           <a:prstGeom prst="rect">
             <a:avLst/>
@@ -9282,7 +9363,7 @@
         <p:spPr>
           <a:xfrm>
             <a:off x="640080" y="1371600"/>
-            <a:ext cx="6583680" cy="2688335"/>
+            <a:ext cx="3108960" cy="969264"/>
           </a:xfrm>
           <a:prstGeom prst="rect">
             <a:avLst/>
@@ -9339,6 +9420,29 @@
               <a:t xml:space="preserve"> — для МНК качество прогноза на test часто не меняется</a:t>
             </a:r>
           </a:p>
+        </p:txBody>
+      </p:sp>
+      <p:sp>
+        <p:nvSpPr>
+          <p:cNvPr id="4" name="TextBox 3"/>
+          <p:cNvSpPr txBox="1"/>
+          <p:nvPr/>
+        </p:nvSpPr>
+        <p:spPr>
+          <a:xfrm>
+            <a:off x="3886200" y="1371600"/>
+            <a:ext cx="3108960" cy="969264"/>
+          </a:xfrm>
+          <a:prstGeom prst="rect">
+            <a:avLst/>
+          </a:prstGeom>
+          <a:noFill/>
+        </p:spPr>
+        <p:txBody>
+          <a:bodyPr wrap="square">
+            <a:normAutofit/>
+          </a:bodyPr>
+          <a:lstStyle/>
           <a:p>
             <a:pPr>
               <a:spcAft>
@@ -9405,7 +9509,7 @@
       </p:sp>
       <p:sp>
         <p:nvSpPr>
-          <p:cNvPr id="4" name="Rectangle 3"/>
+          <p:cNvPr id="5" name="Rectangle 4"/>
           <p:cNvSpPr/>
           <p:nvPr/>
         </p:nvSpPr>
@@ -9450,7 +9554,7 @@
       </p:sp>
       <p:sp>
         <p:nvSpPr>
-          <p:cNvPr id="5" name="TextBox 4"/>
+          <p:cNvPr id="6" name="TextBox 5"/>
           <p:cNvSpPr txBox="1"/>
           <p:nvPr/>
         </p:nvSpPr>
@@ -9585,7 +9689,7 @@
       </p:sp>
       <p:sp>
         <p:nvSpPr>
-          <p:cNvPr id="6" name="TextBox 5"/>
+          <p:cNvPr id="7" name="TextBox 6"/>
           <p:cNvSpPr txBox="1"/>
           <p:nvPr/>
         </p:nvSpPr>
@@ -9620,7 +9724,7 @@
       </p:sp>
       <p:pic>
         <p:nvPicPr>
-          <p:cNvPr id="7" name="Picture 6" descr="scaling_weights_compare.png"/>
+          <p:cNvPr id="8" name="Picture 7" descr="scaling_weights_compare.png"/>
           <p:cNvPicPr>
             <a:picLocks noChangeAspect="1"/>
           </p:cNvPicPr>
@@ -9634,8 +9738,8 @@
         </p:blipFill>
         <p:spPr>
           <a:xfrm>
-            <a:off x="5031801" y="3703320"/>
-            <a:ext cx="6304156" cy="2560320"/>
+            <a:off x="4145173" y="2450592"/>
+            <a:ext cx="3962612" cy="1609344"/>
           </a:xfrm>
           <a:prstGeom prst="rect">
             <a:avLst/>
@@ -9702,7 +9806,7 @@
         <p:spPr>
           <a:xfrm>
             <a:off x="640080" y="1371600"/>
-            <a:ext cx="6583680" cy="1810512"/>
+            <a:ext cx="3108960" cy="1645920"/>
           </a:xfrm>
           <a:prstGeom prst="rect">
             <a:avLst/>
@@ -9741,30 +9845,7 @@
                   <a:srgbClr val="000000"/>
                 </a:solidFill>
               </a:rPr>
-              <a:t>: при MSE сильно тянет линию — одна точка может заметно сдвинуть прямую</a:t>
-            </a:r>
-          </a:p>
-          <a:p>
-            <a:pPr>
-              <a:spcAft>
-                <a:spcPts val="800"/>
-              </a:spcAft>
-            </a:pPr>
-            <a:r>
-              <a:rPr lang="ru-RU" dirty="0" sz="2000" b="1">
-                <a:solidFill>
-                  <a:srgbClr val="000000"/>
-                </a:solidFill>
-              </a:rPr>
-              <a:t>Робастные</a:t>
-            </a:r>
-            <a:r>
-              <a:rPr lang="ru-RU" dirty="0" sz="2000">
-                <a:solidFill>
-                  <a:srgbClr val="000000"/>
-                </a:solidFill>
-              </a:rPr>
-              <a:t xml:space="preserve"> методы (MAE, `HuberRegressor`, RANSAC) меньше реагируют на выбросы, чем MSE</a:t>
+              <a:t>: при MSE сильно тянет линию — решение: MAE (`HuberRegressor`), робастные методы или чистка</a:t>
             </a:r>
           </a:p>
           <a:p>
@@ -9804,6 +9885,29 @@
               </m:oMath>
             </ns0:m>
           </a:p>
+        </p:txBody>
+      </p:sp>
+      <p:sp>
+        <p:nvSpPr>
+          <p:cNvPr id="4" name="TextBox 3"/>
+          <p:cNvSpPr txBox="1"/>
+          <p:nvPr/>
+        </p:nvSpPr>
+        <p:spPr>
+          <a:xfrm>
+            <a:off x="3886200" y="1371600"/>
+            <a:ext cx="3108960" cy="1645920"/>
+          </a:xfrm>
+          <a:prstGeom prst="rect">
+            <a:avLst/>
+          </a:prstGeom>
+          <a:noFill/>
+        </p:spPr>
+        <p:txBody>
+          <a:bodyPr wrap="square">
+            <a:spAutoFit/>
+          </a:bodyPr>
+          <a:lstStyle/>
           <a:p>
             <a:pPr>
               <a:spcAft>
@@ -9816,7 +9920,7 @@
                   <a:srgbClr val="000000"/>
                 </a:solidFill>
               </a:rPr>
-              <a:t xml:space="preserve">Перед обучением: scatter «признак vs </a:t>
+              <a:t xml:space="preserve">Всегда стройте scatter «признак vs </a:t>
             </a:r>
             <ns0:m xmlns:ns0="http://schemas.microsoft.com/office/drawing/2010/main">
               <m:oMath xmlns:m="http://schemas.openxmlformats.org/officeDocument/2006/math">
@@ -9831,14 +9935,29 @@
                   <a:srgbClr val="000000"/>
                 </a:solidFill>
               </a:rPr>
-              <a:t>» и boxplot остатков</a:t>
+              <a:t>» и boxplot остатков перед обучением</a:t>
+            </a:r>
+          </a:p>
+          <a:p>
+            <a:pPr>
+              <a:spcAft>
+                <a:spcPts val="800"/>
+              </a:spcAft>
+            </a:pPr>
+            <a:r>
+              <a:rPr lang="ru-RU" dirty="0" sz="2000">
+                <a:solidFill>
+                  <a:srgbClr val="000000"/>
+                </a:solidFill>
+              </a:rPr>
+              <a:t>Влиятельные точки диагностируют через остатки и расстояние от центра признаков</a:t>
             </a:r>
           </a:p>
         </p:txBody>
       </p:sp>
       <p:pic>
         <p:nvPicPr>
-          <p:cNvPr id="4" name="Picture 3" descr="outlier_y_effect.png"/>
+          <p:cNvPr id="5" name="Picture 4" descr="outlier_y_effect.png"/>
           <p:cNvPicPr>
             <a:picLocks noChangeAspect="1"/>
           </p:cNvPicPr>
@@ -9852,8 +9971,8 @@
         </p:blipFill>
         <p:spPr>
           <a:xfrm>
-            <a:off x="7269480" y="1589656"/>
-            <a:ext cx="2487168" cy="1685294"/>
+            <a:off x="8151212" y="1325880"/>
+            <a:ext cx="3265735" cy="2212848"/>
           </a:xfrm>
           <a:prstGeom prst="rect">
             <a:avLst/>
@@ -9862,7 +9981,7 @@
       </p:pic>
       <p:pic>
         <p:nvPicPr>
-          <p:cNvPr id="5" name="Picture 4" descr="outlier_leverage_x.png"/>
+          <p:cNvPr id="6" name="Picture 5" descr="outlier_leverage_x.png"/>
           <p:cNvPicPr>
             <a:picLocks noChangeAspect="1"/>
           </p:cNvPicPr>
@@ -9870,30 +9989,6 @@
         </p:nvPicPr>
         <p:blipFill>
           <a:blip r:embed="rId3"/>
-          <a:stretch>
-            <a:fillRect/>
-          </a:stretch>
-        </p:blipFill>
-        <p:spPr>
-          <a:xfrm>
-            <a:off x="9811512" y="1927244"/>
-            <a:ext cx="2487168" cy="1010119"/>
-          </a:xfrm>
-          <a:prstGeom prst="rect">
-            <a:avLst/>
-          </a:prstGeom>
-        </p:spPr>
-      </p:pic>
-      <p:pic>
-        <p:nvPicPr>
-          <p:cNvPr id="6" name="Picture 5" descr="outlier_scatter_boxplot.png"/>
-          <p:cNvPicPr>
-            <a:picLocks noChangeAspect="1"/>
-          </p:cNvPicPr>
-          <p:nvPr/>
-        </p:nvPicPr>
-        <p:blipFill>
-          <a:blip r:embed="rId4"/>
           <a:stretch>
             <a:fillRect/>
           </a:stretch>
@@ -9968,7 +10063,7 @@
         <p:spPr>
           <a:xfrm>
             <a:off x="640080" y="1371600"/>
-            <a:ext cx="6583680" cy="1810512"/>
+            <a:ext cx="3108960" cy="969264"/>
           </a:xfrm>
           <a:prstGeom prst="rect">
             <a:avLst/>
@@ -10034,6 +10129,29 @@
               <a:t xml:space="preserve"> нестабильны — большие, меняют знак</a:t>
             </a:r>
           </a:p>
+        </p:txBody>
+      </p:sp>
+      <p:sp>
+        <p:nvSpPr>
+          <p:cNvPr id="4" name="TextBox 3"/>
+          <p:cNvSpPr txBox="1"/>
+          <p:nvPr/>
+        </p:nvSpPr>
+        <p:spPr>
+          <a:xfrm>
+            <a:off x="3886200" y="1371600"/>
+            <a:ext cx="3108960" cy="969264"/>
+          </a:xfrm>
+          <a:prstGeom prst="rect">
+            <a:avLst/>
+          </a:prstGeom>
+          <a:noFill/>
+        </p:spPr>
+        <p:txBody>
+          <a:bodyPr wrap="square">
+            <a:spAutoFit/>
+          </a:bodyPr>
+          <a:lstStyle/>
           <a:p>
             <a:pPr>
               <a:spcAft>
@@ -10068,7 +10186,7 @@
       </p:sp>
       <p:pic>
         <p:nvPicPr>
-          <p:cNvPr id="4" name="Picture 3" descr="multicollinearity.png"/>
+          <p:cNvPr id="5" name="Picture 4" descr="multicollinearity.png"/>
           <p:cNvPicPr>
             <a:picLocks noChangeAspect="1"/>
           </p:cNvPicPr>
@@ -10082,8 +10200,8 @@
         </p:blipFill>
         <p:spPr>
           <a:xfrm>
-            <a:off x="5031801" y="3703320"/>
-            <a:ext cx="6304156" cy="2560320"/>
+            <a:off x="3368411" y="2450592"/>
+            <a:ext cx="5516136" cy="2240280"/>
           </a:xfrm>
           <a:prstGeom prst="rect">
             <a:avLst/>

</xml_diff>

<commit_message>
Fix visual/text overlap with two-column bullets and dynamic wide-band placement. (#20)
Co-authored-by: Cursor <cursoragent@cursor.com>
</commit_message>
<xml_diff>
--- a/lessons/lineynaya_regressiya/presentation.pptx
+++ b/lessons/lineynaya_regressiya/presentation.pptx
@@ -4845,7 +4845,7 @@
         <p:spPr>
           <a:xfrm>
             <a:off x="640080" y="1371600"/>
-            <a:ext cx="6583680" cy="3035807"/>
+            <a:ext cx="3108960" cy="969264"/>
           </a:xfrm>
           <a:prstGeom prst="rect">
             <a:avLst/>
@@ -4887,6 +4887,29 @@
               <a:t>Линейная модель с малым числом признаков переобучается реже деревьев, но шум в данных всё равно завышает метрики на train</a:t>
             </a:r>
           </a:p>
+        </p:txBody>
+      </p:sp>
+      <p:sp>
+        <p:nvSpPr>
+          <p:cNvPr id="4" name="TextBox 3"/>
+          <p:cNvSpPr txBox="1"/>
+          <p:nvPr/>
+        </p:nvSpPr>
+        <p:spPr>
+          <a:xfrm>
+            <a:off x="3886200" y="1371600"/>
+            <a:ext cx="3108960" cy="969264"/>
+          </a:xfrm>
+          <a:prstGeom prst="rect">
+            <a:avLst/>
+          </a:prstGeom>
+          <a:noFill/>
+        </p:spPr>
+        <p:txBody>
+          <a:bodyPr wrap="square">
+            <a:normAutofit/>
+          </a:bodyPr>
+          <a:lstStyle/>
           <a:p>
             <a:pPr>
               <a:spcAft>
@@ -4921,7 +4944,7 @@
       </p:sp>
       <p:sp>
         <p:nvSpPr>
-          <p:cNvPr id="4" name="Rectangle 3"/>
+          <p:cNvPr id="5" name="Rectangle 4"/>
           <p:cNvSpPr/>
           <p:nvPr/>
         </p:nvSpPr>
@@ -4966,7 +4989,7 @@
       </p:sp>
       <p:sp>
         <p:nvSpPr>
-          <p:cNvPr id="5" name="TextBox 4"/>
+          <p:cNvPr id="6" name="TextBox 5"/>
           <p:cNvSpPr txBox="1"/>
           <p:nvPr/>
         </p:nvSpPr>
@@ -5069,7 +5092,7 @@
       </p:sp>
       <p:sp>
         <p:nvSpPr>
-          <p:cNvPr id="6" name="TextBox 5"/>
+          <p:cNvPr id="7" name="TextBox 6"/>
           <p:cNvSpPr txBox="1"/>
           <p:nvPr/>
         </p:nvSpPr>
@@ -5104,7 +5127,7 @@
       </p:sp>
       <p:pic>
         <p:nvPicPr>
-          <p:cNvPr id="7" name="Picture 6" descr="train_test_split.png"/>
+          <p:cNvPr id="8" name="Picture 7" descr="train_test_split.png"/>
           <p:cNvPicPr>
             <a:picLocks noChangeAspect="1"/>
           </p:cNvPicPr>
@@ -5118,8 +5141,8 @@
         </p:blipFill>
         <p:spPr>
           <a:xfrm>
-            <a:off x="5037749" y="3703320"/>
-            <a:ext cx="6292261" cy="2560320"/>
+            <a:off x="3721937" y="2450592"/>
+            <a:ext cx="4809085" cy="1956816"/>
           </a:xfrm>
           <a:prstGeom prst="rect">
             <a:avLst/>
@@ -5186,7 +5209,7 @@
         <p:spPr>
           <a:xfrm>
             <a:off x="640080" y="1371600"/>
-            <a:ext cx="6583680" cy="2194560"/>
+            <a:ext cx="3108960" cy="969264"/>
           </a:xfrm>
           <a:prstGeom prst="rect">
             <a:avLst/>
@@ -5274,25 +5297,32 @@
                   <a:srgbClr val="000000"/>
                 </a:solidFill>
               </a:rPr>
-              <a:t xml:space="preserve"> — сжимает веса </a:t>
-            </a:r>
-            <a:r>
-              <a:rPr lang="ru-RU" dirty="0" sz="2000" b="1">
-                <a:solidFill>
-                  <a:srgbClr val="000000"/>
-                </a:solidFill>
-              </a:rPr>
-              <a:t>вместе</a:t>
-            </a:r>
-            <a:r>
-              <a:rPr lang="ru-RU" dirty="0" sz="2000">
-                <a:solidFill>
-                  <a:srgbClr val="000000"/>
-                </a:solidFill>
-              </a:rPr>
-              <a:t>, не обнуляя; стабилизирует при мультиколлинеарности</a:t>
-            </a:r>
-          </a:p>
+              <a:t xml:space="preserve"> — сжимает веса, помогает при мультиколлинеарности</a:t>
+            </a:r>
+          </a:p>
+        </p:txBody>
+      </p:sp>
+      <p:sp>
+        <p:nvSpPr>
+          <p:cNvPr id="4" name="TextBox 3"/>
+          <p:cNvSpPr txBox="1"/>
+          <p:nvPr/>
+        </p:nvSpPr>
+        <p:spPr>
+          <a:xfrm>
+            <a:off x="3886200" y="1371600"/>
+            <a:ext cx="3108960" cy="969264"/>
+          </a:xfrm>
+          <a:prstGeom prst="rect">
+            <a:avLst/>
+          </a:prstGeom>
+          <a:noFill/>
+        </p:spPr>
+        <p:txBody>
+          <a:bodyPr wrap="square">
+            <a:spAutoFit/>
+          </a:bodyPr>
+          <a:lstStyle/>
           <a:p>
             <a:pPr>
               <a:spcAft>
@@ -5355,38 +5385,7 @@
                   <a:srgbClr val="000000"/>
                 </a:solidFill>
               </a:rPr>
-              <a:t xml:space="preserve"> — обнуляет слабые признаки → отбор фич, но не лечит дублирующие столбцы</a:t>
-            </a:r>
-          </a:p>
-          <a:p>
-            <a:pPr>
-              <a:spcAft>
-                <a:spcPts val="800"/>
-              </a:spcAft>
-            </a:pPr>
-            <a:r>
-              <a:rPr lang="ru-RU" dirty="0" sz="2000">
-                <a:solidFill>
-                  <a:srgbClr val="000000"/>
-                </a:solidFill>
-              </a:rPr>
-              <a:t xml:space="preserve">При коррелированных признаках предпочтите </a:t>
-            </a:r>
-            <a:r>
-              <a:rPr lang="ru-RU" dirty="0" sz="2000" b="1">
-                <a:solidFill>
-                  <a:srgbClr val="000000"/>
-                </a:solidFill>
-              </a:rPr>
-              <a:t>Ridge</a:t>
-            </a:r>
-            <a:r>
-              <a:rPr lang="ru-RU" dirty="0" sz="2000">
-                <a:solidFill>
-                  <a:srgbClr val="000000"/>
-                </a:solidFill>
-              </a:rPr>
-              <a:t>; Lasso выберет один из дублей случайно</a:t>
+              <a:t xml:space="preserve"> — может обнулять веса → отбор признаков</a:t>
             </a:r>
           </a:p>
           <a:p>
@@ -5416,14 +5415,14 @@
                   <a:srgbClr val="000000"/>
                 </a:solidFill>
               </a:rPr>
-              <a:t xml:space="preserve"> подбирают по validation / cross-validation (см. график)</a:t>
+              <a:t xml:space="preserve"> подбирают по validation / cross-validation</a:t>
             </a:r>
           </a:p>
         </p:txBody>
       </p:sp>
       <p:pic>
         <p:nvPicPr>
-          <p:cNvPr id="4" name="Picture 3" descr="regularization_weights.png"/>
+          <p:cNvPr id="5" name="Picture 4" descr="regularization_weights.png"/>
           <p:cNvPicPr>
             <a:picLocks noChangeAspect="1"/>
           </p:cNvPicPr>
@@ -5437,32 +5436,8 @@
         </p:blipFill>
         <p:spPr>
           <a:xfrm>
-            <a:off x="7269480" y="1359615"/>
-            <a:ext cx="5029200" cy="2145377"/>
-          </a:xfrm>
-          <a:prstGeom prst="rect">
-            <a:avLst/>
-          </a:prstGeom>
-        </p:spPr>
-      </p:pic>
-      <p:pic>
-        <p:nvPicPr>
-          <p:cNvPr id="5" name="Picture 4" descr="ridge_alpha_cv.png"/>
-          <p:cNvPicPr>
-            <a:picLocks noChangeAspect="1"/>
-          </p:cNvPicPr>
-          <p:nvPr/>
-        </p:nvPicPr>
-        <p:blipFill>
-          <a:blip r:embed="rId3"/>
-          <a:stretch>
-            <a:fillRect/>
-          </a:stretch>
-        </p:blipFill>
-        <p:spPr>
-          <a:xfrm>
-            <a:off x="8231517" y="3593592"/>
-            <a:ext cx="3105125" cy="2212848"/>
+            <a:off x="3500644" y="2450592"/>
+            <a:ext cx="5251670" cy="2240280"/>
           </a:xfrm>
           <a:prstGeom prst="rect">
             <a:avLst/>
@@ -5529,7 +5504,7 @@
         <p:spPr>
           <a:xfrm>
             <a:off x="640080" y="1371600"/>
-            <a:ext cx="6583680" cy="3035807"/>
+            <a:ext cx="3108960" cy="969264"/>
           </a:xfrm>
           <a:prstGeom prst="rect">
             <a:avLst/>
@@ -5612,6 +5587,29 @@
               <a:t xml:space="preserve"> — сильнее штрафует крупные промахи</a:t>
             </a:r>
           </a:p>
+        </p:txBody>
+      </p:sp>
+      <p:sp>
+        <p:nvSpPr>
+          <p:cNvPr id="4" name="TextBox 3"/>
+          <p:cNvSpPr txBox="1"/>
+          <p:nvPr/>
+        </p:nvSpPr>
+        <p:spPr>
+          <a:xfrm>
+            <a:off x="3886200" y="1371600"/>
+            <a:ext cx="3108960" cy="969264"/>
+          </a:xfrm>
+          <a:prstGeom prst="rect">
+            <a:avLst/>
+          </a:prstGeom>
+          <a:noFill/>
+        </p:spPr>
+        <p:txBody>
+          <a:bodyPr wrap="square">
+            <a:normAutofit/>
+          </a:bodyPr>
+          <a:lstStyle/>
           <a:p>
             <a:pPr>
               <a:spcAft>
@@ -5708,14 +5706,14 @@
       </p:sp>
       <p:sp>
         <p:nvSpPr>
-          <p:cNvPr id="4" name="Rectangle 3"/>
+          <p:cNvPr id="5" name="Rectangle 4"/>
           <p:cNvSpPr/>
           <p:nvPr/>
         </p:nvSpPr>
         <p:spPr>
           <a:xfrm>
-            <a:off x="640080" y="4517136"/>
-            <a:ext cx="6492240" cy="978407"/>
+            <a:off x="640080" y="4690872"/>
+            <a:ext cx="6492240" cy="804672"/>
           </a:xfrm>
           <a:prstGeom prst="rect">
             <a:avLst/>
@@ -5753,14 +5751,14 @@
       </p:sp>
       <p:sp>
         <p:nvSpPr>
-          <p:cNvPr id="5" name="TextBox 4"/>
+          <p:cNvPr id="6" name="TextBox 5"/>
           <p:cNvSpPr txBox="1"/>
           <p:nvPr/>
         </p:nvSpPr>
         <p:spPr>
           <a:xfrm>
-            <a:off x="713231" y="4553712"/>
-            <a:ext cx="6345936" cy="905255"/>
+            <a:off x="713231" y="4727448"/>
+            <a:ext cx="6345936" cy="731520"/>
           </a:xfrm>
           <a:prstGeom prst="rect">
             <a:avLst/>
@@ -5785,7 +5783,7 @@
                 </a:solidFill>
                 <a:latin typeface="Consolas"/>
               </a:rPr>
-              <a:t>from sklearn.metrics import mean_absolute_error, mean_squared_error, r2_score</a:t>
+              <a:t>from sklearn.metrics import mean_absolute_error, r2_score</a:t>
             </a:r>
           </a:p>
           <a:p>
@@ -5817,7 +5815,7 @@
                 </a:solidFill>
                 <a:latin typeface="Consolas"/>
               </a:rPr>
-              <a:t>rmse = mean_squared_error(y_te, y_pred, squared=False)</a:t>
+              <a:t>r2 = r2_score(y_te, y_pred)</a:t>
             </a:r>
           </a:p>
           <a:p>
@@ -5833,36 +5831,20 @@
                 </a:solidFill>
                 <a:latin typeface="Consolas"/>
               </a:rPr>
-              <a:t>r2 = r2_score(y_te, y_pred)</a:t>
-            </a:r>
-          </a:p>
-          <a:p>
-            <a:pPr>
-              <a:spcAft>
-                <a:spcPts val="0"/>
-              </a:spcAft>
-            </a:pPr>
-            <a:r>
-              <a:rPr sz="1100">
-                <a:solidFill>
-                  <a:srgbClr val="000000"/>
-                </a:solidFill>
-                <a:latin typeface="Consolas"/>
-              </a:rPr>
-              <a:t>print(f'MAE={mae:.2f}, RMSE={rmse:.2f}, R²={r2:.3f}')</a:t>
-            </a:r>
-          </a:p>
-        </p:txBody>
-      </p:sp>
-      <p:sp>
-        <p:nvSpPr>
-          <p:cNvPr id="6" name="TextBox 5"/>
+              <a:t>print(f'MAE={mae:.2f}, R²={r2:.3f}')</a:t>
+            </a:r>
+          </a:p>
+        </p:txBody>
+      </p:sp>
+      <p:sp>
+        <p:nvSpPr>
+          <p:cNvPr id="7" name="TextBox 6"/>
           <p:cNvSpPr txBox="1"/>
           <p:nvPr/>
         </p:nvSpPr>
         <p:spPr>
           <a:xfrm>
-            <a:off x="640080" y="5550407"/>
+            <a:off x="640080" y="5550408"/>
             <a:ext cx="6492240" cy="201168"/>
           </a:xfrm>
           <a:prstGeom prst="rect">
@@ -5884,14 +5866,14 @@
               </a:defRPr>
             </a:pPr>
             <a:r>
-              <a:t>MAE, RMSE и R²</a:t>
+              <a:t>MAE и R²</a:t>
             </a:r>
           </a:p>
         </p:txBody>
       </p:sp>
       <p:pic>
         <p:nvPicPr>
-          <p:cNvPr id="7" name="Picture 6" descr="regression_metrics_bar.png"/>
+          <p:cNvPr id="8" name="Picture 7" descr="regression_metrics_bar.png"/>
           <p:cNvPicPr>
             <a:picLocks noChangeAspect="1"/>
           </p:cNvPicPr>
@@ -5905,8 +5887,8 @@
         </p:blipFill>
         <p:spPr>
           <a:xfrm>
-            <a:off x="7269480" y="1774146"/>
-            <a:ext cx="5029200" cy="3584028"/>
+            <a:off x="7500144" y="1325880"/>
+            <a:ext cx="4567870" cy="3255264"/>
           </a:xfrm>
           <a:prstGeom prst="rect">
             <a:avLst/>
@@ -5973,7 +5955,7 @@
         <p:spPr>
           <a:xfrm>
             <a:off x="640080" y="1371600"/>
-            <a:ext cx="6583680" cy="1810512"/>
+            <a:ext cx="3108960" cy="969264"/>
           </a:xfrm>
           <a:prstGeom prst="rect">
             <a:avLst/>
@@ -6054,6 +6036,29 @@
               <a:t>Хорошо: случайное облако вокруг нуля, без тренда (гомоскедастичность)</a:t>
             </a:r>
           </a:p>
+        </p:txBody>
+      </p:sp>
+      <p:sp>
+        <p:nvSpPr>
+          <p:cNvPr id="4" name="TextBox 3"/>
+          <p:cNvSpPr txBox="1"/>
+          <p:nvPr/>
+        </p:nvSpPr>
+        <p:spPr>
+          <a:xfrm>
+            <a:off x="3886200" y="1371600"/>
+            <a:ext cx="3108960" cy="969264"/>
+          </a:xfrm>
+          <a:prstGeom prst="rect">
+            <a:avLst/>
+          </a:prstGeom>
+          <a:noFill/>
+        </p:spPr>
+        <p:txBody>
+          <a:bodyPr wrap="square">
+            <a:spAutoFit/>
+          </a:bodyPr>
+          <a:lstStyle/>
           <a:p>
             <a:pPr>
               <a:spcAft>
@@ -6103,7 +6108,7 @@
       </p:sp>
       <p:pic>
         <p:nvPicPr>
-          <p:cNvPr id="4" name="Picture 3" descr="residual_diagnostics.png"/>
+          <p:cNvPr id="5" name="Picture 4" descr="residual_diagnostics.png"/>
           <p:cNvPicPr>
             <a:picLocks noChangeAspect="1"/>
           </p:cNvPicPr>
@@ -6117,8 +6122,8 @@
         </p:blipFill>
         <p:spPr>
           <a:xfrm>
-            <a:off x="4572000" y="3731449"/>
-            <a:ext cx="7223760" cy="2504062"/>
+            <a:off x="2895081" y="2450592"/>
+            <a:ext cx="6462797" cy="2240280"/>
           </a:xfrm>
           <a:prstGeom prst="rect">
             <a:avLst/>
@@ -6185,7 +6190,7 @@
         <p:spPr>
           <a:xfrm>
             <a:off x="640080" y="1371600"/>
-            <a:ext cx="6583680" cy="1810512"/>
+            <a:ext cx="3108960" cy="1645920"/>
           </a:xfrm>
           <a:prstGeom prst="rect">
             <a:avLst/>
@@ -6291,6 +6296,29 @@
               <a:t>Ceteris paribus — «при прочих равных»; в реальных данных признаки коррелированы</a:t>
             </a:r>
           </a:p>
+        </p:txBody>
+      </p:sp>
+      <p:sp>
+        <p:nvSpPr>
+          <p:cNvPr id="4" name="TextBox 3"/>
+          <p:cNvSpPr txBox="1"/>
+          <p:nvPr/>
+        </p:nvSpPr>
+        <p:spPr>
+          <a:xfrm>
+            <a:off x="3886200" y="1371600"/>
+            <a:ext cx="3108960" cy="1645920"/>
+          </a:xfrm>
+          <a:prstGeom prst="rect">
+            <a:avLst/>
+          </a:prstGeom>
+          <a:noFill/>
+        </p:spPr>
+        <p:txBody>
+          <a:bodyPr wrap="square">
+            <a:spAutoFit/>
+          </a:bodyPr>
+          <a:lstStyle/>
           <a:p>
             <a:pPr>
               <a:spcAft>
@@ -6325,7 +6353,7 @@
       </p:sp>
       <p:pic>
         <p:nvPicPr>
-          <p:cNvPr id="4" name="Picture 3" descr="standardized_weights.png"/>
+          <p:cNvPr id="5" name="Picture 4" descr="standardized_weights.png"/>
           <p:cNvPicPr>
             <a:picLocks noChangeAspect="1"/>
           </p:cNvPicPr>
@@ -6339,7 +6367,7 @@
         </p:blipFill>
         <p:spPr>
           <a:xfrm>
-            <a:off x="7269480" y="1789462"/>
+            <a:off x="7269480" y="1752886"/>
             <a:ext cx="5029200" cy="3553395"/>
           </a:xfrm>
           <a:prstGeom prst="rect">
@@ -6407,7 +6435,7 @@
         <p:spPr>
           <a:xfrm>
             <a:off x="640080" y="1371600"/>
-            <a:ext cx="6583680" cy="2514599"/>
+            <a:ext cx="3108960" cy="969264"/>
           </a:xfrm>
           <a:prstGeom prst="rect">
             <a:avLst/>
@@ -6465,6 +6493,29 @@
               <a:t xml:space="preserve"> split — статистики теста попадают в train</a:t>
             </a:r>
           </a:p>
+        </p:txBody>
+      </p:sp>
+      <p:sp>
+        <p:nvSpPr>
+          <p:cNvPr id="4" name="TextBox 3"/>
+          <p:cNvSpPr txBox="1"/>
+          <p:nvPr/>
+        </p:nvSpPr>
+        <p:spPr>
+          <a:xfrm>
+            <a:off x="3886200" y="1371600"/>
+            <a:ext cx="3108960" cy="969264"/>
+          </a:xfrm>
+          <a:prstGeom prst="rect">
+            <a:avLst/>
+          </a:prstGeom>
+          <a:noFill/>
+        </p:spPr>
+        <p:txBody>
+          <a:bodyPr wrap="square">
+            <a:normAutofit/>
+          </a:bodyPr>
+          <a:lstStyle/>
           <a:p>
             <a:pPr>
               <a:spcAft>
@@ -6499,7 +6550,7 @@
       </p:sp>
       <p:sp>
         <p:nvSpPr>
-          <p:cNvPr id="4" name="Rectangle 3"/>
+          <p:cNvPr id="5" name="Rectangle 4"/>
           <p:cNvSpPr/>
           <p:nvPr/>
         </p:nvSpPr>
@@ -6544,7 +6595,7 @@
       </p:sp>
       <p:sp>
         <p:nvSpPr>
-          <p:cNvPr id="5" name="TextBox 4"/>
+          <p:cNvPr id="6" name="TextBox 5"/>
           <p:cNvSpPr txBox="1"/>
           <p:nvPr/>
         </p:nvSpPr>
@@ -6695,7 +6746,7 @@
       </p:sp>
       <p:sp>
         <p:nvSpPr>
-          <p:cNvPr id="6" name="TextBox 5"/>
+          <p:cNvPr id="7" name="TextBox 6"/>
           <p:cNvSpPr txBox="1"/>
           <p:nvPr/>
         </p:nvSpPr>
@@ -6730,7 +6781,7 @@
       </p:sp>
       <p:pic>
         <p:nvPicPr>
-          <p:cNvPr id="7" name="Picture 6" descr="pipeline_leakage.png"/>
+          <p:cNvPr id="8" name="Picture 7" descr="pipeline_leakage.png"/>
           <p:cNvPicPr>
             <a:picLocks noChangeAspect="1"/>
           </p:cNvPicPr>
@@ -6744,8 +6795,8 @@
         </p:blipFill>
         <p:spPr>
           <a:xfrm>
-            <a:off x="4627306" y="3703320"/>
-            <a:ext cx="7113147" cy="2560320"/>
+            <a:off x="4132258" y="2450592"/>
+            <a:ext cx="3988443" cy="1435608"/>
           </a:xfrm>
           <a:prstGeom prst="rect">
             <a:avLst/>
@@ -6812,7 +6863,7 @@
         <p:spPr>
           <a:xfrm>
             <a:off x="640080" y="1371600"/>
-            <a:ext cx="6583680" cy="1810512"/>
+            <a:ext cx="3108960" cy="969264"/>
           </a:xfrm>
           <a:prstGeom prst="rect">
             <a:avLst/>
@@ -6851,7 +6902,7 @@
                   <a:srgbClr val="000000"/>
                 </a:solidFill>
               </a:rPr>
-              <a:t xml:space="preserve">Эффект одного признака зависит от другого, но в модели нет произведения </a:t>
+              <a:t>Сильное взаимодействие признаков без явных фичей (</a:t>
             </a:r>
             <ns0:m xmlns:ns0="http://schemas.microsoft.com/office/drawing/2010/main">
               <m:oMath xmlns:m="http://schemas.openxmlformats.org/officeDocument/2006/math">
@@ -6890,9 +6941,32 @@
                   <a:srgbClr val="000000"/>
                 </a:solidFill>
               </a:rPr>
-              <a:t xml:space="preserve"> — линейная формула это не описывает</a:t>
-            </a:r>
-          </a:p>
+              <a:t>)</a:t>
+            </a:r>
+          </a:p>
+        </p:txBody>
+      </p:sp>
+      <p:sp>
+        <p:nvSpPr>
+          <p:cNvPr id="4" name="TextBox 3"/>
+          <p:cNvSpPr txBox="1"/>
+          <p:nvPr/>
+        </p:nvSpPr>
+        <p:spPr>
+          <a:xfrm>
+            <a:off x="3886200" y="1371600"/>
+            <a:ext cx="3108960" cy="969264"/>
+          </a:xfrm>
+          <a:prstGeom prst="rect">
+            <a:avLst/>
+          </a:prstGeom>
+          <a:noFill/>
+        </p:spPr>
+        <p:txBody>
+          <a:bodyPr wrap="square">
+            <a:spAutoFit/>
+          </a:bodyPr>
+          <a:lstStyle/>
           <a:p>
             <a:pPr>
               <a:spcAft>
@@ -6942,7 +7016,7 @@
       </p:sp>
       <p:pic>
         <p:nvPicPr>
-          <p:cNvPr id="4" name="Picture 3" descr="nonlinear_vs_linear.png"/>
+          <p:cNvPr id="5" name="Picture 4" descr="nonlinear_vs_linear.png"/>
           <p:cNvPicPr>
             <a:picLocks noChangeAspect="1"/>
           </p:cNvPicPr>
@@ -6956,8 +7030,8 @@
         </p:blipFill>
         <p:spPr>
           <a:xfrm>
-            <a:off x="5103169" y="3703320"/>
-            <a:ext cx="6161420" cy="2560320"/>
+            <a:off x="3430858" y="2450592"/>
+            <a:ext cx="5391242" cy="2240280"/>
           </a:xfrm>
           <a:prstGeom prst="rect">
             <a:avLst/>
@@ -7257,7 +7331,7 @@
                 </a:solidFill>
                 <a:hlinkClick r:id="rId2"/>
               </a:rPr>
-              <a:t>Markov A.A. (1900). Least Squares Estimation of Linear Models</a:t>
+              <a:t>Hoerl A.E., Kennard R.W. (1970). Ridge Regression: Biased Estimation for Nonorthogonal Problems</a:t>
             </a:r>
           </a:p>
         </p:txBody>
@@ -7304,7 +7378,7 @@
                 </a:solidFill>
                 <a:hlinkClick r:id="rId3"/>
               </a:rPr>
-              <a:t>Hoerl A.E., Kennard R.W. (1970). Ridge Regression: Biased Estimation for Nonorthogonal Problems</a:t>
+              <a:t>Tibshirani R. (1996). Regression Shrinkage and Selection via the Lasso</a:t>
             </a:r>
           </a:p>
         </p:txBody>
@@ -7351,7 +7425,7 @@
                 </a:solidFill>
                 <a:hlinkClick r:id="rId4"/>
               </a:rPr>
-              <a:t>Tibshirani R. (1996). Regression Shrinkage and Selection via the Lasso</a:t>
+              <a:t>Markov A.A. (1900). Least Squares Estimation of Linear Models</a:t>
             </a:r>
           </a:p>
         </p:txBody>
@@ -7653,7 +7727,7 @@
         <p:spPr>
           <a:xfrm>
             <a:off x="640080" y="1371600"/>
-            <a:ext cx="6583680" cy="1810512"/>
+            <a:ext cx="3108960" cy="1645920"/>
           </a:xfrm>
           <a:prstGeom prst="rect">
             <a:avLst/>
@@ -7710,6 +7784,29 @@
               <a:t xml:space="preserve"> — прямая на плоскости «признак → ответ»</a:t>
             </a:r>
           </a:p>
+        </p:txBody>
+      </p:sp>
+      <p:sp>
+        <p:nvSpPr>
+          <p:cNvPr id="4" name="TextBox 3"/>
+          <p:cNvSpPr txBox="1"/>
+          <p:nvPr/>
+        </p:nvSpPr>
+        <p:spPr>
+          <a:xfrm>
+            <a:off x="3886200" y="1371600"/>
+            <a:ext cx="3108960" cy="1645920"/>
+          </a:xfrm>
+          <a:prstGeom prst="rect">
+            <a:avLst/>
+          </a:prstGeom>
+          <a:noFill/>
+        </p:spPr>
+        <p:txBody>
+          <a:bodyPr wrap="square">
+            <a:spAutoFit/>
+          </a:bodyPr>
+          <a:lstStyle/>
           <a:p>
             <a:pPr>
               <a:spcAft>
@@ -7774,7 +7871,7 @@
       </p:sp>
       <p:pic>
         <p:nvPicPr>
-          <p:cNvPr id="4" name="Picture 3" descr="intro_scatter_line.png"/>
+          <p:cNvPr id="5" name="Picture 4" descr="intro_scatter_line.png"/>
           <p:cNvPicPr>
             <a:picLocks noChangeAspect="1"/>
           </p:cNvPicPr>
@@ -7788,7 +7885,7 @@
         </p:blipFill>
         <p:spPr>
           <a:xfrm>
-            <a:off x="7269480" y="1774146"/>
+            <a:off x="7269480" y="1737570"/>
             <a:ext cx="5029200" cy="3584028"/>
           </a:xfrm>
           <a:prstGeom prst="rect">
@@ -7856,7 +7953,7 @@
         <p:spPr>
           <a:xfrm>
             <a:off x="640080" y="1371600"/>
-            <a:ext cx="6583680" cy="1810512"/>
+            <a:ext cx="3108960" cy="1645920"/>
           </a:xfrm>
           <a:prstGeom prst="rect">
             <a:avLst/>
@@ -7975,6 +8072,29 @@
               <a:t xml:space="preserve"> — разница между фактом и прогнозом</a:t>
             </a:r>
           </a:p>
+        </p:txBody>
+      </p:sp>
+      <p:sp>
+        <p:nvSpPr>
+          <p:cNvPr id="4" name="TextBox 3"/>
+          <p:cNvSpPr txBox="1"/>
+          <p:nvPr/>
+        </p:nvSpPr>
+        <p:spPr>
+          <a:xfrm>
+            <a:off x="3886200" y="1371600"/>
+            <a:ext cx="3108960" cy="1645920"/>
+          </a:xfrm>
+          <a:prstGeom prst="rect">
+            <a:avLst/>
+          </a:prstGeom>
+          <a:noFill/>
+        </p:spPr>
+        <p:txBody>
+          <a:bodyPr wrap="square">
+            <a:spAutoFit/>
+          </a:bodyPr>
+          <a:lstStyle/>
           <a:p>
             <a:pPr>
               <a:spcAft>
@@ -7982,65 +8102,12 @@
               </a:spcAft>
             </a:pPr>
             <a:r>
-              <a:rPr lang="ru-RU" dirty="0" sz="2000" b="1">
-                <a:solidFill>
-                  <a:srgbClr val="000000"/>
-                </a:solidFill>
-              </a:rPr>
-              <a:t>Intercept</a:t>
-            </a:r>
-            <a:r>
               <a:rPr lang="ru-RU" dirty="0" sz="2000">
                 <a:solidFill>
                   <a:srgbClr val="000000"/>
                 </a:solidFill>
               </a:rPr>
-              <a:t xml:space="preserve"> (</a:t>
-            </a:r>
-            <ns0:m xmlns:ns0="http://schemas.microsoft.com/office/drawing/2010/main">
-              <m:oMath xmlns:m="http://schemas.openxmlformats.org/officeDocument/2006/math">
-                <m:r>
-                  <m:t>b</m:t>
-                </m:r>
-              </m:oMath>
-            </ns0:m>
-            <a:r>
-              <a:rPr lang="ru-RU" dirty="0" sz="2000">
-                <a:solidFill>
-                  <a:srgbClr val="000000"/>
-                </a:solidFill>
-              </a:rPr>
-              <a:t xml:space="preserve">): прогноз при </a:t>
-            </a:r>
-            <ns0:m xmlns:ns0="http://schemas.microsoft.com/office/drawing/2010/main">
-              <m:oMath xmlns:m="http://schemas.openxmlformats.org/officeDocument/2006/math">
-                <m:r>
-                  <m:t>x=0</m:t>
-                </m:r>
-              </m:oMath>
-            </ns0:m>
-            <a:r>
-              <a:rPr lang="ru-RU" dirty="0" sz="2000">
-                <a:solidFill>
-                  <a:srgbClr val="000000"/>
-                </a:solidFill>
-              </a:rPr>
-              <a:t xml:space="preserve">; в sklearn — параметр `fit_intercept=True` (смещение прямой по оси </a:t>
-            </a:r>
-            <ns0:m xmlns:ns0="http://schemas.microsoft.com/office/drawing/2010/main">
-              <m:oMath xmlns:m="http://schemas.openxmlformats.org/officeDocument/2006/math">
-                <m:r>
-                  <m:t>y</m:t>
-                </m:r>
-              </m:oMath>
-            </ns0:m>
-            <a:r>
-              <a:rPr lang="ru-RU" dirty="0" sz="2000">
-                <a:solidFill>
-                  <a:srgbClr val="000000"/>
-                </a:solidFill>
-              </a:rPr>
-              <a:t>)</a:t>
+              <a:t>Хорошая модель: остатки симметрично разбросаны вокруг нуля, без систематического смещения</a:t>
             </a:r>
           </a:p>
           <a:p>
@@ -8055,14 +8122,14 @@
                   <a:srgbClr val="000000"/>
                 </a:solidFill>
               </a:rPr>
-              <a:t>Хорошая модель: остатки симметрично разбросаны вокруг нуля, без систематического смещения</a:t>
+              <a:t>Сумма остатков на обучающей выборке при МНК равна нулю (для модели с intercept)</a:t>
             </a:r>
           </a:p>
         </p:txBody>
       </p:sp>
       <p:pic>
         <p:nvPicPr>
-          <p:cNvPr id="4" name="Picture 3" descr="residuals_vertical.png"/>
+          <p:cNvPr id="5" name="Picture 4" descr="residuals_vertical.png"/>
           <p:cNvPicPr>
             <a:picLocks noChangeAspect="1"/>
           </p:cNvPicPr>
@@ -8086,7 +8153,7 @@
       </p:pic>
       <p:pic>
         <p:nvPicPr>
-          <p:cNvPr id="5" name="Picture 4" descr="residuals_histogram.png"/>
+          <p:cNvPr id="6" name="Picture 5" descr="residuals_histogram.png"/>
           <p:cNvPicPr>
             <a:picLocks noChangeAspect="1"/>
           </p:cNvPicPr>
@@ -8168,7 +8235,7 @@
         <p:spPr>
           <a:xfrm>
             <a:off x="640080" y="1371600"/>
-            <a:ext cx="6583680" cy="2194560"/>
+            <a:ext cx="3108960" cy="1645920"/>
           </a:xfrm>
           <a:prstGeom prst="rect">
             <a:avLst/>
@@ -8300,85 +8367,7 @@
                   <a:srgbClr val="000000"/>
                 </a:solidFill>
               </a:rPr>
-              <a:t xml:space="preserve">Минимизация </a:t>
-            </a:r>
-            <ns0:m xmlns:ns0="http://schemas.microsoft.com/office/drawing/2010/main">
-              <m:oMath xmlns:m="http://schemas.openxmlformats.org/officeDocument/2006/math">
-                <m:nary>
-                  <m:naryPr>
-                    <m:chr m:val="∑"/>
-                    <m:limLoc m:val="subSup"/>
-                    <m:grow m:val="1"/>
-                    <m:subHide m:val="off"/>
-                    <m:supHide m:val="on"/>
-                  </m:naryPr>
-                  <m:sub>
-                    <m:r>
-                      <m:t>i</m:t>
-                    </m:r>
-                  </m:sub>
-                  <m:sup/>
-                  <m:e>
-                    <m:r>
-                      <m:t>(</m:t>
-                    </m:r>
-                  </m:e>
-                </m:nary>
-                <m:sSub>
-                  <m:e>
-                    <m:r>
-                      <m:t>y</m:t>
-                    </m:r>
-                  </m:e>
-                  <m:sub>
-                    <m:r>
-                      <m:t>i</m:t>
-                    </m:r>
-                  </m:sub>
-                </m:sSub>
-                <m:r>
-                  <m:t>−</m:t>
-                </m:r>
-                <m:sSub>
-                  <m:e>
-                    <m:acc>
-                      <m:accPr>
-                        <m:chr m:val="̂"/>
-                      </m:accPr>
-                      <m:e>
-                        <m:r>
-                          <m:t>y</m:t>
-                        </m:r>
-                      </m:e>
-                    </m:acc>
-                  </m:e>
-                  <m:sub>
-                    <m:r>
-                      <m:t>i</m:t>
-                    </m:r>
-                  </m:sub>
-                </m:sSub>
-                <m:sSup>
-                  <m:e>
-                    <m:r>
-                      <m:t>)</m:t>
-                    </m:r>
-                  </m:e>
-                  <m:sup>
-                    <m:r>
-                      <m:t>2</m:t>
-                    </m:r>
-                  </m:sup>
-                </m:sSup>
-              </m:oMath>
-            </ns0:m>
-            <a:r>
-              <a:rPr lang="ru-RU" dirty="0" sz="2000">
-                <a:solidFill>
-                  <a:srgbClr val="000000"/>
-                </a:solidFill>
-              </a:rPr>
-              <a:t xml:space="preserve"> без деления на </a:t>
+              <a:t xml:space="preserve">Сумму без деления на </a:t>
             </a:r>
             <ns0:m xmlns:ns0="http://schemas.microsoft.com/office/drawing/2010/main">
               <m:oMath xmlns:m="http://schemas.openxmlformats.org/officeDocument/2006/math">
@@ -8393,22 +8382,7 @@
                   <a:srgbClr val="000000"/>
                 </a:solidFill>
               </a:rPr>
-              <a:t xml:space="preserve"> даёт те же оптимальные веса; деление на </a:t>
-            </a:r>
-            <ns0:m xmlns:ns0="http://schemas.microsoft.com/office/drawing/2010/main">
-              <m:oMath xmlns:m="http://schemas.openxmlformats.org/officeDocument/2006/math">
-                <m:r>
-                  <m:t>N</m:t>
-                </m:r>
-              </m:oMath>
-            </ns0:m>
-            <a:r>
-              <a:rPr lang="ru-RU" dirty="0" sz="2000">
-                <a:solidFill>
-                  <a:srgbClr val="000000"/>
-                </a:solidFill>
-              </a:rPr>
-              <a:t xml:space="preserve"> нужно для сравнимости между выборками</a:t>
+              <a:t xml:space="preserve"> минимизировать то же самое; деление нужно для сравнимости между выборками</a:t>
             </a:r>
           </a:p>
           <a:p>
@@ -8493,6 +8467,29 @@
               <a:t>) устойчивее к выбросам, но не гладкая в нуле</a:t>
             </a:r>
           </a:p>
+        </p:txBody>
+      </p:sp>
+      <p:sp>
+        <p:nvSpPr>
+          <p:cNvPr id="4" name="TextBox 3"/>
+          <p:cNvSpPr txBox="1"/>
+          <p:nvPr/>
+        </p:nvSpPr>
+        <p:spPr>
+          <a:xfrm>
+            <a:off x="3886200" y="1371600"/>
+            <a:ext cx="3108960" cy="1645920"/>
+          </a:xfrm>
+          <a:prstGeom prst="rect">
+            <a:avLst/>
+          </a:prstGeom>
+          <a:noFill/>
+        </p:spPr>
+        <p:txBody>
+          <a:bodyPr wrap="square">
+            <a:spAutoFit/>
+          </a:bodyPr>
+          <a:lstStyle/>
           <a:p>
             <a:pPr>
               <a:spcAft>
@@ -8520,14 +8517,14 @@
                   <a:srgbClr val="000000"/>
                 </a:solidFill>
               </a:rPr>
-              <a:t>MSE = MLE при нормальных остатках; MAE = MLE, если ошибки распределены по Лапласу (редкие, но крупные сбои — например, катастрофические задержки доставки)</a:t>
+              <a:t>MSE = MLE при гауссовских остатках; MAE = MLE при распределении Лапласа (например, медианный шум в задачах с редкими сбоями)</a:t>
             </a:r>
           </a:p>
         </p:txBody>
       </p:sp>
       <p:pic>
         <p:nvPicPr>
-          <p:cNvPr id="4" name="Picture 3" descr="mse_vs_mae_loss.png"/>
+          <p:cNvPr id="5" name="Picture 4" descr="mse_vs_mae_loss.png"/>
           <p:cNvPicPr>
             <a:picLocks noChangeAspect="1"/>
           </p:cNvPicPr>
@@ -8541,7 +8538,7 @@
         </p:blipFill>
         <p:spPr>
           <a:xfrm>
-            <a:off x="7269480" y="1791148"/>
+            <a:off x="7269480" y="1754572"/>
             <a:ext cx="5029200" cy="3550024"/>
           </a:xfrm>
           <a:prstGeom prst="rect">
@@ -8609,7 +8606,7 @@
         <p:spPr>
           <a:xfrm>
             <a:off x="640080" y="1371600"/>
-            <a:ext cx="6583680" cy="3383279"/>
+            <a:ext cx="3108960" cy="1316736"/>
           </a:xfrm>
           <a:prstGeom prst="rect">
             <a:avLst/>
@@ -8633,7 +8630,7 @@
                   <a:srgbClr val="000000"/>
                 </a:solidFill>
               </a:rPr>
-              <a:t xml:space="preserve">Аналитическое решение (МНК): </a:t>
+              <a:t xml:space="preserve">Аналитическое решение (МНК): производная по весам → система линейных уравнений → </a:t>
             </a:r>
             <ns0:m xmlns:ns0="http://schemas.microsoft.com/office/drawing/2010/main">
               <m:oMath xmlns:m="http://schemas.openxmlformats.org/officeDocument/2006/math">
@@ -8694,14 +8691,6 @@
                 </m:r>
               </m:oMath>
             </ns0:m>
-            <a:r>
-              <a:rPr lang="ru-RU" dirty="0" sz="2000">
-                <a:solidFill>
-                  <a:srgbClr val="000000"/>
-                </a:solidFill>
-              </a:rPr>
-              <a:t xml:space="preserve"> — быстро для умеренных матриц</a:t>
-            </a:r>
           </a:p>
           <a:p>
             <a:pPr>
@@ -8715,7 +8704,7 @@
                   <a:srgbClr val="000000"/>
                 </a:solidFill>
               </a:rPr>
-              <a:t>`LinearRegression` в sklearn использует solver `linalg` без итераций</a:t>
+              <a:t>`LinearRegression` в sklearn по умолчанию решает так (solver `linalg`) — быстро и точно для умеренных матриц</a:t>
             </a:r>
           </a:p>
           <a:p>
@@ -8730,9 +8719,47 @@
                   <a:srgbClr val="000000"/>
                 </a:solidFill>
               </a:rPr>
-              <a:t>При огромных данных — итеративные методы: SGD, `SGDRegressor`</a:t>
-            </a:r>
-          </a:p>
+              <a:t xml:space="preserve">При очень больших </a:t>
+            </a:r>
+            <ns0:m xmlns:ns0="http://schemas.microsoft.com/office/drawing/2010/main">
+              <m:oMath xmlns:m="http://schemas.openxmlformats.org/officeDocument/2006/math">
+                <m:r>
+                  <m:t>X</m:t>
+                </m:r>
+              </m:oMath>
+            </ns0:m>
+            <a:r>
+              <a:rPr lang="ru-RU" dirty="0" sz="2000">
+                <a:solidFill>
+                  <a:srgbClr val="000000"/>
+                </a:solidFill>
+              </a:rPr>
+              <a:t xml:space="preserve"> или нехватке памяти — итеративные методы: SGD, `sag`, `lsqr`</a:t>
+            </a:r>
+          </a:p>
+        </p:txBody>
+      </p:sp>
+      <p:sp>
+        <p:nvSpPr>
+          <p:cNvPr id="4" name="TextBox 3"/>
+          <p:cNvSpPr txBox="1"/>
+          <p:nvPr/>
+        </p:nvSpPr>
+        <p:spPr>
+          <a:xfrm>
+            <a:off x="3886200" y="1371600"/>
+            <a:ext cx="3108960" cy="1316736"/>
+          </a:xfrm>
+          <a:prstGeom prst="rect">
+            <a:avLst/>
+          </a:prstGeom>
+          <a:noFill/>
+        </p:spPr>
+        <p:txBody>
+          <a:bodyPr wrap="square">
+            <a:normAutofit/>
+          </a:bodyPr>
+          <a:lstStyle/>
           <a:p>
             <a:pPr>
               <a:spcAft>
@@ -8745,21 +8772,36 @@
                   <a:srgbClr val="000000"/>
                 </a:solidFill>
               </a:rPr>
-              <a:t>Градиентный спуск: шаг против градиента функции потерь</a:t>
-            </a:r>
-          </a:p>
-        </p:txBody>
-      </p:sp>
-      <p:sp>
-        <p:nvSpPr>
-          <p:cNvPr id="4" name="Rectangle 3"/>
+              <a:t>Градиентный спуск: шаг против градиента функции потерь; `SGDRegressor` в sklearn</a:t>
+            </a:r>
+          </a:p>
+          <a:p>
+            <a:pPr>
+              <a:spcAft>
+                <a:spcPts val="800"/>
+              </a:spcAft>
+            </a:pPr>
+            <a:r>
+              <a:rPr lang="ru-RU" dirty="0" sz="2000">
+                <a:solidFill>
+                  <a:srgbClr val="000000"/>
+                </a:solidFill>
+              </a:rPr>
+              <a:t>На практике для линейной регрессии чаще используют не «чистый» SGD, а стабильные solver'ы (`lbfgs`, `sag` в Ridge/Lasso)</a:t>
+            </a:r>
+          </a:p>
+        </p:txBody>
+      </p:sp>
+      <p:sp>
+        <p:nvSpPr>
+          <p:cNvPr id="5" name="Rectangle 4"/>
           <p:cNvSpPr/>
           <p:nvPr/>
         </p:nvSpPr>
         <p:spPr>
           <a:xfrm>
-            <a:off x="640080" y="4864607"/>
-            <a:ext cx="6492240" cy="630936"/>
+            <a:off x="640080" y="4690872"/>
+            <a:ext cx="6492240" cy="804672"/>
           </a:xfrm>
           <a:prstGeom prst="rect">
             <a:avLst/>
@@ -8797,14 +8839,14 @@
       </p:sp>
       <p:sp>
         <p:nvSpPr>
-          <p:cNvPr id="5" name="TextBox 4"/>
+          <p:cNvPr id="6" name="TextBox 5"/>
           <p:cNvSpPr txBox="1"/>
           <p:nvPr/>
         </p:nvSpPr>
         <p:spPr>
           <a:xfrm>
-            <a:off x="713231" y="4901183"/>
-            <a:ext cx="6345936" cy="557784"/>
+            <a:off x="713231" y="4727448"/>
+            <a:ext cx="6345936" cy="731520"/>
           </a:xfrm>
           <a:prstGeom prst="rect">
             <a:avLst/>
@@ -8845,7 +8887,7 @@
                 </a:solidFill>
                 <a:latin typeface="Consolas"/>
               </a:rPr>
-              <a:t>model = LinearRegression().fit(X_train, y_train)</a:t>
+              <a:t>model = LinearRegression()  # solver='linalg' по умолчанию</a:t>
             </a:r>
           </a:p>
           <a:p>
@@ -8861,6 +8903,22 @@
                 </a:solidFill>
                 <a:latin typeface="Consolas"/>
               </a:rPr>
+              <a:t>model.fit(X_train, y_train)</a:t>
+            </a:r>
+          </a:p>
+          <a:p>
+            <a:pPr>
+              <a:spcAft>
+                <a:spcPts val="0"/>
+              </a:spcAft>
+            </a:pPr>
+            <a:r>
+              <a:rPr sz="1100">
+                <a:solidFill>
+                  <a:srgbClr val="000000"/>
+                </a:solidFill>
+                <a:latin typeface="Consolas"/>
+              </a:rPr>
               <a:t>y_pred = model.predict(X_test)</a:t>
             </a:r>
           </a:p>
@@ -8868,13 +8926,13 @@
       </p:sp>
       <p:sp>
         <p:nvSpPr>
-          <p:cNvPr id="6" name="TextBox 5"/>
+          <p:cNvPr id="7" name="TextBox 6"/>
           <p:cNvSpPr txBox="1"/>
           <p:nvPr/>
         </p:nvSpPr>
         <p:spPr>
           <a:xfrm>
-            <a:off x="640080" y="5550407"/>
+            <a:off x="640080" y="5550408"/>
             <a:ext cx="6492240" cy="201168"/>
           </a:xfrm>
           <a:prstGeom prst="rect">
@@ -8903,7 +8961,7 @@
       </p:sp>
       <p:pic>
         <p:nvPicPr>
-          <p:cNvPr id="7" name="Picture 6" descr="gradient_descent_contour.png"/>
+          <p:cNvPr id="8" name="Picture 7" descr="gradient_descent_contour.png"/>
           <p:cNvPicPr>
             <a:picLocks noChangeAspect="1"/>
           </p:cNvPicPr>
@@ -8917,8 +8975,8 @@
         </p:blipFill>
         <p:spPr>
           <a:xfrm>
-            <a:off x="7269480" y="1774146"/>
-            <a:ext cx="5029200" cy="3584028"/>
+            <a:off x="7500144" y="1325880"/>
+            <a:ext cx="4567870" cy="3255264"/>
           </a:xfrm>
           <a:prstGeom prst="rect">
             <a:avLst/>
@@ -8985,7 +9043,7 @@
         <p:spPr>
           <a:xfrm>
             <a:off x="640080" y="1371600"/>
-            <a:ext cx="6583680" cy="1810512"/>
+            <a:ext cx="3108960" cy="1645920"/>
           </a:xfrm>
           <a:prstGeom prst="rect">
             <a:avLst/>
@@ -9151,6 +9209,29 @@
               </m:oMath>
             </ns0:m>
           </a:p>
+        </p:txBody>
+      </p:sp>
+      <p:sp>
+        <p:nvSpPr>
+          <p:cNvPr id="4" name="TextBox 3"/>
+          <p:cNvSpPr txBox="1"/>
+          <p:nvPr/>
+        </p:nvSpPr>
+        <p:spPr>
+          <a:xfrm>
+            <a:off x="3886200" y="1371600"/>
+            <a:ext cx="3108960" cy="1645920"/>
+          </a:xfrm>
+          <a:prstGeom prst="rect">
+            <a:avLst/>
+          </a:prstGeom>
+          <a:noFill/>
+        </p:spPr>
+        <p:txBody>
+          <a:bodyPr wrap="square">
+            <a:spAutoFit/>
+          </a:bodyPr>
+          <a:lstStyle/>
           <a:p>
             <a:pPr>
               <a:spcAft>
@@ -9200,7 +9281,7 @@
       </p:sp>
       <p:pic>
         <p:nvPicPr>
-          <p:cNvPr id="4" name="Picture 3" descr="hyperplane_3d.png"/>
+          <p:cNvPr id="5" name="Picture 4" descr="hyperplane_3d.png"/>
           <p:cNvPicPr>
             <a:picLocks noChangeAspect="1"/>
           </p:cNvPicPr>
@@ -9214,8 +9295,8 @@
         </p:blipFill>
         <p:spPr>
           <a:xfrm>
-            <a:off x="7632338" y="1325880"/>
-            <a:ext cx="4303483" cy="4480559"/>
+            <a:off x="7667468" y="1325880"/>
+            <a:ext cx="4233223" cy="4407408"/>
           </a:xfrm>
           <a:prstGeom prst="rect">
             <a:avLst/>
@@ -9282,7 +9363,7 @@
         <p:spPr>
           <a:xfrm>
             <a:off x="640080" y="1371600"/>
-            <a:ext cx="6583680" cy="2688335"/>
+            <a:ext cx="3108960" cy="969264"/>
           </a:xfrm>
           <a:prstGeom prst="rect">
             <a:avLst/>
@@ -9339,6 +9420,29 @@
               <a:t xml:space="preserve"> — для МНК качество прогноза на test часто не меняется</a:t>
             </a:r>
           </a:p>
+        </p:txBody>
+      </p:sp>
+      <p:sp>
+        <p:nvSpPr>
+          <p:cNvPr id="4" name="TextBox 3"/>
+          <p:cNvSpPr txBox="1"/>
+          <p:nvPr/>
+        </p:nvSpPr>
+        <p:spPr>
+          <a:xfrm>
+            <a:off x="3886200" y="1371600"/>
+            <a:ext cx="3108960" cy="969264"/>
+          </a:xfrm>
+          <a:prstGeom prst="rect">
+            <a:avLst/>
+          </a:prstGeom>
+          <a:noFill/>
+        </p:spPr>
+        <p:txBody>
+          <a:bodyPr wrap="square">
+            <a:normAutofit/>
+          </a:bodyPr>
+          <a:lstStyle/>
           <a:p>
             <a:pPr>
               <a:spcAft>
@@ -9405,7 +9509,7 @@
       </p:sp>
       <p:sp>
         <p:nvSpPr>
-          <p:cNvPr id="4" name="Rectangle 3"/>
+          <p:cNvPr id="5" name="Rectangle 4"/>
           <p:cNvSpPr/>
           <p:nvPr/>
         </p:nvSpPr>
@@ -9450,7 +9554,7 @@
       </p:sp>
       <p:sp>
         <p:nvSpPr>
-          <p:cNvPr id="5" name="TextBox 4"/>
+          <p:cNvPr id="6" name="TextBox 5"/>
           <p:cNvSpPr txBox="1"/>
           <p:nvPr/>
         </p:nvSpPr>
@@ -9585,7 +9689,7 @@
       </p:sp>
       <p:sp>
         <p:nvSpPr>
-          <p:cNvPr id="6" name="TextBox 5"/>
+          <p:cNvPr id="7" name="TextBox 6"/>
           <p:cNvSpPr txBox="1"/>
           <p:nvPr/>
         </p:nvSpPr>
@@ -9620,7 +9724,7 @@
       </p:sp>
       <p:pic>
         <p:nvPicPr>
-          <p:cNvPr id="7" name="Picture 6" descr="scaling_weights_compare.png"/>
+          <p:cNvPr id="8" name="Picture 7" descr="scaling_weights_compare.png"/>
           <p:cNvPicPr>
             <a:picLocks noChangeAspect="1"/>
           </p:cNvPicPr>
@@ -9634,8 +9738,8 @@
         </p:blipFill>
         <p:spPr>
           <a:xfrm>
-            <a:off x="5031801" y="3703320"/>
-            <a:ext cx="6304156" cy="2560320"/>
+            <a:off x="4145173" y="2450592"/>
+            <a:ext cx="3962612" cy="1609344"/>
           </a:xfrm>
           <a:prstGeom prst="rect">
             <a:avLst/>
@@ -9702,7 +9806,7 @@
         <p:spPr>
           <a:xfrm>
             <a:off x="640080" y="1371600"/>
-            <a:ext cx="6583680" cy="1810512"/>
+            <a:ext cx="3108960" cy="1645920"/>
           </a:xfrm>
           <a:prstGeom prst="rect">
             <a:avLst/>
@@ -9741,30 +9845,7 @@
                   <a:srgbClr val="000000"/>
                 </a:solidFill>
               </a:rPr>
-              <a:t>: при MSE сильно тянет линию — одна точка может заметно сдвинуть прямую</a:t>
-            </a:r>
-          </a:p>
-          <a:p>
-            <a:pPr>
-              <a:spcAft>
-                <a:spcPts val="800"/>
-              </a:spcAft>
-            </a:pPr>
-            <a:r>
-              <a:rPr lang="ru-RU" dirty="0" sz="2000" b="1">
-                <a:solidFill>
-                  <a:srgbClr val="000000"/>
-                </a:solidFill>
-              </a:rPr>
-              <a:t>Робастные</a:t>
-            </a:r>
-            <a:r>
-              <a:rPr lang="ru-RU" dirty="0" sz="2000">
-                <a:solidFill>
-                  <a:srgbClr val="000000"/>
-                </a:solidFill>
-              </a:rPr>
-              <a:t xml:space="preserve"> методы (MAE, `HuberRegressor`, RANSAC) меньше реагируют на выбросы, чем MSE</a:t>
+              <a:t>: при MSE сильно тянет линию — решение: MAE (`HuberRegressor`), робастные методы или чистка</a:t>
             </a:r>
           </a:p>
           <a:p>
@@ -9804,6 +9885,29 @@
               </m:oMath>
             </ns0:m>
           </a:p>
+        </p:txBody>
+      </p:sp>
+      <p:sp>
+        <p:nvSpPr>
+          <p:cNvPr id="4" name="TextBox 3"/>
+          <p:cNvSpPr txBox="1"/>
+          <p:nvPr/>
+        </p:nvSpPr>
+        <p:spPr>
+          <a:xfrm>
+            <a:off x="3886200" y="1371600"/>
+            <a:ext cx="3108960" cy="1645920"/>
+          </a:xfrm>
+          <a:prstGeom prst="rect">
+            <a:avLst/>
+          </a:prstGeom>
+          <a:noFill/>
+        </p:spPr>
+        <p:txBody>
+          <a:bodyPr wrap="square">
+            <a:spAutoFit/>
+          </a:bodyPr>
+          <a:lstStyle/>
           <a:p>
             <a:pPr>
               <a:spcAft>
@@ -9816,7 +9920,7 @@
                   <a:srgbClr val="000000"/>
                 </a:solidFill>
               </a:rPr>
-              <a:t xml:space="preserve">Перед обучением: scatter «признак vs </a:t>
+              <a:t xml:space="preserve">Всегда стройте scatter «признак vs </a:t>
             </a:r>
             <ns0:m xmlns:ns0="http://schemas.microsoft.com/office/drawing/2010/main">
               <m:oMath xmlns:m="http://schemas.openxmlformats.org/officeDocument/2006/math">
@@ -9831,14 +9935,29 @@
                   <a:srgbClr val="000000"/>
                 </a:solidFill>
               </a:rPr>
-              <a:t>» и boxplot остатков</a:t>
+              <a:t>» и boxplot остатков перед обучением</a:t>
+            </a:r>
+          </a:p>
+          <a:p>
+            <a:pPr>
+              <a:spcAft>
+                <a:spcPts val="800"/>
+              </a:spcAft>
+            </a:pPr>
+            <a:r>
+              <a:rPr lang="ru-RU" dirty="0" sz="2000">
+                <a:solidFill>
+                  <a:srgbClr val="000000"/>
+                </a:solidFill>
+              </a:rPr>
+              <a:t>Влиятельные точки диагностируют через остатки и расстояние от центра признаков</a:t>
             </a:r>
           </a:p>
         </p:txBody>
       </p:sp>
       <p:pic>
         <p:nvPicPr>
-          <p:cNvPr id="4" name="Picture 3" descr="outlier_y_effect.png"/>
+          <p:cNvPr id="5" name="Picture 4" descr="outlier_y_effect.png"/>
           <p:cNvPicPr>
             <a:picLocks noChangeAspect="1"/>
           </p:cNvPicPr>
@@ -9852,8 +9971,8 @@
         </p:blipFill>
         <p:spPr>
           <a:xfrm>
-            <a:off x="7269480" y="1589656"/>
-            <a:ext cx="2487168" cy="1685294"/>
+            <a:off x="8151212" y="1325880"/>
+            <a:ext cx="3265735" cy="2212848"/>
           </a:xfrm>
           <a:prstGeom prst="rect">
             <a:avLst/>
@@ -9862,7 +9981,7 @@
       </p:pic>
       <p:pic>
         <p:nvPicPr>
-          <p:cNvPr id="5" name="Picture 4" descr="outlier_leverage_x.png"/>
+          <p:cNvPr id="6" name="Picture 5" descr="outlier_leverage_x.png"/>
           <p:cNvPicPr>
             <a:picLocks noChangeAspect="1"/>
           </p:cNvPicPr>
@@ -9870,30 +9989,6 @@
         </p:nvPicPr>
         <p:blipFill>
           <a:blip r:embed="rId3"/>
-          <a:stretch>
-            <a:fillRect/>
-          </a:stretch>
-        </p:blipFill>
-        <p:spPr>
-          <a:xfrm>
-            <a:off x="9811512" y="1927244"/>
-            <a:ext cx="2487168" cy="1010119"/>
-          </a:xfrm>
-          <a:prstGeom prst="rect">
-            <a:avLst/>
-          </a:prstGeom>
-        </p:spPr>
-      </p:pic>
-      <p:pic>
-        <p:nvPicPr>
-          <p:cNvPr id="6" name="Picture 5" descr="outlier_scatter_boxplot.png"/>
-          <p:cNvPicPr>
-            <a:picLocks noChangeAspect="1"/>
-          </p:cNvPicPr>
-          <p:nvPr/>
-        </p:nvPicPr>
-        <p:blipFill>
-          <a:blip r:embed="rId4"/>
           <a:stretch>
             <a:fillRect/>
           </a:stretch>
@@ -9968,7 +10063,7 @@
         <p:spPr>
           <a:xfrm>
             <a:off x="640080" y="1371600"/>
-            <a:ext cx="6583680" cy="1810512"/>
+            <a:ext cx="3108960" cy="969264"/>
           </a:xfrm>
           <a:prstGeom prst="rect">
             <a:avLst/>
@@ -10034,6 +10129,29 @@
               <a:t xml:space="preserve"> нестабильны — большие, меняют знак</a:t>
             </a:r>
           </a:p>
+        </p:txBody>
+      </p:sp>
+      <p:sp>
+        <p:nvSpPr>
+          <p:cNvPr id="4" name="TextBox 3"/>
+          <p:cNvSpPr txBox="1"/>
+          <p:nvPr/>
+        </p:nvSpPr>
+        <p:spPr>
+          <a:xfrm>
+            <a:off x="3886200" y="1371600"/>
+            <a:ext cx="3108960" cy="969264"/>
+          </a:xfrm>
+          <a:prstGeom prst="rect">
+            <a:avLst/>
+          </a:prstGeom>
+          <a:noFill/>
+        </p:spPr>
+        <p:txBody>
+          <a:bodyPr wrap="square">
+            <a:spAutoFit/>
+          </a:bodyPr>
+          <a:lstStyle/>
           <a:p>
             <a:pPr>
               <a:spcAft>
@@ -10068,7 +10186,7 @@
       </p:sp>
       <p:pic>
         <p:nvPicPr>
-          <p:cNvPr id="4" name="Picture 3" descr="multicollinearity.png"/>
+          <p:cNvPr id="5" name="Picture 4" descr="multicollinearity.png"/>
           <p:cNvPicPr>
             <a:picLocks noChangeAspect="1"/>
           </p:cNvPicPr>
@@ -10082,8 +10200,8 @@
         </p:blipFill>
         <p:spPr>
           <a:xfrm>
-            <a:off x="5031801" y="3703320"/>
-            <a:ext cx="6304156" cy="2560320"/>
+            <a:off x="3368411" y="2450592"/>
+            <a:ext cx="5516136" cy="2240280"/>
           </a:xfrm>
           <a:prstGeom prst="rect">
             <a:avLst/>

</xml_diff>